<commit_message>
Generalize bilingual slide skill and add datasets in 10 minutes decks
</commit_message>
<xml_diff>
--- a/.agents/skills/master-guided-slides/SlideMaster.pptx
+++ b/.agents/skills/master-guided-slides/SlideMaster.pptx
@@ -4,9 +4,6 @@
   <p:sldMasterIdLst>
     <p:sldMasterId id="2147483662" r:id="rId1"/>
   </p:sldMasterIdLst>
-  <p:notesMasterIdLst>
-    <p:notesMasterId r:id="rId10"/>
-  </p:notesMasterIdLst>
   <p:sldIdLst>
     <p:sldId id="501" r:id="rId2"/>
     <p:sldId id="509" r:id="rId3"/>
@@ -272,454 +269,6 @@
 </p:presentation>
 </file>
 
-<file path=ppt/notesMasters/notesMaster1.xml><?xml version="1.0" encoding="utf-8"?>
-<p:notesMaster xmlns:a="http://schemas.openxmlformats.org/drawingml/2006/main" xmlns:r="http://schemas.openxmlformats.org/officeDocument/2006/relationships" xmlns:p="http://schemas.openxmlformats.org/presentationml/2006/main">
-  <p:cSld>
-    <p:bg>
-      <p:bgRef idx="1001">
-        <a:schemeClr val="bg1"/>
-      </p:bgRef>
-    </p:bg>
-    <p:spTree>
-      <p:nvGrpSpPr>
-        <p:cNvPr id="1" name="Shape 2"/>
-        <p:cNvGrpSpPr/>
-        <p:nvPr/>
-      </p:nvGrpSpPr>
-      <p:grpSpPr>
-        <a:xfrm>
-          <a:off x="0" y="0"/>
-          <a:ext cx="0" cy="0"/>
-          <a:chOff x="0" y="0"/>
-          <a:chExt cx="0" cy="0"/>
-        </a:xfrm>
-      </p:grpSpPr>
-      <p:sp>
-        <p:nvSpPr>
-          <p:cNvPr id="3" name="Google Shape;3;n"/>
-          <p:cNvSpPr>
-            <a:spLocks noGrp="1" noRot="1" noChangeAspect="1"/>
-          </p:cNvSpPr>
-          <p:nvPr>
-            <p:ph type="sldImg" idx="2"/>
-          </p:nvPr>
-        </p:nvSpPr>
-        <p:spPr>
-          <a:xfrm>
-            <a:off x="381300" y="685800"/>
-            <a:ext cx="6096075" cy="3429000"/>
-          </a:xfrm>
-          <a:custGeom>
-            <a:avLst/>
-            <a:gdLst/>
-            <a:ahLst/>
-            <a:cxnLst/>
-            <a:rect l="l" t="t" r="r" b="b"/>
-            <a:pathLst>
-              <a:path w="120000" h="120000" extrusionOk="0">
-                <a:moveTo>
-                  <a:pt x="0" y="0"/>
-                </a:moveTo>
-                <a:lnTo>
-                  <a:pt x="120000" y="0"/>
-                </a:lnTo>
-                <a:lnTo>
-                  <a:pt x="120000" y="120000"/>
-                </a:lnTo>
-                <a:lnTo>
-                  <a:pt x="0" y="120000"/>
-                </a:lnTo>
-                <a:close/>
-              </a:path>
-            </a:pathLst>
-          </a:custGeom>
-          <a:noFill/>
-          <a:ln w="9525" cap="flat" cmpd="sng">
-            <a:solidFill>
-              <a:srgbClr val="000000"/>
-            </a:solidFill>
-            <a:prstDash val="solid"/>
-            <a:round/>
-            <a:headEnd type="none" w="sm" len="sm"/>
-            <a:tailEnd type="none" w="sm" len="sm"/>
-          </a:ln>
-        </p:spPr>
-        <p:txBody>
-          <a:bodyPr/>
-          <a:lstStyle/>
-          <a:p>
-            <a:endParaRPr lang="ja-JP" altLang="en-US"/>
-          </a:p>
-        </p:txBody>
-      </p:sp>
-      <p:sp>
-        <p:nvSpPr>
-          <p:cNvPr id="4" name="Google Shape;4;n"/>
-          <p:cNvSpPr txBox="1">
-            <a:spLocks noGrp="1"/>
-          </p:cNvSpPr>
-          <p:nvPr>
-            <p:ph type="body" idx="1"/>
-          </p:nvPr>
-        </p:nvSpPr>
-        <p:spPr>
-          <a:xfrm>
-            <a:off x="685800" y="4343400"/>
-            <a:ext cx="5486400" cy="4114800"/>
-          </a:xfrm>
-          <a:prstGeom prst="rect">
-            <a:avLst/>
-          </a:prstGeom>
-          <a:noFill/>
-          <a:ln>
-            <a:noFill/>
-          </a:ln>
-        </p:spPr>
-        <p:txBody>
-          <a:bodyPr spcFirstLastPara="1" wrap="square" lIns="91425" tIns="91425" rIns="91425" bIns="91425" anchor="t" anchorCtr="0">
-            <a:noAutofit/>
-          </a:bodyPr>
-          <a:lstStyle>
-            <a:lvl1pPr marL="457200" lvl="0" indent="-298450">
-              <a:spcBef>
-                <a:spcPts val="0"/>
-              </a:spcBef>
-              <a:spcAft>
-                <a:spcPts val="0"/>
-              </a:spcAft>
-              <a:buSzPts val="1100"/>
-              <a:buChar char="●"/>
-              <a:defRPr sz="1100"/>
-            </a:lvl1pPr>
-            <a:lvl2pPr marL="914400" lvl="1" indent="-298450">
-              <a:spcBef>
-                <a:spcPts val="0"/>
-              </a:spcBef>
-              <a:spcAft>
-                <a:spcPts val="0"/>
-              </a:spcAft>
-              <a:buSzPts val="1100"/>
-              <a:buChar char="○"/>
-              <a:defRPr sz="1100"/>
-            </a:lvl2pPr>
-            <a:lvl3pPr marL="1371600" lvl="2" indent="-298450">
-              <a:spcBef>
-                <a:spcPts val="0"/>
-              </a:spcBef>
-              <a:spcAft>
-                <a:spcPts val="0"/>
-              </a:spcAft>
-              <a:buSzPts val="1100"/>
-              <a:buChar char="■"/>
-              <a:defRPr sz="1100"/>
-            </a:lvl3pPr>
-            <a:lvl4pPr marL="1828800" lvl="3" indent="-298450">
-              <a:spcBef>
-                <a:spcPts val="0"/>
-              </a:spcBef>
-              <a:spcAft>
-                <a:spcPts val="0"/>
-              </a:spcAft>
-              <a:buSzPts val="1100"/>
-              <a:buChar char="●"/>
-              <a:defRPr sz="1100"/>
-            </a:lvl4pPr>
-            <a:lvl5pPr marL="2286000" lvl="4" indent="-298450">
-              <a:spcBef>
-                <a:spcPts val="0"/>
-              </a:spcBef>
-              <a:spcAft>
-                <a:spcPts val="0"/>
-              </a:spcAft>
-              <a:buSzPts val="1100"/>
-              <a:buChar char="○"/>
-              <a:defRPr sz="1100"/>
-            </a:lvl5pPr>
-            <a:lvl6pPr marL="2743200" lvl="5" indent="-298450">
-              <a:spcBef>
-                <a:spcPts val="0"/>
-              </a:spcBef>
-              <a:spcAft>
-                <a:spcPts val="0"/>
-              </a:spcAft>
-              <a:buSzPts val="1100"/>
-              <a:buChar char="■"/>
-              <a:defRPr sz="1100"/>
-            </a:lvl6pPr>
-            <a:lvl7pPr marL="3200400" lvl="6" indent="-298450">
-              <a:spcBef>
-                <a:spcPts val="0"/>
-              </a:spcBef>
-              <a:spcAft>
-                <a:spcPts val="0"/>
-              </a:spcAft>
-              <a:buSzPts val="1100"/>
-              <a:buChar char="●"/>
-              <a:defRPr sz="1100"/>
-            </a:lvl7pPr>
-            <a:lvl8pPr marL="3657600" lvl="7" indent="-298450">
-              <a:spcBef>
-                <a:spcPts val="0"/>
-              </a:spcBef>
-              <a:spcAft>
-                <a:spcPts val="0"/>
-              </a:spcAft>
-              <a:buSzPts val="1100"/>
-              <a:buChar char="○"/>
-              <a:defRPr sz="1100"/>
-            </a:lvl8pPr>
-            <a:lvl9pPr marL="4114800" lvl="8" indent="-298450">
-              <a:spcBef>
-                <a:spcPts val="0"/>
-              </a:spcBef>
-              <a:spcAft>
-                <a:spcPts val="0"/>
-              </a:spcAft>
-              <a:buSzPts val="1100"/>
-              <a:buChar char="■"/>
-              <a:defRPr sz="1100"/>
-            </a:lvl9pPr>
-          </a:lstStyle>
-          <a:p>
-            <a:endParaRPr/>
-          </a:p>
-        </p:txBody>
-      </p:sp>
-    </p:spTree>
-  </p:cSld>
-  <p:clrMap bg1="lt1" tx1="dk1" bg2="dk2" tx2="lt2" accent1="accent1" accent2="accent2" accent3="accent3" accent4="accent4" accent5="accent5" accent6="accent6" hlink="hlink" folHlink="folHlink"/>
-  <p:notesStyle>
-    <a:defPPr marR="0" lvl="0" algn="l" rtl="0">
-      <a:lnSpc>
-        <a:spcPct val="100000"/>
-      </a:lnSpc>
-      <a:spcBef>
-        <a:spcPts val="0"/>
-      </a:spcBef>
-      <a:spcAft>
-        <a:spcPts val="0"/>
-      </a:spcAft>
-    </a:defPPr>
-    <a:lvl1pPr marR="0" lvl="0" algn="l" rtl="0">
-      <a:lnSpc>
-        <a:spcPct val="100000"/>
-      </a:lnSpc>
-      <a:spcBef>
-        <a:spcPts val="0"/>
-      </a:spcBef>
-      <a:spcAft>
-        <a:spcPts val="0"/>
-      </a:spcAft>
-      <a:buClr>
-        <a:srgbClr val="000000"/>
-      </a:buClr>
-      <a:buFont typeface="Arial"/>
-      <a:defRPr sz="1400" b="0" i="0" u="none" strike="noStrike" cap="none">
-        <a:solidFill>
-          <a:srgbClr val="000000"/>
-        </a:solidFill>
-        <a:latin typeface="Arial"/>
-        <a:ea typeface="Arial"/>
-        <a:cs typeface="Arial"/>
-        <a:sym typeface="Arial"/>
-      </a:defRPr>
-    </a:lvl1pPr>
-    <a:lvl2pPr marR="0" lvl="1" algn="l" rtl="0">
-      <a:lnSpc>
-        <a:spcPct val="100000"/>
-      </a:lnSpc>
-      <a:spcBef>
-        <a:spcPts val="0"/>
-      </a:spcBef>
-      <a:spcAft>
-        <a:spcPts val="0"/>
-      </a:spcAft>
-      <a:buClr>
-        <a:srgbClr val="000000"/>
-      </a:buClr>
-      <a:buFont typeface="Arial"/>
-      <a:defRPr sz="1400" b="0" i="0" u="none" strike="noStrike" cap="none">
-        <a:solidFill>
-          <a:srgbClr val="000000"/>
-        </a:solidFill>
-        <a:latin typeface="Arial"/>
-        <a:ea typeface="Arial"/>
-        <a:cs typeface="Arial"/>
-        <a:sym typeface="Arial"/>
-      </a:defRPr>
-    </a:lvl2pPr>
-    <a:lvl3pPr marR="0" lvl="2" algn="l" rtl="0">
-      <a:lnSpc>
-        <a:spcPct val="100000"/>
-      </a:lnSpc>
-      <a:spcBef>
-        <a:spcPts val="0"/>
-      </a:spcBef>
-      <a:spcAft>
-        <a:spcPts val="0"/>
-      </a:spcAft>
-      <a:buClr>
-        <a:srgbClr val="000000"/>
-      </a:buClr>
-      <a:buFont typeface="Arial"/>
-      <a:defRPr sz="1400" b="0" i="0" u="none" strike="noStrike" cap="none">
-        <a:solidFill>
-          <a:srgbClr val="000000"/>
-        </a:solidFill>
-        <a:latin typeface="Arial"/>
-        <a:ea typeface="Arial"/>
-        <a:cs typeface="Arial"/>
-        <a:sym typeface="Arial"/>
-      </a:defRPr>
-    </a:lvl3pPr>
-    <a:lvl4pPr marR="0" lvl="3" algn="l" rtl="0">
-      <a:lnSpc>
-        <a:spcPct val="100000"/>
-      </a:lnSpc>
-      <a:spcBef>
-        <a:spcPts val="0"/>
-      </a:spcBef>
-      <a:spcAft>
-        <a:spcPts val="0"/>
-      </a:spcAft>
-      <a:buClr>
-        <a:srgbClr val="000000"/>
-      </a:buClr>
-      <a:buFont typeface="Arial"/>
-      <a:defRPr sz="1400" b="0" i="0" u="none" strike="noStrike" cap="none">
-        <a:solidFill>
-          <a:srgbClr val="000000"/>
-        </a:solidFill>
-        <a:latin typeface="Arial"/>
-        <a:ea typeface="Arial"/>
-        <a:cs typeface="Arial"/>
-        <a:sym typeface="Arial"/>
-      </a:defRPr>
-    </a:lvl4pPr>
-    <a:lvl5pPr marR="0" lvl="4" algn="l" rtl="0">
-      <a:lnSpc>
-        <a:spcPct val="100000"/>
-      </a:lnSpc>
-      <a:spcBef>
-        <a:spcPts val="0"/>
-      </a:spcBef>
-      <a:spcAft>
-        <a:spcPts val="0"/>
-      </a:spcAft>
-      <a:buClr>
-        <a:srgbClr val="000000"/>
-      </a:buClr>
-      <a:buFont typeface="Arial"/>
-      <a:defRPr sz="1400" b="0" i="0" u="none" strike="noStrike" cap="none">
-        <a:solidFill>
-          <a:srgbClr val="000000"/>
-        </a:solidFill>
-        <a:latin typeface="Arial"/>
-        <a:ea typeface="Arial"/>
-        <a:cs typeface="Arial"/>
-        <a:sym typeface="Arial"/>
-      </a:defRPr>
-    </a:lvl5pPr>
-    <a:lvl6pPr marR="0" lvl="5" algn="l" rtl="0">
-      <a:lnSpc>
-        <a:spcPct val="100000"/>
-      </a:lnSpc>
-      <a:spcBef>
-        <a:spcPts val="0"/>
-      </a:spcBef>
-      <a:spcAft>
-        <a:spcPts val="0"/>
-      </a:spcAft>
-      <a:buClr>
-        <a:srgbClr val="000000"/>
-      </a:buClr>
-      <a:buFont typeface="Arial"/>
-      <a:defRPr sz="1400" b="0" i="0" u="none" strike="noStrike" cap="none">
-        <a:solidFill>
-          <a:srgbClr val="000000"/>
-        </a:solidFill>
-        <a:latin typeface="Arial"/>
-        <a:ea typeface="Arial"/>
-        <a:cs typeface="Arial"/>
-        <a:sym typeface="Arial"/>
-      </a:defRPr>
-    </a:lvl6pPr>
-    <a:lvl7pPr marR="0" lvl="6" algn="l" rtl="0">
-      <a:lnSpc>
-        <a:spcPct val="100000"/>
-      </a:lnSpc>
-      <a:spcBef>
-        <a:spcPts val="0"/>
-      </a:spcBef>
-      <a:spcAft>
-        <a:spcPts val="0"/>
-      </a:spcAft>
-      <a:buClr>
-        <a:srgbClr val="000000"/>
-      </a:buClr>
-      <a:buFont typeface="Arial"/>
-      <a:defRPr sz="1400" b="0" i="0" u="none" strike="noStrike" cap="none">
-        <a:solidFill>
-          <a:srgbClr val="000000"/>
-        </a:solidFill>
-        <a:latin typeface="Arial"/>
-        <a:ea typeface="Arial"/>
-        <a:cs typeface="Arial"/>
-        <a:sym typeface="Arial"/>
-      </a:defRPr>
-    </a:lvl7pPr>
-    <a:lvl8pPr marR="0" lvl="7" algn="l" rtl="0">
-      <a:lnSpc>
-        <a:spcPct val="100000"/>
-      </a:lnSpc>
-      <a:spcBef>
-        <a:spcPts val="0"/>
-      </a:spcBef>
-      <a:spcAft>
-        <a:spcPts val="0"/>
-      </a:spcAft>
-      <a:buClr>
-        <a:srgbClr val="000000"/>
-      </a:buClr>
-      <a:buFont typeface="Arial"/>
-      <a:defRPr sz="1400" b="0" i="0" u="none" strike="noStrike" cap="none">
-        <a:solidFill>
-          <a:srgbClr val="000000"/>
-        </a:solidFill>
-        <a:latin typeface="Arial"/>
-        <a:ea typeface="Arial"/>
-        <a:cs typeface="Arial"/>
-        <a:sym typeface="Arial"/>
-      </a:defRPr>
-    </a:lvl8pPr>
-    <a:lvl9pPr marR="0" lvl="8" algn="l" rtl="0">
-      <a:lnSpc>
-        <a:spcPct val="100000"/>
-      </a:lnSpc>
-      <a:spcBef>
-        <a:spcPts val="0"/>
-      </a:spcBef>
-      <a:spcAft>
-        <a:spcPts val="0"/>
-      </a:spcAft>
-      <a:buClr>
-        <a:srgbClr val="000000"/>
-      </a:buClr>
-      <a:buFont typeface="Arial"/>
-      <a:defRPr sz="1400" b="0" i="0" u="none" strike="noStrike" cap="none">
-        <a:solidFill>
-          <a:srgbClr val="000000"/>
-        </a:solidFill>
-        <a:latin typeface="Arial"/>
-        <a:ea typeface="Arial"/>
-        <a:cs typeface="Arial"/>
-        <a:sym typeface="Arial"/>
-      </a:defRPr>
-    </a:lvl9pPr>
-  </p:notesStyle>
-</p:notesMaster>
-</file>
-
 <file path=ppt/slideLayouts/slideLayout1.xml><?xml version="1.0" encoding="utf-8"?>
 <p:sldLayout xmlns:a="http://schemas.openxmlformats.org/drawingml/2006/main" xmlns:r="http://schemas.openxmlformats.org/officeDocument/2006/relationships" xmlns:p="http://schemas.openxmlformats.org/presentationml/2006/main" matchingName="Title slide" type="title">
   <p:cSld name="TITLE">
@@ -1504,8 +1053,8 @@
         </p:nvSpPr>
         <p:spPr>
           <a:xfrm>
-            <a:off x="5486400" y="4773168"/>
-            <a:ext cx="3108960" cy="228600"/>
+            <a:off x="457200" y="274320"/>
+            <a:ext cx="3657600" cy="228600"/>
           </a:xfrm>
           <a:prstGeom prst="rect">
             <a:avLst/>
@@ -2365,7 +1914,7 @@
           </a:prstGeom>
         </p:spPr>
         <p:txBody>
-          <a:bodyPr spcFirstLastPara="1" wrap="square" lIns="91425" tIns="91425" rIns="91425" bIns="91425" anchor="t" anchorCtr="0">
+          <a:bodyPr spcFirstLastPara="1" wrap="none" lIns="91425" tIns="91425" rIns="91425" bIns="91425" anchor="t" anchorCtr="0">
             <a:normAutofit/>
           </a:bodyPr>
           <a:lstStyle>
@@ -2947,7 +2496,7 @@
           </a:prstGeom>
         </p:spPr>
         <p:txBody>
-          <a:bodyPr spcFirstLastPara="1" wrap="square" lIns="91425" tIns="91425" rIns="91425" bIns="91425" anchor="t" anchorCtr="0">
+          <a:bodyPr spcFirstLastPara="1" wrap="none" lIns="91425" tIns="91425" rIns="91425" bIns="91425" anchor="t" anchorCtr="0">
             <a:normAutofit/>
           </a:bodyPr>
           <a:lstStyle>
@@ -3337,7 +2886,7 @@
           </a:prstGeom>
         </p:spPr>
         <p:txBody>
-          <a:bodyPr spcFirstLastPara="1" wrap="square" lIns="91425" tIns="91425" rIns="91425" bIns="91425" anchor="t" anchorCtr="0">
+          <a:bodyPr spcFirstLastPara="1" wrap="none" lIns="91425" tIns="91425" rIns="91425" bIns="91425" anchor="t" anchorCtr="0">
             <a:normAutofit/>
           </a:bodyPr>
           <a:lstStyle>
@@ -6266,7 +5815,12 @@
             <p:ph type="body" idx="12"/>
           </p:nvPr>
         </p:nvSpPr>
-        <p:spPr/>
+        <p:spPr>
+          <a:xfrm>
+            <a:off x="457200" y="274320"/>
+            <a:ext cx="3657600" cy="228600"/>
+          </a:xfrm>
+        </p:spPr>
         <p:txBody>
           <a:bodyPr tIns="0" bIns="0" lIns="0" rIns="0" anchor="ctr"/>
           <a:lstStyle/>
@@ -6385,7 +5939,7 @@
         </p:nvSpPr>
         <p:spPr/>
         <p:txBody>
-          <a:bodyPr>
+          <a:bodyPr wrap="none">
             <a:normAutofit fontScale="90000"/>
           </a:bodyPr>
           <a:lstStyle/>
@@ -6498,7 +6052,7 @@
         </p:nvSpPr>
         <p:spPr/>
         <p:txBody>
-          <a:bodyPr>
+          <a:bodyPr wrap="none">
             <a:normAutofit fontScale="90000"/>
           </a:bodyPr>
           <a:lstStyle/>
@@ -6579,7 +6133,7 @@
         </p:nvSpPr>
         <p:spPr/>
         <p:txBody>
-          <a:bodyPr>
+          <a:bodyPr wrap="none">
             <a:normAutofit fontScale="90000"/>
           </a:bodyPr>
           <a:lstStyle/>
@@ -7100,287 +6654,6 @@
 </a:theme>
 </file>
 
-<file path=ppt/theme/theme2.xml><?xml version="1.0" encoding="utf-8"?>
-<a:theme xmlns:a="http://schemas.openxmlformats.org/drawingml/2006/main">
-  <a:themeElements>
-    <a:clrScheme name="Default">
-      <a:dk1>
-        <a:srgbClr val="000000"/>
-      </a:dk1>
-      <a:lt1>
-        <a:srgbClr val="FFFFFF"/>
-      </a:lt1>
-      <a:dk2>
-        <a:srgbClr val="158158"/>
-      </a:dk2>
-      <a:lt2>
-        <a:srgbClr val="F3F3F3"/>
-      </a:lt2>
-      <a:accent1>
-        <a:srgbClr val="058DC7"/>
-      </a:accent1>
-      <a:accent2>
-        <a:srgbClr val="50B432"/>
-      </a:accent2>
-      <a:accent3>
-        <a:srgbClr val="ED561B"/>
-      </a:accent3>
-      <a:accent4>
-        <a:srgbClr val="EDEF00"/>
-      </a:accent4>
-      <a:accent5>
-        <a:srgbClr val="24CBE5"/>
-      </a:accent5>
-      <a:accent6>
-        <a:srgbClr val="64E572"/>
-      </a:accent6>
-      <a:hlink>
-        <a:srgbClr val="2200CC"/>
-      </a:hlink>
-      <a:folHlink>
-        <a:srgbClr val="551A8B"/>
-      </a:folHlink>
-    </a:clrScheme>
-    <a:fontScheme name="Office">
-      <a:majorFont>
-        <a:latin typeface="Arial"/>
-        <a:ea typeface=""/>
-        <a:cs typeface=""/>
-        <a:font script="Jpan" typeface="ＭＳ Ｐゴシック"/>
-        <a:font script="Hang" typeface="맑은 고딕"/>
-        <a:font script="Hans" typeface="宋体"/>
-        <a:font script="Hant" typeface="新細明體"/>
-        <a:font script="Arab" typeface="Times New Roman"/>
-        <a:font script="Hebr" typeface="Times New Roman"/>
-        <a:font script="Thai" typeface="Angsana New"/>
-        <a:font script="Ethi" typeface="Nyala"/>
-        <a:font script="Beng" typeface="Vrinda"/>
-        <a:font script="Gujr" typeface="Shruti"/>
-        <a:font script="Khmr" typeface="MoolBoran"/>
-        <a:font script="Knda" typeface="Tunga"/>
-        <a:font script="Guru" typeface="Raavi"/>
-        <a:font script="Cans" typeface="Euphemia"/>
-        <a:font script="Cher" typeface="Plantagenet Cherokee"/>
-        <a:font script="Yiii" typeface="Microsoft Yi Baiti"/>
-        <a:font script="Tibt" typeface="Microsoft Himalaya"/>
-        <a:font script="Thaa" typeface="MV Boli"/>
-        <a:font script="Deva" typeface="Mangal"/>
-        <a:font script="Telu" typeface="Gautami"/>
-        <a:font script="Taml" typeface="Latha"/>
-        <a:font script="Syrc" typeface="Estrangelo Edessa"/>
-        <a:font script="Orya" typeface="Kalinga"/>
-        <a:font script="Mlym" typeface="Kartika"/>
-        <a:font script="Laoo" typeface="DokChampa"/>
-        <a:font script="Sinh" typeface="Iskoola Pota"/>
-        <a:font script="Mong" typeface="Mongolian Baiti"/>
-        <a:font script="Viet" typeface="Times New Roman"/>
-        <a:font script="Uigh" typeface="Microsoft Uighur"/>
-        <a:font script="Geor" typeface="Sylfaen"/>
-      </a:majorFont>
-      <a:minorFont>
-        <a:latin typeface="Arial"/>
-        <a:ea typeface=""/>
-        <a:cs typeface=""/>
-        <a:font script="Jpan" typeface="ＭＳ Ｐゴシック"/>
-        <a:font script="Hang" typeface="맑은 고딕"/>
-        <a:font script="Hans" typeface="宋体"/>
-        <a:font script="Hant" typeface="新細明體"/>
-        <a:font script="Arab" typeface="Arial"/>
-        <a:font script="Hebr" typeface="Arial"/>
-        <a:font script="Thai" typeface="Cordia New"/>
-        <a:font script="Ethi" typeface="Nyala"/>
-        <a:font script="Beng" typeface="Vrinda"/>
-        <a:font script="Gujr" typeface="Shruti"/>
-        <a:font script="Khmr" typeface="DaunPenh"/>
-        <a:font script="Knda" typeface="Tunga"/>
-        <a:font script="Guru" typeface="Raavi"/>
-        <a:font script="Cans" typeface="Euphemia"/>
-        <a:font script="Cher" typeface="Plantagenet Cherokee"/>
-        <a:font script="Yiii" typeface="Microsoft Yi Baiti"/>
-        <a:font script="Tibt" typeface="Microsoft Himalaya"/>
-        <a:font script="Thaa" typeface="MV Boli"/>
-        <a:font script="Deva" typeface="Mangal"/>
-        <a:font script="Telu" typeface="Gautami"/>
-        <a:font script="Taml" typeface="Latha"/>
-        <a:font script="Syrc" typeface="Estrangelo Edessa"/>
-        <a:font script="Orya" typeface="Kalinga"/>
-        <a:font script="Mlym" typeface="Kartika"/>
-        <a:font script="Laoo" typeface="DokChampa"/>
-        <a:font script="Sinh" typeface="Iskoola Pota"/>
-        <a:font script="Mong" typeface="Mongolian Baiti"/>
-        <a:font script="Viet" typeface="Arial"/>
-        <a:font script="Uigh" typeface="Microsoft Uighur"/>
-        <a:font script="Geor" typeface="Sylfaen"/>
-      </a:minorFont>
-    </a:fontScheme>
-    <a:fmtScheme name="Office">
-      <a:fillStyleLst>
-        <a:solidFill>
-          <a:schemeClr val="phClr"/>
-        </a:solidFill>
-        <a:gradFill rotWithShape="1">
-          <a:gsLst>
-            <a:gs pos="0">
-              <a:schemeClr val="phClr">
-                <a:tint val="50000"/>
-                <a:satMod val="300000"/>
-              </a:schemeClr>
-            </a:gs>
-            <a:gs pos="35000">
-              <a:schemeClr val="phClr">
-                <a:tint val="37000"/>
-                <a:satMod val="300000"/>
-              </a:schemeClr>
-            </a:gs>
-            <a:gs pos="100000">
-              <a:schemeClr val="phClr">
-                <a:tint val="15000"/>
-                <a:satMod val="350000"/>
-              </a:schemeClr>
-            </a:gs>
-          </a:gsLst>
-          <a:lin ang="16200000" scaled="1"/>
-        </a:gradFill>
-        <a:gradFill rotWithShape="1">
-          <a:gsLst>
-            <a:gs pos="0">
-              <a:schemeClr val="phClr">
-                <a:tint val="100000"/>
-                <a:shade val="100000"/>
-                <a:satMod val="130000"/>
-              </a:schemeClr>
-            </a:gs>
-            <a:gs pos="100000">
-              <a:schemeClr val="phClr">
-                <a:tint val="50000"/>
-                <a:shade val="100000"/>
-                <a:satMod val="350000"/>
-              </a:schemeClr>
-            </a:gs>
-          </a:gsLst>
-          <a:lin ang="16200000" scaled="0"/>
-        </a:gradFill>
-      </a:fillStyleLst>
-      <a:lnStyleLst>
-        <a:ln w="9525" cap="flat" cmpd="sng" algn="ctr">
-          <a:solidFill>
-            <a:schemeClr val="phClr">
-              <a:shade val="95000"/>
-              <a:satMod val="105000"/>
-            </a:schemeClr>
-          </a:solidFill>
-          <a:prstDash val="solid"/>
-        </a:ln>
-        <a:ln w="25400" cap="flat" cmpd="sng" algn="ctr">
-          <a:solidFill>
-            <a:schemeClr val="phClr"/>
-          </a:solidFill>
-          <a:prstDash val="solid"/>
-        </a:ln>
-        <a:ln w="38100" cap="flat" cmpd="sng" algn="ctr">
-          <a:solidFill>
-            <a:schemeClr val="phClr"/>
-          </a:solidFill>
-          <a:prstDash val="solid"/>
-        </a:ln>
-      </a:lnStyleLst>
-      <a:effectStyleLst>
-        <a:effectStyle>
-          <a:effectLst>
-            <a:outerShdw blurRad="40000" dist="20000" dir="5400000" rotWithShape="0">
-              <a:srgbClr val="000000">
-                <a:alpha val="38000"/>
-              </a:srgbClr>
-            </a:outerShdw>
-          </a:effectLst>
-        </a:effectStyle>
-        <a:effectStyle>
-          <a:effectLst>
-            <a:outerShdw blurRad="40000" dist="23000" dir="5400000" rotWithShape="0">
-              <a:srgbClr val="000000">
-                <a:alpha val="35000"/>
-              </a:srgbClr>
-            </a:outerShdw>
-          </a:effectLst>
-        </a:effectStyle>
-        <a:effectStyle>
-          <a:effectLst>
-            <a:outerShdw blurRad="40000" dist="23000" dir="5400000" rotWithShape="0">
-              <a:srgbClr val="000000">
-                <a:alpha val="35000"/>
-              </a:srgbClr>
-            </a:outerShdw>
-          </a:effectLst>
-          <a:scene3d>
-            <a:camera prst="orthographicFront">
-              <a:rot lat="0" lon="0" rev="0"/>
-            </a:camera>
-            <a:lightRig rig="threePt" dir="t">
-              <a:rot lat="0" lon="0" rev="1200000"/>
-            </a:lightRig>
-          </a:scene3d>
-          <a:sp3d>
-            <a:bevelT w="63500" h="25400"/>
-          </a:sp3d>
-        </a:effectStyle>
-      </a:effectStyleLst>
-      <a:bgFillStyleLst>
-        <a:solidFill>
-          <a:schemeClr val="phClr"/>
-        </a:solidFill>
-        <a:gradFill rotWithShape="1">
-          <a:gsLst>
-            <a:gs pos="0">
-              <a:schemeClr val="phClr">
-                <a:tint val="40000"/>
-                <a:satMod val="350000"/>
-              </a:schemeClr>
-            </a:gs>
-            <a:gs pos="40000">
-              <a:schemeClr val="phClr">
-                <a:tint val="45000"/>
-                <a:shade val="99000"/>
-                <a:satMod val="350000"/>
-              </a:schemeClr>
-            </a:gs>
-            <a:gs pos="100000">
-              <a:schemeClr val="phClr">
-                <a:shade val="20000"/>
-                <a:satMod val="255000"/>
-              </a:schemeClr>
-            </a:gs>
-          </a:gsLst>
-          <a:path path="circle">
-            <a:fillToRect l="50000" t="-80000" r="50000" b="180000"/>
-          </a:path>
-        </a:gradFill>
-        <a:gradFill rotWithShape="1">
-          <a:gsLst>
-            <a:gs pos="0">
-              <a:schemeClr val="phClr">
-                <a:tint val="80000"/>
-                <a:satMod val="300000"/>
-              </a:schemeClr>
-            </a:gs>
-            <a:gs pos="100000">
-              <a:schemeClr val="phClr">
-                <a:shade val="30000"/>
-                <a:satMod val="200000"/>
-              </a:schemeClr>
-            </a:gs>
-          </a:gsLst>
-          <a:path path="circle">
-            <a:fillToRect l="50000" t="50000" r="50000" b="50000"/>
-          </a:path>
-        </a:gradFill>
-      </a:bgFillStyleLst>
-    </a:fmtScheme>
-  </a:themeElements>
-  <a:objectDefaults/>
-  <a:extraClrSchemeLst/>
-</a:theme>
-</file>
-
 <file path=ppt/webextensions/taskpanes.xml><?xml version="1.0" encoding="utf-8"?>
 <wetp:taskpanes xmlns:wetp="http://schemas.microsoft.com/office/webextensions/taskpanes/2010/11">
   <wetp:taskpane dockstate="right" visibility="0" width="350" row="0">

</xml_diff>

<commit_message>
Refine slide hierarchy, citations and dataset visual layouts
</commit_message>
<xml_diff>
--- a/.agents/skills/master-guided-slides/SlideMaster.pptx
+++ b/.agents/skills/master-guided-slides/SlideMaster.pptx
@@ -16,6 +16,27 @@
   </p:sldIdLst>
   <p:sldSz cx="9144000" cy="5143500" type="screen16x9"/>
   <p:notesSz cx="6858000" cy="9144000"/>
+  <p:extLst>
+    <p:ext uri="{EFAFB233-063F-42B5-8137-9DF3F51BA10A}">
+      <p15:sldGuideLst xmlns:p15="http://schemas.microsoft.com/office/powerpoint/2012/main">
+        <p15:guide id="1" orient="horz" pos="590">
+          <p15:clr>
+            <a:srgbClr val="747775"/>
+          </p15:clr>
+        </p15:guide>
+        <p15:guide id="2" pos="1271">
+          <p15:clr>
+            <a:srgbClr val="747775"/>
+          </p15:clr>
+        </p15:guide>
+        <p15:guide id="3" orient="horz" pos="1584">
+          <p15:clr>
+            <a:srgbClr val="747775"/>
+          </p15:clr>
+        </p15:guide>
+      </p15:sldGuideLst>
+    </p:ext>
+  </p:extLst>
   <p:defaultTextStyle>
     <a:defPPr marR="0" lvl="0" algn="l" rtl="0">
       <a:lnSpc>
@@ -245,27 +266,6 @@
       </a:defRPr>
     </a:lvl9pPr>
   </p:defaultTextStyle>
-  <p:extLst>
-    <p:ext uri="{EFAFB233-063F-42B5-8137-9DF3F51BA10A}">
-      <p15:sldGuideLst xmlns:p15="http://schemas.microsoft.com/office/powerpoint/2012/main">
-        <p15:guide id="1" orient="horz" pos="590">
-          <p15:clr>
-            <a:srgbClr val="747775"/>
-          </p15:clr>
-        </p15:guide>
-        <p15:guide id="2" pos="1271">
-          <p15:clr>
-            <a:srgbClr val="747775"/>
-          </p15:clr>
-        </p15:guide>
-        <p15:guide id="3" orient="horz" pos="1584">
-          <p15:clr>
-            <a:srgbClr val="747775"/>
-          </p15:clr>
-        </p15:guide>
-      </p15:sldGuideLst>
-    </p:ext>
-  </p:extLst>
 </p:presentation>
 </file>
 
@@ -2054,7 +2054,7 @@
             <a:normAutofit/>
           </a:bodyPr>
           <a:lstStyle>
-            <a:lvl1pPr marL="457200" lvl="0" indent="-355600">
+            <a:lvl1pPr marL="203200" lvl="0" indent="-152400">
               <a:spcBef>
                 <a:spcPts val="0"/>
               </a:spcBef>
@@ -2065,14 +2065,14 @@
                 <a:schemeClr val="dk2"/>
               </a:buClr>
               <a:buSzPts val="2000"/>
-              <a:buChar char="●"/>
+              <a:buChar char="•"/>
               <a:defRPr sz="2000">
                 <a:solidFill>
                   <a:schemeClr val="dk2"/>
                 </a:solidFill>
               </a:defRPr>
             </a:lvl1pPr>
-            <a:lvl2pPr marL="914400" lvl="1" indent="-355600">
+            <a:lvl2pPr marL="482600" lvl="1" indent="-127000">
               <a:spcBef>
                 <a:spcPts val="0"/>
               </a:spcBef>
@@ -2090,7 +2090,7 @@
                 </a:solidFill>
               </a:defRPr>
             </a:lvl2pPr>
-            <a:lvl3pPr marL="1371600" lvl="2" indent="-355600">
+            <a:lvl3pPr marL="762000" lvl="2" indent="-127000">
               <a:spcBef>
                 <a:spcPts val="0"/>
               </a:spcBef>
@@ -2108,7 +2108,7 @@
                 </a:solidFill>
               </a:defRPr>
             </a:lvl3pPr>
-            <a:lvl4pPr marL="1828800" lvl="3" indent="-368300">
+            <a:lvl4pPr marL="1041400" lvl="3" indent="-127000">
               <a:spcBef>
                 <a:spcPts val="0"/>
               </a:spcBef>
@@ -2119,14 +2119,14 @@
                 <a:schemeClr val="dk2"/>
               </a:buClr>
               <a:buSzPts val="2200"/>
-              <a:buChar char="●"/>
+              <a:buChar char="•"/>
               <a:defRPr sz="2200">
                 <a:solidFill>
                   <a:schemeClr val="dk2"/>
                 </a:solidFill>
               </a:defRPr>
             </a:lvl4pPr>
-            <a:lvl5pPr marL="2286000" lvl="4" indent="-355600">
+            <a:lvl5pPr marL="1320800" lvl="4" indent="-127000">
               <a:spcBef>
                 <a:spcPts val="0"/>
               </a:spcBef>
@@ -2144,7 +2144,7 @@
                 </a:solidFill>
               </a:defRPr>
             </a:lvl5pPr>
-            <a:lvl6pPr marL="2743200" lvl="5" indent="-355600">
+            <a:lvl6pPr marL="1600200" lvl="5" indent="-127000">
               <a:spcBef>
                 <a:spcPts val="0"/>
               </a:spcBef>
@@ -2162,7 +2162,7 @@
                 </a:solidFill>
               </a:defRPr>
             </a:lvl6pPr>
-            <a:lvl7pPr marL="3200400" lvl="6" indent="-355600">
+            <a:lvl7pPr marL="1879600" lvl="6" indent="-127000">
               <a:spcBef>
                 <a:spcPts val="0"/>
               </a:spcBef>
@@ -2173,14 +2173,14 @@
                 <a:schemeClr val="dk2"/>
               </a:buClr>
               <a:buSzPts val="2000"/>
-              <a:buChar char="●"/>
+              <a:buChar char="•"/>
               <a:defRPr sz="2000">
                 <a:solidFill>
                   <a:schemeClr val="dk2"/>
                 </a:solidFill>
               </a:defRPr>
             </a:lvl7pPr>
-            <a:lvl8pPr marL="3657600" lvl="7" indent="-355600">
+            <a:lvl8pPr marL="2159000" lvl="7" indent="-127000">
               <a:spcBef>
                 <a:spcPts val="0"/>
               </a:spcBef>
@@ -2198,7 +2198,7 @@
                 </a:solidFill>
               </a:defRPr>
             </a:lvl8pPr>
-            <a:lvl9pPr marL="4114800" lvl="8" indent="-355600">
+            <a:lvl9pPr marL="2438400" lvl="8" indent="-127000">
               <a:spcBef>
                 <a:spcPts val="0"/>
               </a:spcBef>
@@ -3280,7 +3280,7 @@
             <a:normAutofit/>
           </a:bodyPr>
           <a:lstStyle>
-            <a:lvl1pPr marL="457200" lvl="0" indent="-355600" rtl="0">
+            <a:lvl1pPr marL="203200" lvl="0" indent="-152400" rtl="0">
               <a:spcBef>
                 <a:spcPts val="0"/>
               </a:spcBef>
@@ -3291,14 +3291,14 @@
                 <a:schemeClr val="dk2"/>
               </a:buClr>
               <a:buSzPts val="2000"/>
-              <a:buChar char="●"/>
+              <a:buChar char="•"/>
               <a:defRPr sz="2000">
                 <a:solidFill>
                   <a:schemeClr val="dk2"/>
                 </a:solidFill>
               </a:defRPr>
             </a:lvl1pPr>
-            <a:lvl2pPr marL="914400" lvl="1" indent="-355600" rtl="0">
+            <a:lvl2pPr marL="482600" lvl="1" indent="-127000" rtl="0">
               <a:spcBef>
                 <a:spcPts val="0"/>
               </a:spcBef>
@@ -3316,7 +3316,7 @@
                 </a:solidFill>
               </a:defRPr>
             </a:lvl2pPr>
-            <a:lvl3pPr marL="1371600" lvl="2" indent="-355600" rtl="0">
+            <a:lvl3pPr marL="762000" lvl="2" indent="-127000" rtl="0">
               <a:spcBef>
                 <a:spcPts val="0"/>
               </a:spcBef>
@@ -3334,7 +3334,7 @@
                 </a:solidFill>
               </a:defRPr>
             </a:lvl3pPr>
-            <a:lvl4pPr marL="1828800" lvl="3" indent="-368300" rtl="0">
+            <a:lvl4pPr marL="1041400" lvl="3" indent="-127000" rtl="0">
               <a:spcBef>
                 <a:spcPts val="0"/>
               </a:spcBef>
@@ -3345,14 +3345,14 @@
                 <a:schemeClr val="dk2"/>
               </a:buClr>
               <a:buSzPts val="2200"/>
-              <a:buChar char="●"/>
+              <a:buChar char="•"/>
               <a:defRPr sz="2200">
                 <a:solidFill>
                   <a:schemeClr val="dk2"/>
                 </a:solidFill>
               </a:defRPr>
             </a:lvl4pPr>
-            <a:lvl5pPr marL="2286000" lvl="4" indent="-355600" rtl="0">
+            <a:lvl5pPr marL="1320800" lvl="4" indent="-127000" rtl="0">
               <a:spcBef>
                 <a:spcPts val="0"/>
               </a:spcBef>
@@ -3370,7 +3370,7 @@
                 </a:solidFill>
               </a:defRPr>
             </a:lvl5pPr>
-            <a:lvl6pPr marL="2743200" lvl="5" indent="-355600" rtl="0">
+            <a:lvl6pPr marL="1600200" lvl="5" indent="-127000" rtl="0">
               <a:spcBef>
                 <a:spcPts val="0"/>
               </a:spcBef>
@@ -3388,7 +3388,7 @@
                 </a:solidFill>
               </a:defRPr>
             </a:lvl6pPr>
-            <a:lvl7pPr marL="3200400" lvl="6" indent="-355600" rtl="0">
+            <a:lvl7pPr marL="1879600" lvl="6" indent="-127000" rtl="0">
               <a:spcBef>
                 <a:spcPts val="0"/>
               </a:spcBef>
@@ -3399,14 +3399,14 @@
                 <a:schemeClr val="dk2"/>
               </a:buClr>
               <a:buSzPts val="2000"/>
-              <a:buChar char="●"/>
+              <a:buChar char="•"/>
               <a:defRPr sz="2000">
                 <a:solidFill>
                   <a:schemeClr val="dk2"/>
                 </a:solidFill>
               </a:defRPr>
             </a:lvl7pPr>
-            <a:lvl8pPr marL="3657600" lvl="7" indent="-355600" rtl="0">
+            <a:lvl8pPr marL="2159000" lvl="7" indent="-127000" rtl="0">
               <a:spcBef>
                 <a:spcPts val="0"/>
               </a:spcBef>
@@ -3424,7 +3424,7 @@
                 </a:solidFill>
               </a:defRPr>
             </a:lvl8pPr>
-            <a:lvl9pPr marL="4114800" lvl="8" indent="-355600" rtl="0">
+            <a:lvl9pPr marL="2438400" lvl="8" indent="-127000" rtl="0">
               <a:spcBef>
                 <a:spcPts val="0"/>
               </a:spcBef>
@@ -4640,7 +4640,7 @@
             <a:normAutofit/>
           </a:bodyPr>
           <a:lstStyle>
-            <a:lvl1pPr marL="457200" lvl="0" indent="-342900">
+            <a:lvl1pPr marL="203200" lvl="0" indent="-152400">
               <a:lnSpc>
                 <a:spcPct val="115000"/>
               </a:lnSpc>
@@ -4654,14 +4654,14 @@
                 <a:schemeClr val="dk2"/>
               </a:buClr>
               <a:buSzPts val="1800"/>
-              <a:buChar char="●"/>
+              <a:buChar char="•"/>
               <a:defRPr sz="1800">
                 <a:solidFill>
                   <a:schemeClr val="dk2"/>
                 </a:solidFill>
               </a:defRPr>
             </a:lvl1pPr>
-            <a:lvl2pPr marL="914400" lvl="1" indent="-317500">
+            <a:lvl2pPr marL="482600" lvl="1" indent="-127000">
               <a:lnSpc>
                 <a:spcPct val="115000"/>
               </a:lnSpc>
@@ -4682,7 +4682,7 @@
                 </a:solidFill>
               </a:defRPr>
             </a:lvl2pPr>
-            <a:lvl3pPr marL="1371600" lvl="2" indent="-317500">
+            <a:lvl3pPr marL="762000" lvl="2" indent="-127000">
               <a:lnSpc>
                 <a:spcPct val="115000"/>
               </a:lnSpc>
@@ -4703,7 +4703,7 @@
                 </a:solidFill>
               </a:defRPr>
             </a:lvl3pPr>
-            <a:lvl4pPr marL="1828800" lvl="3" indent="-317500">
+            <a:lvl4pPr marL="1041400" lvl="3" indent="-127000">
               <a:lnSpc>
                 <a:spcPct val="115000"/>
               </a:lnSpc>
@@ -4717,14 +4717,14 @@
                 <a:schemeClr val="dk2"/>
               </a:buClr>
               <a:buSzPts val="1400"/>
-              <a:buChar char="●"/>
+              <a:buChar char="•"/>
               <a:defRPr>
                 <a:solidFill>
                   <a:schemeClr val="dk2"/>
                 </a:solidFill>
               </a:defRPr>
             </a:lvl4pPr>
-            <a:lvl5pPr marL="2286000" lvl="4" indent="-317500">
+            <a:lvl5pPr marL="1320800" lvl="4" indent="-127000">
               <a:lnSpc>
                 <a:spcPct val="115000"/>
               </a:lnSpc>
@@ -4745,7 +4745,7 @@
                 </a:solidFill>
               </a:defRPr>
             </a:lvl5pPr>
-            <a:lvl6pPr marL="2743200" lvl="5" indent="-317500">
+            <a:lvl6pPr marL="1600200" lvl="5" indent="-127000">
               <a:lnSpc>
                 <a:spcPct val="115000"/>
               </a:lnSpc>
@@ -4766,7 +4766,7 @@
                 </a:solidFill>
               </a:defRPr>
             </a:lvl6pPr>
-            <a:lvl7pPr marL="3200400" lvl="6" indent="-317500">
+            <a:lvl7pPr marL="1879600" lvl="6" indent="-127000">
               <a:lnSpc>
                 <a:spcPct val="115000"/>
               </a:lnSpc>
@@ -4780,14 +4780,14 @@
                 <a:schemeClr val="dk2"/>
               </a:buClr>
               <a:buSzPts val="1400"/>
-              <a:buChar char="●"/>
+              <a:buChar char="•"/>
               <a:defRPr>
                 <a:solidFill>
                   <a:schemeClr val="dk2"/>
                 </a:solidFill>
               </a:defRPr>
             </a:lvl7pPr>
-            <a:lvl8pPr marL="3657600" lvl="7" indent="-317500">
+            <a:lvl8pPr marL="2159000" lvl="7" indent="-127000">
               <a:lnSpc>
                 <a:spcPct val="115000"/>
               </a:lnSpc>
@@ -4808,7 +4808,7 @@
                 </a:solidFill>
               </a:defRPr>
             </a:lvl8pPr>
-            <a:lvl9pPr marL="4114800" lvl="8" indent="-317500">
+            <a:lvl9pPr marL="2438400" lvl="8" indent="-127000">
               <a:lnSpc>
                 <a:spcPct val="115000"/>
               </a:lnSpc>
@@ -5695,8 +5695,13 @@
           </a:bodyPr>
           <a:lstStyle/>
           <a:p>
+            <a:pPr>
+              <a:defRPr/>
+            </a:pPr>
             <a:r>
-              <a:rPr lang="en-US" dirty="0"/>
+              <a:rPr lang="en-US" dirty="0">
+                <a:ea typeface="Noto Sans CJK JP"/>
+              </a:rPr>
               <a:t>Developing and Applying a Systematic Classification Framework</a:t>
             </a:r>
           </a:p>
@@ -5722,8 +5727,13 @@
           <a:bodyPr/>
           <a:lstStyle/>
           <a:p>
+            <a:pPr>
+              <a:defRPr/>
+            </a:pPr>
             <a:r>
-              <a:rPr lang="en-US" dirty="0"/>
+              <a:rPr lang="en-US" dirty="0">
+                <a:ea typeface="Noto Sans CJK JP"/>
+              </a:rPr>
               <a:t>Presenter Name, Co-author Name</a:t>
             </a:r>
           </a:p>
@@ -5762,6 +5772,9 @@
               </a:defRPr>
             </a:pPr>
             <a:r>
+              <a:rPr lang="ja-JP">
+                <a:ea typeface="Noto Sans CJK JP"/>
+              </a:rPr>
               <a:t>所属　［所属］</a:t>
             </a:r>
           </a:p>
@@ -5800,6 +5813,9 @@
               </a:defRPr>
             </a:pPr>
             <a:r>
+              <a:rPr lang="ja-JP">
+                <a:ea typeface="Noto Sans CJK JP"/>
+              </a:rPr>
               <a:t>氏名　［氏名］</a:t>
             </a:r>
           </a:p>
@@ -5843,6 +5859,9 @@
               </a:defRPr>
             </a:pPr>
             <a:r>
+              <a:rPr lang="ja-JP">
+                <a:ea typeface="Noto Sans CJK JP"/>
+              </a:rPr>
               <a:t>作成日　YYYY-MM-DD</a:t>
             </a:r>
           </a:p>
@@ -5898,6 +5917,7 @@
           <a:bodyPr wrap="square"/>
           <a:lstStyle/>
           <a:p>
+            <a:pPr/>
             <a:endParaRPr lang="en-US"/>
           </a:p>
         </p:txBody>
@@ -5944,6 +5964,7 @@
           </a:bodyPr>
           <a:lstStyle/>
           <a:p>
+            <a:pPr/>
             <a:endParaRPr lang="en-US" dirty="0">
               <a:solidFill>
                 <a:schemeClr val="dk1">
@@ -6057,6 +6078,7 @@
           </a:bodyPr>
           <a:lstStyle/>
           <a:p>
+            <a:pPr/>
             <a:endParaRPr lang="en-US" dirty="0"/>
           </a:p>
         </p:txBody>
@@ -6138,6 +6160,7 @@
           </a:bodyPr>
           <a:lstStyle/>
           <a:p>
+            <a:pPr/>
             <a:endParaRPr lang="en-US" dirty="0"/>
           </a:p>
         </p:txBody>
@@ -6217,6 +6240,7 @@
           <a:bodyPr/>
           <a:lstStyle/>
           <a:p>
+            <a:pPr/>
             <a:endParaRPr lang="en-US" dirty="0"/>
           </a:p>
         </p:txBody>
@@ -6358,8 +6382,13 @@
           </a:bodyPr>
           <a:lstStyle/>
           <a:p>
+            <a:pPr>
+              <a:defRPr/>
+            </a:pPr>
             <a:r>
-              <a:rPr lang="en-US"/>
+              <a:rPr lang="en-US">
+                <a:ea typeface="Noto Sans CJK JP"/>
+              </a:rPr>
               <a:t>Bottom-right caption</a:t>
             </a:r>
           </a:p>

</xml_diff>

<commit_message>
Show UCF101 temporal examples and explain data units and references
</commit_message>
<xml_diff>
--- a/.agents/skills/master-guided-slides/SlideMaster.pptx
+++ b/.agents/skills/master-guided-slides/SlideMaster.pptx
@@ -836,7 +836,7 @@
             </a:lvl9pPr>
           </a:lstStyle>
           <a:p>
-            <a:pPr algn="l">
+            <a:pPr algn="r">
               <a:lnSpc>
                 <a:spcPct val="100000"/>
               </a:lnSpc>
@@ -871,8 +871,8 @@
         </p:nvSpPr>
         <p:spPr>
           <a:xfrm>
-            <a:off x="5486400" y="4498848"/>
-            <a:ext cx="3108960" cy="228600"/>
+            <a:off x="5486400" y="4416552"/>
+            <a:ext cx="3108960" cy="402336"/>
           </a:xfrm>
           <a:prstGeom prst="rect">
             <a:avLst/>
@@ -1018,7 +1018,7 @@
             </a:lvl9pPr>
           </a:lstStyle>
           <a:p>
-            <a:pPr algn="l">
+            <a:pPr algn="r">
               <a:lnSpc>
                 <a:spcPct val="100000"/>
               </a:lnSpc>
@@ -1028,7 +1028,7 @@
               <a:spcAft>
                 <a:spcPts val="0"/>
               </a:spcAft>
-              <a:defRPr sz="1400" b="0">
+              <a:defRPr sz="2000" b="0">
                 <a:solidFill>
                   <a:srgbClr val="626669"/>
                 </a:solidFill>
@@ -1036,6 +1036,11 @@
               </a:defRPr>
             </a:pPr>
             <a:r>
+              <a:rPr sz="2000">
+                <a:solidFill>
+                  <a:srgbClr val="303437"/>
+                </a:solidFill>
+              </a:rPr>
               <a:t>氏名　［氏名］</a:t>
             </a:r>
           </a:p>

</xml_diff>

<commit_message>
Repair OOXML compatibility, match native lists, and refine UCF101 slides
</commit_message>
<xml_diff>
--- a/.agents/skills/master-guided-slides/SlideMaster.pptx
+++ b/.agents/skills/master-guided-slides/SlideMaster.pptx
@@ -16,27 +16,6 @@
   </p:sldIdLst>
   <p:sldSz cx="9144000" cy="5143500" type="screen16x9"/>
   <p:notesSz cx="6858000" cy="9144000"/>
-  <p:extLst>
-    <p:ext uri="{EFAFB233-063F-42B5-8137-9DF3F51BA10A}">
-      <p15:sldGuideLst xmlns:p15="http://schemas.microsoft.com/office/powerpoint/2012/main">
-        <p15:guide id="1" orient="horz" pos="590">
-          <p15:clr>
-            <a:srgbClr val="747775"/>
-          </p15:clr>
-        </p15:guide>
-        <p15:guide id="2" pos="1271">
-          <p15:clr>
-            <a:srgbClr val="747775"/>
-          </p15:clr>
-        </p15:guide>
-        <p15:guide id="3" orient="horz" pos="1584">
-          <p15:clr>
-            <a:srgbClr val="747775"/>
-          </p15:clr>
-        </p15:guide>
-      </p15:sldGuideLst>
-    </p:ext>
-  </p:extLst>
   <p:defaultTextStyle>
     <a:defPPr marR="0" lvl="0" algn="l" rtl="0">
       <a:lnSpc>
@@ -62,14 +41,14 @@
       <a:buClr>
         <a:srgbClr val="000000"/>
       </a:buClr>
-      <a:buFont typeface="Arial"/>
+      <a:buFont typeface="Noto Sans CJK JP"/>
       <a:defRPr sz="1400" b="0" i="0" u="none" strike="noStrike" cap="none" lang="ja-JP">
         <a:solidFill>
           <a:srgbClr val="000000"/>
         </a:solidFill>
-        <a:latin typeface="Arial"/>
-        <a:ea typeface="ＭＳ Ｐゴシック"/>
-        <a:cs typeface="Arial"/>
+        <a:latin typeface="Noto Sans"/>
+        <a:ea typeface="Noto Sans CJK JP"/>
+        <a:cs typeface="Noto Sans"/>
         <a:sym typeface="Arial"/>
       </a:defRPr>
     </a:lvl1pPr>
@@ -86,14 +65,14 @@
       <a:buClr>
         <a:srgbClr val="000000"/>
       </a:buClr>
-      <a:buFont typeface="Arial"/>
+      <a:buFont typeface="Noto Sans CJK JP"/>
       <a:defRPr sz="1400" b="0" i="0" u="none" strike="noStrike" cap="none" lang="ja-JP">
         <a:solidFill>
           <a:srgbClr val="000000"/>
         </a:solidFill>
-        <a:latin typeface="Arial"/>
-        <a:ea typeface="ＭＳ Ｐゴシック"/>
-        <a:cs typeface="Arial"/>
+        <a:latin typeface="Noto Sans"/>
+        <a:ea typeface="Noto Sans CJK JP"/>
+        <a:cs typeface="Noto Sans"/>
         <a:sym typeface="Arial"/>
       </a:defRPr>
     </a:lvl2pPr>
@@ -110,14 +89,14 @@
       <a:buClr>
         <a:srgbClr val="000000"/>
       </a:buClr>
-      <a:buFont typeface="Arial"/>
+      <a:buFont typeface="Noto Sans CJK JP"/>
       <a:defRPr sz="1400" b="0" i="0" u="none" strike="noStrike" cap="none" lang="ja-JP">
         <a:solidFill>
           <a:srgbClr val="000000"/>
         </a:solidFill>
-        <a:latin typeface="Arial"/>
-        <a:ea typeface="ＭＳ Ｐゴシック"/>
-        <a:cs typeface="Arial"/>
+        <a:latin typeface="Noto Sans"/>
+        <a:ea typeface="Noto Sans CJK JP"/>
+        <a:cs typeface="Noto Sans"/>
         <a:sym typeface="Arial"/>
       </a:defRPr>
     </a:lvl3pPr>
@@ -134,14 +113,14 @@
       <a:buClr>
         <a:srgbClr val="000000"/>
       </a:buClr>
-      <a:buFont typeface="Arial"/>
+      <a:buFont typeface="Noto Sans CJK JP"/>
       <a:defRPr sz="1400" b="0" i="0" u="none" strike="noStrike" cap="none" lang="ja-JP">
         <a:solidFill>
           <a:srgbClr val="000000"/>
         </a:solidFill>
-        <a:latin typeface="Arial"/>
-        <a:ea typeface="ＭＳ Ｐゴシック"/>
-        <a:cs typeface="Arial"/>
+        <a:latin typeface="Noto Sans"/>
+        <a:ea typeface="Noto Sans CJK JP"/>
+        <a:cs typeface="Noto Sans"/>
         <a:sym typeface="Arial"/>
       </a:defRPr>
     </a:lvl4pPr>
@@ -158,14 +137,14 @@
       <a:buClr>
         <a:srgbClr val="000000"/>
       </a:buClr>
-      <a:buFont typeface="Arial"/>
+      <a:buFont typeface="Noto Sans CJK JP"/>
       <a:defRPr sz="1400" b="0" i="0" u="none" strike="noStrike" cap="none" lang="ja-JP">
         <a:solidFill>
           <a:srgbClr val="000000"/>
         </a:solidFill>
-        <a:latin typeface="Arial"/>
-        <a:ea typeface="ＭＳ Ｐゴシック"/>
-        <a:cs typeface="Arial"/>
+        <a:latin typeface="Noto Sans"/>
+        <a:ea typeface="Noto Sans CJK JP"/>
+        <a:cs typeface="Noto Sans"/>
         <a:sym typeface="Arial"/>
       </a:defRPr>
     </a:lvl5pPr>
@@ -182,14 +161,14 @@
       <a:buClr>
         <a:srgbClr val="000000"/>
       </a:buClr>
-      <a:buFont typeface="Arial"/>
+      <a:buFont typeface="Noto Sans CJK JP"/>
       <a:defRPr sz="1400" b="0" i="0" u="none" strike="noStrike" cap="none" lang="ja-JP">
         <a:solidFill>
           <a:srgbClr val="000000"/>
         </a:solidFill>
-        <a:latin typeface="Arial"/>
-        <a:ea typeface="ＭＳ Ｐゴシック"/>
-        <a:cs typeface="Arial"/>
+        <a:latin typeface="Noto Sans"/>
+        <a:ea typeface="Noto Sans CJK JP"/>
+        <a:cs typeface="Noto Sans"/>
         <a:sym typeface="Arial"/>
       </a:defRPr>
     </a:lvl6pPr>
@@ -206,14 +185,14 @@
       <a:buClr>
         <a:srgbClr val="000000"/>
       </a:buClr>
-      <a:buFont typeface="Arial"/>
+      <a:buFont typeface="Noto Sans CJK JP"/>
       <a:defRPr sz="1400" b="0" i="0" u="none" strike="noStrike" cap="none" lang="ja-JP">
         <a:solidFill>
           <a:srgbClr val="000000"/>
         </a:solidFill>
-        <a:latin typeface="Arial"/>
-        <a:ea typeface="ＭＳ Ｐゴシック"/>
-        <a:cs typeface="Arial"/>
+        <a:latin typeface="Noto Sans"/>
+        <a:ea typeface="Noto Sans CJK JP"/>
+        <a:cs typeface="Noto Sans"/>
         <a:sym typeface="Arial"/>
       </a:defRPr>
     </a:lvl7pPr>
@@ -230,14 +209,14 @@
       <a:buClr>
         <a:srgbClr val="000000"/>
       </a:buClr>
-      <a:buFont typeface="Arial"/>
+      <a:buFont typeface="Noto Sans CJK JP"/>
       <a:defRPr sz="1400" b="0" i="0" u="none" strike="noStrike" cap="none" lang="ja-JP">
         <a:solidFill>
           <a:srgbClr val="000000"/>
         </a:solidFill>
-        <a:latin typeface="Arial"/>
-        <a:ea typeface="ＭＳ Ｐゴシック"/>
-        <a:cs typeface="Arial"/>
+        <a:latin typeface="Noto Sans"/>
+        <a:ea typeface="Noto Sans CJK JP"/>
+        <a:cs typeface="Noto Sans"/>
         <a:sym typeface="Arial"/>
       </a:defRPr>
     </a:lvl8pPr>
@@ -254,18 +233,39 @@
       <a:buClr>
         <a:srgbClr val="000000"/>
       </a:buClr>
-      <a:buFont typeface="Arial"/>
+      <a:buFont typeface="Noto Sans CJK JP"/>
       <a:defRPr sz="1400" b="0" i="0" u="none" strike="noStrike" cap="none" lang="ja-JP">
         <a:solidFill>
           <a:srgbClr val="000000"/>
         </a:solidFill>
-        <a:latin typeface="Arial"/>
-        <a:ea typeface="ＭＳ Ｐゴシック"/>
-        <a:cs typeface="Arial"/>
+        <a:latin typeface="Noto Sans"/>
+        <a:ea typeface="Noto Sans CJK JP"/>
+        <a:cs typeface="Noto Sans"/>
         <a:sym typeface="Arial"/>
       </a:defRPr>
     </a:lvl9pPr>
   </p:defaultTextStyle>
+  <p:extLst>
+    <p:ext uri="{EFAFB233-063F-42B5-8137-9DF3F51BA10A}">
+      <p15:sldGuideLst xmlns:p15="http://schemas.microsoft.com/office/powerpoint/2012/main">
+        <p15:guide id="1" orient="horz" pos="590">
+          <p15:clr>
+            <a:srgbClr val="747775"/>
+          </p15:clr>
+        </p15:guide>
+        <p15:guide id="2" pos="1271">
+          <p15:clr>
+            <a:srgbClr val="747775"/>
+          </p15:clr>
+        </p15:guide>
+        <p15:guide id="3" orient="horz" pos="1584">
+          <p15:clr>
+            <a:srgbClr val="747775"/>
+          </p15:clr>
+        </p15:guide>
+      </p15:sldGuideLst>
+    </p:ext>
+  </p:extLst>
 </p:presentation>
 </file>
 
@@ -326,9 +326,9 @@
                 <a:solidFill>
                   <a:schemeClr val="dk1"/>
                 </a:solidFill>
-                <a:latin typeface="Arial"/>
-                <a:ea typeface="ＭＳ Ｐゴシック"/>
-                <a:cs typeface="Arial"/>
+                <a:latin typeface="Noto Sans"/>
+                <a:ea typeface="Noto Sans CJK JP"/>
+                <a:cs typeface="Noto Sans"/>
               </a:defRPr>
             </a:lvl1pPr>
             <a:lvl2pPr lvl="1" algn="ctr">
@@ -341,9 +341,9 @@
               <a:buSzPts val="5200"/>
               <a:buNone/>
               <a:defRPr sz="5200" lang="ja-JP">
-                <a:latin typeface="Arial"/>
-                <a:ea typeface="ＭＳ Ｐゴシック"/>
-                <a:cs typeface="Arial"/>
+                <a:latin typeface="Noto Sans"/>
+                <a:ea typeface="Noto Sans CJK JP"/>
+                <a:cs typeface="Noto Sans"/>
               </a:defRPr>
             </a:lvl2pPr>
             <a:lvl3pPr lvl="2" algn="ctr">
@@ -356,9 +356,9 @@
               <a:buSzPts val="5200"/>
               <a:buNone/>
               <a:defRPr sz="5200" lang="ja-JP">
-                <a:latin typeface="Arial"/>
-                <a:ea typeface="ＭＳ Ｐゴシック"/>
-                <a:cs typeface="Arial"/>
+                <a:latin typeface="Noto Sans"/>
+                <a:ea typeface="Noto Sans CJK JP"/>
+                <a:cs typeface="Noto Sans"/>
               </a:defRPr>
             </a:lvl3pPr>
             <a:lvl4pPr lvl="3" algn="ctr">
@@ -371,9 +371,9 @@
               <a:buSzPts val="5200"/>
               <a:buNone/>
               <a:defRPr sz="5200" lang="ja-JP">
-                <a:latin typeface="Arial"/>
-                <a:ea typeface="ＭＳ Ｐゴシック"/>
-                <a:cs typeface="Arial"/>
+                <a:latin typeface="Noto Sans"/>
+                <a:ea typeface="Noto Sans CJK JP"/>
+                <a:cs typeface="Noto Sans"/>
               </a:defRPr>
             </a:lvl4pPr>
             <a:lvl5pPr lvl="4" algn="ctr">
@@ -386,9 +386,9 @@
               <a:buSzPts val="5200"/>
               <a:buNone/>
               <a:defRPr sz="5200" lang="ja-JP">
-                <a:latin typeface="Arial"/>
-                <a:ea typeface="ＭＳ Ｐゴシック"/>
-                <a:cs typeface="Arial"/>
+                <a:latin typeface="Noto Sans"/>
+                <a:ea typeface="Noto Sans CJK JP"/>
+                <a:cs typeface="Noto Sans"/>
               </a:defRPr>
             </a:lvl5pPr>
             <a:lvl6pPr lvl="5" algn="ctr">
@@ -401,9 +401,9 @@
               <a:buSzPts val="5200"/>
               <a:buNone/>
               <a:defRPr sz="5200" lang="ja-JP">
-                <a:latin typeface="Arial"/>
-                <a:ea typeface="ＭＳ Ｐゴシック"/>
-                <a:cs typeface="Arial"/>
+                <a:latin typeface="Noto Sans"/>
+                <a:ea typeface="Noto Sans CJK JP"/>
+                <a:cs typeface="Noto Sans"/>
               </a:defRPr>
             </a:lvl6pPr>
             <a:lvl7pPr lvl="6" algn="ctr">
@@ -416,9 +416,9 @@
               <a:buSzPts val="5200"/>
               <a:buNone/>
               <a:defRPr sz="5200" lang="ja-JP">
-                <a:latin typeface="Arial"/>
-                <a:ea typeface="ＭＳ Ｐゴシック"/>
-                <a:cs typeface="Arial"/>
+                <a:latin typeface="Noto Sans"/>
+                <a:ea typeface="Noto Sans CJK JP"/>
+                <a:cs typeface="Noto Sans"/>
               </a:defRPr>
             </a:lvl7pPr>
             <a:lvl8pPr lvl="7" algn="ctr">
@@ -431,9 +431,9 @@
               <a:buSzPts val="5200"/>
               <a:buNone/>
               <a:defRPr sz="5200" lang="ja-JP">
-                <a:latin typeface="Arial"/>
-                <a:ea typeface="ＭＳ Ｐゴシック"/>
-                <a:cs typeface="Arial"/>
+                <a:latin typeface="Noto Sans"/>
+                <a:ea typeface="Noto Sans CJK JP"/>
+                <a:cs typeface="Noto Sans"/>
               </a:defRPr>
             </a:lvl8pPr>
             <a:lvl9pPr lvl="8" algn="ctr">
@@ -446,17 +446,17 @@
               <a:buSzPts val="5200"/>
               <a:buNone/>
               <a:defRPr sz="5200" lang="ja-JP">
-                <a:latin typeface="Arial"/>
-                <a:ea typeface="ＭＳ Ｐゴシック"/>
-                <a:cs typeface="Arial"/>
+                <a:latin typeface="Noto Sans"/>
+                <a:ea typeface="Noto Sans CJK JP"/>
+                <a:cs typeface="Noto Sans"/>
               </a:defRPr>
             </a:lvl9pPr>
           </a:lstStyle>
           <a:p>
             <a:endParaRPr lang="ja-JP">
-              <a:latin typeface="Arial"/>
-              <a:ea typeface="ＭＳ Ｐゴシック"/>
-              <a:cs typeface="Arial"/>
+              <a:latin typeface="Noto Sans"/>
+              <a:ea typeface="Noto Sans CJK JP"/>
+              <a:cs typeface="Noto Sans"/>
             </a:endParaRPr>
           </a:p>
         </p:txBody>
@@ -504,9 +504,9 @@
                 <a:solidFill>
                   <a:schemeClr val="dk1"/>
                 </a:solidFill>
-                <a:latin typeface="Arial"/>
-                <a:ea typeface="ＭＳ Ｐゴシック"/>
-                <a:cs typeface="Arial"/>
+                <a:latin typeface="Noto Sans"/>
+                <a:ea typeface="Noto Sans CJK JP"/>
+                <a:cs typeface="Noto Sans"/>
               </a:defRPr>
             </a:lvl1pPr>
             <a:lvl2pPr lvl="1" algn="ctr">
@@ -522,9 +522,9 @@
               <a:buSzPts val="2800"/>
               <a:buNone/>
               <a:defRPr sz="2800" lang="ja-JP">
-                <a:latin typeface="Arial"/>
-                <a:ea typeface="ＭＳ Ｐゴシック"/>
-                <a:cs typeface="Arial"/>
+                <a:latin typeface="Noto Sans"/>
+                <a:ea typeface="Noto Sans CJK JP"/>
+                <a:cs typeface="Noto Sans"/>
               </a:defRPr>
             </a:lvl2pPr>
             <a:lvl3pPr lvl="2" algn="ctr">
@@ -540,9 +540,9 @@
               <a:buSzPts val="2800"/>
               <a:buNone/>
               <a:defRPr sz="2800" lang="ja-JP">
-                <a:latin typeface="Arial"/>
-                <a:ea typeface="ＭＳ Ｐゴシック"/>
-                <a:cs typeface="Arial"/>
+                <a:latin typeface="Noto Sans"/>
+                <a:ea typeface="Noto Sans CJK JP"/>
+                <a:cs typeface="Noto Sans"/>
               </a:defRPr>
             </a:lvl3pPr>
             <a:lvl4pPr lvl="3" algn="ctr">
@@ -558,9 +558,9 @@
               <a:buSzPts val="2800"/>
               <a:buNone/>
               <a:defRPr sz="2800" lang="ja-JP">
-                <a:latin typeface="Arial"/>
-                <a:ea typeface="ＭＳ Ｐゴシック"/>
-                <a:cs typeface="Arial"/>
+                <a:latin typeface="Noto Sans"/>
+                <a:ea typeface="Noto Sans CJK JP"/>
+                <a:cs typeface="Noto Sans"/>
               </a:defRPr>
             </a:lvl4pPr>
             <a:lvl5pPr lvl="4" algn="ctr">
@@ -576,9 +576,9 @@
               <a:buSzPts val="2800"/>
               <a:buNone/>
               <a:defRPr sz="2800" lang="ja-JP">
-                <a:latin typeface="Arial"/>
-                <a:ea typeface="ＭＳ Ｐゴシック"/>
-                <a:cs typeface="Arial"/>
+                <a:latin typeface="Noto Sans"/>
+                <a:ea typeface="Noto Sans CJK JP"/>
+                <a:cs typeface="Noto Sans"/>
               </a:defRPr>
             </a:lvl5pPr>
             <a:lvl6pPr lvl="5" algn="ctr">
@@ -594,9 +594,9 @@
               <a:buSzPts val="2800"/>
               <a:buNone/>
               <a:defRPr sz="2800" lang="ja-JP">
-                <a:latin typeface="Arial"/>
-                <a:ea typeface="ＭＳ Ｐゴシック"/>
-                <a:cs typeface="Arial"/>
+                <a:latin typeface="Noto Sans"/>
+                <a:ea typeface="Noto Sans CJK JP"/>
+                <a:cs typeface="Noto Sans"/>
               </a:defRPr>
             </a:lvl6pPr>
             <a:lvl7pPr lvl="6" algn="ctr">
@@ -612,9 +612,9 @@
               <a:buSzPts val="2800"/>
               <a:buNone/>
               <a:defRPr sz="2800" lang="ja-JP">
-                <a:latin typeface="Arial"/>
-                <a:ea typeface="ＭＳ Ｐゴシック"/>
-                <a:cs typeface="Arial"/>
+                <a:latin typeface="Noto Sans"/>
+                <a:ea typeface="Noto Sans CJK JP"/>
+                <a:cs typeface="Noto Sans"/>
               </a:defRPr>
             </a:lvl7pPr>
             <a:lvl8pPr lvl="7" algn="ctr">
@@ -630,9 +630,9 @@
               <a:buSzPts val="2800"/>
               <a:buNone/>
               <a:defRPr sz="2800" lang="ja-JP">
-                <a:latin typeface="Arial"/>
-                <a:ea typeface="ＭＳ Ｐゴシック"/>
-                <a:cs typeface="Arial"/>
+                <a:latin typeface="Noto Sans"/>
+                <a:ea typeface="Noto Sans CJK JP"/>
+                <a:cs typeface="Noto Sans"/>
               </a:defRPr>
             </a:lvl8pPr>
             <a:lvl9pPr lvl="8" algn="ctr">
@@ -648,24 +648,24 @@
               <a:buSzPts val="2800"/>
               <a:buNone/>
               <a:defRPr sz="2800" lang="ja-JP">
-                <a:latin typeface="Arial"/>
-                <a:ea typeface="ＭＳ Ｐゴシック"/>
-                <a:cs typeface="Arial"/>
+                <a:latin typeface="Noto Sans"/>
+                <a:ea typeface="Noto Sans CJK JP"/>
+                <a:cs typeface="Noto Sans"/>
               </a:defRPr>
             </a:lvl9pPr>
           </a:lstStyle>
           <a:p>
             <a:pPr>
               <a:defRPr sz="2200" lang="ja-JP">
-                <a:latin typeface="Arial"/>
-                <a:ea typeface="ＭＳ Ｐゴシック"/>
-                <a:cs typeface="Arial"/>
+                <a:latin typeface="Noto Sans"/>
+                <a:ea typeface="Noto Sans CJK JP"/>
+                <a:cs typeface="Noto Sans"/>
               </a:defRPr>
             </a:pPr>
             <a:endParaRPr lang="ja-JP">
-              <a:latin typeface="Arial"/>
-              <a:ea typeface="ＭＳ Ｐゴシック"/>
-              <a:cs typeface="Arial"/>
+              <a:latin typeface="Noto Sans"/>
+              <a:ea typeface="Noto Sans CJK JP"/>
+              <a:cs typeface="Noto Sans"/>
             </a:endParaRPr>
           </a:p>
         </p:txBody>
@@ -713,9 +713,9 @@
               <a:buNone/>
             </a:pPr>
             <a:endParaRPr lang="ja-JP">
-              <a:latin typeface="Arial"/>
-              <a:ea typeface="ＭＳ Ｐゴシック"/>
-              <a:cs typeface="Arial"/>
+              <a:latin typeface="Noto Sans"/>
+              <a:ea typeface="Noto Sans CJK JP"/>
+              <a:cs typeface="Noto Sans"/>
             </a:endParaRPr>
           </a:p>
         </p:txBody>
@@ -755,17 +755,17 @@
                 <a:solidFill>
                   <a:schemeClr val="lt1"/>
                 </a:solidFill>
-                <a:latin typeface="Arial"/>
-                <a:ea typeface="ＭＳ Ｐゴシック"/>
-                <a:cs typeface="Arial"/>
+                <a:latin typeface="Noto Sans"/>
+                <a:ea typeface="Noto Sans CJK JP"/>
+                <a:cs typeface="Noto Sans"/>
               </a:rPr>
               <a:pPr algn="ctr"/>
               <a:t>‹#›</a:t>
             </a:fld>
             <a:endParaRPr lang="ja-JP" sz="1800" b="1" dirty="0">
-              <a:latin typeface="Arial"/>
-              <a:ea typeface="ＭＳ Ｐゴシック"/>
-              <a:cs typeface="Arial"/>
+              <a:latin typeface="Noto Sans"/>
+              <a:ea typeface="Noto Sans CJK JP"/>
+              <a:cs typeface="Noto Sans"/>
             </a:endParaRPr>
           </a:p>
         </p:txBody>
@@ -810,9 +810,9 @@
                 <a:solidFill>
                   <a:srgbClr val="303437"/>
                 </a:solidFill>
-                <a:latin typeface="Arial"/>
-                <a:ea typeface="ＭＳ Ｐゴシック"/>
-                <a:cs typeface="Arial"/>
+                <a:latin typeface="Noto Sans"/>
+                <a:ea typeface="Noto Sans CJK JP"/>
+                <a:cs typeface="Noto Sans"/>
               </a:defRPr>
             </a:lvl1pPr>
             <a:lvl2pPr marL="914400" lvl="1" indent="-355600">
@@ -831,9 +831,9 @@
                 <a:solidFill>
                   <a:srgbClr val="303437"/>
                 </a:solidFill>
-                <a:latin typeface="Arial"/>
-                <a:ea typeface="ＭＳ Ｐゴシック"/>
-                <a:cs typeface="Arial"/>
+                <a:latin typeface="Noto Sans"/>
+                <a:ea typeface="Noto Sans CJK JP"/>
+                <a:cs typeface="Noto Sans"/>
               </a:defRPr>
             </a:lvl2pPr>
             <a:lvl3pPr marL="1371600" lvl="2" indent="-355600">
@@ -852,9 +852,9 @@
                 <a:solidFill>
                   <a:srgbClr val="303437"/>
                 </a:solidFill>
-                <a:latin typeface="Arial"/>
-                <a:ea typeface="ＭＳ Ｐゴシック"/>
-                <a:cs typeface="Arial"/>
+                <a:latin typeface="Noto Sans"/>
+                <a:ea typeface="Noto Sans CJK JP"/>
+                <a:cs typeface="Noto Sans"/>
               </a:defRPr>
             </a:lvl3pPr>
             <a:lvl4pPr marL="1828800" lvl="3" indent="-368300">
@@ -873,9 +873,9 @@
                 <a:solidFill>
                   <a:srgbClr val="303437"/>
                 </a:solidFill>
-                <a:latin typeface="Arial"/>
-                <a:ea typeface="ＭＳ Ｐゴシック"/>
-                <a:cs typeface="Arial"/>
+                <a:latin typeface="Noto Sans"/>
+                <a:ea typeface="Noto Sans CJK JP"/>
+                <a:cs typeface="Noto Sans"/>
               </a:defRPr>
             </a:lvl4pPr>
             <a:lvl5pPr marL="2286000" lvl="4" indent="-355600">
@@ -894,9 +894,9 @@
                 <a:solidFill>
                   <a:srgbClr val="303437"/>
                 </a:solidFill>
-                <a:latin typeface="Arial"/>
-                <a:ea typeface="ＭＳ Ｐゴシック"/>
-                <a:cs typeface="Arial"/>
+                <a:latin typeface="Noto Sans"/>
+                <a:ea typeface="Noto Sans CJK JP"/>
+                <a:cs typeface="Noto Sans"/>
               </a:defRPr>
             </a:lvl5pPr>
             <a:lvl6pPr marL="2743200" lvl="5" indent="-355600">
@@ -915,9 +915,9 @@
                 <a:solidFill>
                   <a:srgbClr val="303437"/>
                 </a:solidFill>
-                <a:latin typeface="Arial"/>
-                <a:ea typeface="ＭＳ Ｐゴシック"/>
-                <a:cs typeface="Arial"/>
+                <a:latin typeface="Noto Sans"/>
+                <a:ea typeface="Noto Sans CJK JP"/>
+                <a:cs typeface="Noto Sans"/>
               </a:defRPr>
             </a:lvl6pPr>
             <a:lvl7pPr marL="3200400" lvl="6" indent="-355600">
@@ -936,9 +936,9 @@
                 <a:solidFill>
                   <a:srgbClr val="303437"/>
                 </a:solidFill>
-                <a:latin typeface="Arial"/>
-                <a:ea typeface="ＭＳ Ｐゴシック"/>
-                <a:cs typeface="Arial"/>
+                <a:latin typeface="Noto Sans"/>
+                <a:ea typeface="Noto Sans CJK JP"/>
+                <a:cs typeface="Noto Sans"/>
               </a:defRPr>
             </a:lvl7pPr>
             <a:lvl8pPr marL="3657600" lvl="7" indent="-355600">
@@ -957,9 +957,9 @@
                 <a:solidFill>
                   <a:srgbClr val="303437"/>
                 </a:solidFill>
-                <a:latin typeface="Arial"/>
-                <a:ea typeface="ＭＳ Ｐゴシック"/>
-                <a:cs typeface="Arial"/>
+                <a:latin typeface="Noto Sans"/>
+                <a:ea typeface="Noto Sans CJK JP"/>
+                <a:cs typeface="Noto Sans"/>
               </a:defRPr>
             </a:lvl8pPr>
             <a:lvl9pPr marL="4114800" lvl="8" indent="-355600">
@@ -978,9 +978,9 @@
                 <a:solidFill>
                   <a:srgbClr val="303437"/>
                 </a:solidFill>
-                <a:latin typeface="Arial"/>
-                <a:ea typeface="ＭＳ Ｐゴシック"/>
-                <a:cs typeface="Arial"/>
+                <a:latin typeface="Noto Sans"/>
+                <a:ea typeface="Noto Sans CJK JP"/>
+                <a:cs typeface="Noto Sans"/>
               </a:defRPr>
             </a:lvl9pPr>
           </a:lstStyle>
@@ -999,9 +999,9 @@
                 <a:solidFill>
                   <a:srgbClr val="626669"/>
                 </a:solidFill>
-                <a:latin typeface="Arial"/>
-                <a:ea typeface="ＭＳ Ｐゴシック"/>
-                <a:cs typeface="Arial"/>
+                <a:latin typeface="Noto Sans"/>
+                <a:ea typeface="Noto Sans CJK JP"/>
+                <a:cs typeface="Noto Sans"/>
               </a:defRPr>
             </a:pPr>
             <a:r>
@@ -1050,9 +1050,9 @@
                 <a:solidFill>
                   <a:srgbClr val="303437"/>
                 </a:solidFill>
-                <a:latin typeface="Arial"/>
-                <a:ea typeface="ＭＳ Ｐゴシック"/>
-                <a:cs typeface="Arial"/>
+                <a:latin typeface="Noto Sans"/>
+                <a:ea typeface="Noto Sans CJK JP"/>
+                <a:cs typeface="Noto Sans"/>
               </a:defRPr>
             </a:lvl1pPr>
             <a:lvl2pPr marL="914400" lvl="1" indent="-355600">
@@ -1071,9 +1071,9 @@
                 <a:solidFill>
                   <a:srgbClr val="303437"/>
                 </a:solidFill>
-                <a:latin typeface="Arial"/>
-                <a:ea typeface="ＭＳ Ｐゴシック"/>
-                <a:cs typeface="Arial"/>
+                <a:latin typeface="Noto Sans"/>
+                <a:ea typeface="Noto Sans CJK JP"/>
+                <a:cs typeface="Noto Sans"/>
               </a:defRPr>
             </a:lvl2pPr>
             <a:lvl3pPr marL="1371600" lvl="2" indent="-355600">
@@ -1092,9 +1092,9 @@
                 <a:solidFill>
                   <a:srgbClr val="303437"/>
                 </a:solidFill>
-                <a:latin typeface="Arial"/>
-                <a:ea typeface="ＭＳ Ｐゴシック"/>
-                <a:cs typeface="Arial"/>
+                <a:latin typeface="Noto Sans"/>
+                <a:ea typeface="Noto Sans CJK JP"/>
+                <a:cs typeface="Noto Sans"/>
               </a:defRPr>
             </a:lvl3pPr>
             <a:lvl4pPr marL="1828800" lvl="3" indent="-368300">
@@ -1113,9 +1113,9 @@
                 <a:solidFill>
                   <a:srgbClr val="303437"/>
                 </a:solidFill>
-                <a:latin typeface="Arial"/>
-                <a:ea typeface="ＭＳ Ｐゴシック"/>
-                <a:cs typeface="Arial"/>
+                <a:latin typeface="Noto Sans"/>
+                <a:ea typeface="Noto Sans CJK JP"/>
+                <a:cs typeface="Noto Sans"/>
               </a:defRPr>
             </a:lvl4pPr>
             <a:lvl5pPr marL="2286000" lvl="4" indent="-355600">
@@ -1134,9 +1134,9 @@
                 <a:solidFill>
                   <a:srgbClr val="303437"/>
                 </a:solidFill>
-                <a:latin typeface="Arial"/>
-                <a:ea typeface="ＭＳ Ｐゴシック"/>
-                <a:cs typeface="Arial"/>
+                <a:latin typeface="Noto Sans"/>
+                <a:ea typeface="Noto Sans CJK JP"/>
+                <a:cs typeface="Noto Sans"/>
               </a:defRPr>
             </a:lvl5pPr>
             <a:lvl6pPr marL="2743200" lvl="5" indent="-355600">
@@ -1155,9 +1155,9 @@
                 <a:solidFill>
                   <a:srgbClr val="303437"/>
                 </a:solidFill>
-                <a:latin typeface="Arial"/>
-                <a:ea typeface="ＭＳ Ｐゴシック"/>
-                <a:cs typeface="Arial"/>
+                <a:latin typeface="Noto Sans"/>
+                <a:ea typeface="Noto Sans CJK JP"/>
+                <a:cs typeface="Noto Sans"/>
               </a:defRPr>
             </a:lvl6pPr>
             <a:lvl7pPr marL="3200400" lvl="6" indent="-355600">
@@ -1176,9 +1176,9 @@
                 <a:solidFill>
                   <a:srgbClr val="303437"/>
                 </a:solidFill>
-                <a:latin typeface="Arial"/>
-                <a:ea typeface="ＭＳ Ｐゴシック"/>
-                <a:cs typeface="Arial"/>
+                <a:latin typeface="Noto Sans"/>
+                <a:ea typeface="Noto Sans CJK JP"/>
+                <a:cs typeface="Noto Sans"/>
               </a:defRPr>
             </a:lvl7pPr>
             <a:lvl8pPr marL="3657600" lvl="7" indent="-355600">
@@ -1197,9 +1197,9 @@
                 <a:solidFill>
                   <a:srgbClr val="303437"/>
                 </a:solidFill>
-                <a:latin typeface="Arial"/>
-                <a:ea typeface="ＭＳ Ｐゴシック"/>
-                <a:cs typeface="Arial"/>
+                <a:latin typeface="Noto Sans"/>
+                <a:ea typeface="Noto Sans CJK JP"/>
+                <a:cs typeface="Noto Sans"/>
               </a:defRPr>
             </a:lvl8pPr>
             <a:lvl9pPr marL="4114800" lvl="8" indent="-355600">
@@ -1218,9 +1218,9 @@
                 <a:solidFill>
                   <a:srgbClr val="303437"/>
                 </a:solidFill>
-                <a:latin typeface="Arial"/>
-                <a:ea typeface="ＭＳ Ｐゴシック"/>
-                <a:cs typeface="Arial"/>
+                <a:latin typeface="Noto Sans"/>
+                <a:ea typeface="Noto Sans CJK JP"/>
+                <a:cs typeface="Noto Sans"/>
               </a:defRPr>
             </a:lvl9pPr>
           </a:lstStyle>
@@ -1239,9 +1239,9 @@
                 <a:solidFill>
                   <a:srgbClr val="626669"/>
                 </a:solidFill>
-                <a:latin typeface="Arial"/>
-                <a:ea typeface="ＭＳ Ｐゴシック"/>
-                <a:cs typeface="Arial"/>
+                <a:latin typeface="Noto Sans"/>
+                <a:ea typeface="Noto Sans CJK JP"/>
+                <a:cs typeface="Noto Sans"/>
               </a:defRPr>
             </a:pPr>
             <a:r>
@@ -1249,9 +1249,9 @@
                 <a:solidFill>
                   <a:srgbClr val="303437"/>
                 </a:solidFill>
-                <a:latin typeface="Arial"/>
-                <a:ea typeface="ＭＳ Ｐゴシック"/>
-                <a:cs typeface="Arial"/>
+                <a:latin typeface="Noto Sans"/>
+                <a:ea typeface="Noto Sans CJK JP"/>
+                <a:cs typeface="Noto Sans"/>
               </a:rPr>
               <a:t>氏名　［氏名］</a:t>
             </a:r>
@@ -1298,9 +1298,9 @@
                 <a:solidFill>
                   <a:srgbClr val="303437"/>
                 </a:solidFill>
-                <a:latin typeface="Arial"/>
-                <a:ea typeface="ＭＳ Ｐゴシック"/>
-                <a:cs typeface="Arial"/>
+                <a:latin typeface="Noto Sans"/>
+                <a:ea typeface="Noto Sans CJK JP"/>
+                <a:cs typeface="Noto Sans"/>
               </a:defRPr>
             </a:lvl1pPr>
             <a:lvl2pPr marL="914400" lvl="1" indent="-355600">
@@ -1319,9 +1319,9 @@
                 <a:solidFill>
                   <a:srgbClr val="303437"/>
                 </a:solidFill>
-                <a:latin typeface="Arial"/>
-                <a:ea typeface="ＭＳ Ｐゴシック"/>
-                <a:cs typeface="Arial"/>
+                <a:latin typeface="Noto Sans"/>
+                <a:ea typeface="Noto Sans CJK JP"/>
+                <a:cs typeface="Noto Sans"/>
               </a:defRPr>
             </a:lvl2pPr>
             <a:lvl3pPr marL="1371600" lvl="2" indent="-355600">
@@ -1340,9 +1340,9 @@
                 <a:solidFill>
                   <a:srgbClr val="303437"/>
                 </a:solidFill>
-                <a:latin typeface="Arial"/>
-                <a:ea typeface="ＭＳ Ｐゴシック"/>
-                <a:cs typeface="Arial"/>
+                <a:latin typeface="Noto Sans"/>
+                <a:ea typeface="Noto Sans CJK JP"/>
+                <a:cs typeface="Noto Sans"/>
               </a:defRPr>
             </a:lvl3pPr>
             <a:lvl4pPr marL="1828800" lvl="3" indent="-368300">
@@ -1361,9 +1361,9 @@
                 <a:solidFill>
                   <a:srgbClr val="303437"/>
                 </a:solidFill>
-                <a:latin typeface="Arial"/>
-                <a:ea typeface="ＭＳ Ｐゴシック"/>
-                <a:cs typeface="Arial"/>
+                <a:latin typeface="Noto Sans"/>
+                <a:ea typeface="Noto Sans CJK JP"/>
+                <a:cs typeface="Noto Sans"/>
               </a:defRPr>
             </a:lvl4pPr>
             <a:lvl5pPr marL="2286000" lvl="4" indent="-355600">
@@ -1382,9 +1382,9 @@
                 <a:solidFill>
                   <a:srgbClr val="303437"/>
                 </a:solidFill>
-                <a:latin typeface="Arial"/>
-                <a:ea typeface="ＭＳ Ｐゴシック"/>
-                <a:cs typeface="Arial"/>
+                <a:latin typeface="Noto Sans"/>
+                <a:ea typeface="Noto Sans CJK JP"/>
+                <a:cs typeface="Noto Sans"/>
               </a:defRPr>
             </a:lvl5pPr>
             <a:lvl6pPr marL="2743200" lvl="5" indent="-355600">
@@ -1403,9 +1403,9 @@
                 <a:solidFill>
                   <a:srgbClr val="303437"/>
                 </a:solidFill>
-                <a:latin typeface="Arial"/>
-                <a:ea typeface="ＭＳ Ｐゴシック"/>
-                <a:cs typeface="Arial"/>
+                <a:latin typeface="Noto Sans"/>
+                <a:ea typeface="Noto Sans CJK JP"/>
+                <a:cs typeface="Noto Sans"/>
               </a:defRPr>
             </a:lvl6pPr>
             <a:lvl7pPr marL="3200400" lvl="6" indent="-355600">
@@ -1424,9 +1424,9 @@
                 <a:solidFill>
                   <a:srgbClr val="303437"/>
                 </a:solidFill>
-                <a:latin typeface="Arial"/>
-                <a:ea typeface="ＭＳ Ｐゴシック"/>
-                <a:cs typeface="Arial"/>
+                <a:latin typeface="Noto Sans"/>
+                <a:ea typeface="Noto Sans CJK JP"/>
+                <a:cs typeface="Noto Sans"/>
               </a:defRPr>
             </a:lvl7pPr>
             <a:lvl8pPr marL="3657600" lvl="7" indent="-355600">
@@ -1445,9 +1445,9 @@
                 <a:solidFill>
                   <a:srgbClr val="303437"/>
                 </a:solidFill>
-                <a:latin typeface="Arial"/>
-                <a:ea typeface="ＭＳ Ｐゴシック"/>
-                <a:cs typeface="Arial"/>
+                <a:latin typeface="Noto Sans"/>
+                <a:ea typeface="Noto Sans CJK JP"/>
+                <a:cs typeface="Noto Sans"/>
               </a:defRPr>
             </a:lvl8pPr>
             <a:lvl9pPr marL="4114800" lvl="8" indent="-355600">
@@ -1466,9 +1466,9 @@
                 <a:solidFill>
                   <a:srgbClr val="303437"/>
                 </a:solidFill>
-                <a:latin typeface="Arial"/>
-                <a:ea typeface="ＭＳ Ｐゴシック"/>
-                <a:cs typeface="Arial"/>
+                <a:latin typeface="Noto Sans"/>
+                <a:ea typeface="Noto Sans CJK JP"/>
+                <a:cs typeface="Noto Sans"/>
               </a:defRPr>
             </a:lvl9pPr>
           </a:lstStyle>
@@ -1487,9 +1487,9 @@
                 <a:solidFill>
                   <a:srgbClr val="626669"/>
                 </a:solidFill>
-                <a:latin typeface="Arial"/>
-                <a:ea typeface="ＭＳ Ｐゴシック"/>
-                <a:cs typeface="Arial"/>
+                <a:latin typeface="Noto Sans"/>
+                <a:ea typeface="Noto Sans CJK JP"/>
+                <a:cs typeface="Noto Sans"/>
               </a:defRPr>
             </a:pPr>
             <a:r>
@@ -1563,9 +1563,9 @@
               <a:buNone/>
             </a:pPr>
             <a:endParaRPr lang="ja-JP">
-              <a:latin typeface="Arial"/>
-              <a:ea typeface="ＭＳ Ｐゴシック"/>
-              <a:cs typeface="Arial"/>
+              <a:latin typeface="Noto Sans"/>
+              <a:ea typeface="Noto Sans CJK JP"/>
+              <a:cs typeface="Noto Sans"/>
             </a:endParaRPr>
           </a:p>
         </p:txBody>
@@ -1612,9 +1612,9 @@
                 <a:solidFill>
                   <a:schemeClr val="lt1"/>
                 </a:solidFill>
-                <a:latin typeface="Arial"/>
-                <a:ea typeface="ＭＳ Ｐゴシック"/>
-                <a:cs typeface="Arial"/>
+                <a:latin typeface="Noto Sans"/>
+                <a:ea typeface="Noto Sans CJK JP"/>
+                <a:cs typeface="Noto Sans"/>
               </a:rPr>
               <a:t>T</a:t>
             </a:r>
@@ -1623,9 +1623,9 @@
                 <a:solidFill>
                   <a:schemeClr val="lt1"/>
                 </a:solidFill>
-                <a:latin typeface="Arial"/>
-                <a:ea typeface="ＭＳ Ｐゴシック"/>
-                <a:cs typeface="Arial"/>
+                <a:latin typeface="Noto Sans"/>
+                <a:ea typeface="Noto Sans CJK JP"/>
+                <a:cs typeface="Noto Sans"/>
               </a:rPr>
               <a:t>able of </a:t>
             </a:r>
@@ -1634,9 +1634,9 @@
                 <a:solidFill>
                   <a:schemeClr val="lt1"/>
                 </a:solidFill>
-                <a:latin typeface="Arial"/>
-                <a:ea typeface="ＭＳ Ｐゴシック"/>
-                <a:cs typeface="Arial"/>
+                <a:latin typeface="Noto Sans"/>
+                <a:ea typeface="Noto Sans CJK JP"/>
+                <a:cs typeface="Noto Sans"/>
               </a:rPr>
               <a:t>C</a:t>
             </a:r>
@@ -1645,9 +1645,9 @@
                 <a:solidFill>
                   <a:schemeClr val="lt1"/>
                 </a:solidFill>
-                <a:latin typeface="Arial"/>
-                <a:ea typeface="ＭＳ Ｐゴシック"/>
-                <a:cs typeface="Arial"/>
+                <a:latin typeface="Noto Sans"/>
+                <a:ea typeface="Noto Sans CJK JP"/>
+                <a:cs typeface="Noto Sans"/>
               </a:rPr>
               <a:t>ontents</a:t>
             </a:r>
@@ -1655,9 +1655,9 @@
               <a:solidFill>
                 <a:schemeClr val="lt1"/>
               </a:solidFill>
-              <a:latin typeface="Arial"/>
-              <a:ea typeface="ＭＳ Ｐゴシック"/>
-              <a:cs typeface="Arial"/>
+              <a:latin typeface="Noto Sans"/>
+              <a:ea typeface="Noto Sans CJK JP"/>
+              <a:cs typeface="Noto Sans"/>
             </a:endParaRPr>
           </a:p>
         </p:txBody>
@@ -1701,13 +1701,13 @@
                 <a:schemeClr val="dk1"/>
               </a:buClr>
               <a:buSzPts val="1018"/>
-              <a:buFont typeface="Arial"/>
+              <a:buFont typeface="Noto Sans CJK JP"/>
               <a:buNone/>
               <a:tabLst/>
               <a:defRPr lang="ja-JP">
-                <a:latin typeface="Arial"/>
-                <a:ea typeface="ＭＳ Ｐゴシック"/>
-                <a:cs typeface="Arial"/>
+                <a:latin typeface="Noto Sans"/>
+                <a:ea typeface="Noto Sans CJK JP"/>
+                <a:cs typeface="Noto Sans"/>
               </a:defRPr>
             </a:pPr>
             <a:r>
@@ -1715,9 +1715,9 @@
                 <a:solidFill>
                   <a:schemeClr val="accent2"/>
                 </a:solidFill>
-                <a:latin typeface="Arial"/>
-                <a:ea typeface="ＭＳ Ｐゴシック"/>
-                <a:cs typeface="Arial"/>
+                <a:latin typeface="Noto Sans"/>
+                <a:ea typeface="Noto Sans CJK JP"/>
+                <a:cs typeface="Noto Sans"/>
               </a:rPr>
               <a:t>1.</a:t>
             </a:r>
@@ -1726,9 +1726,9 @@
                 <a:solidFill>
                   <a:schemeClr val="accent2"/>
                 </a:solidFill>
-                <a:latin typeface="Arial"/>
-                <a:ea typeface="ＭＳ Ｐゴシック"/>
-                <a:cs typeface="Arial"/>
+                <a:latin typeface="Noto Sans"/>
+                <a:ea typeface="Noto Sans CJK JP"/>
+                <a:cs typeface="Noto Sans"/>
               </a:rPr>
               <a:t> </a:t>
             </a:r>
@@ -1737,9 +1737,9 @@
                 <a:solidFill>
                   <a:schemeClr val="dk1"/>
                 </a:solidFill>
-                <a:latin typeface="Arial"/>
-                <a:ea typeface="ＭＳ Ｐゴシック"/>
-                <a:cs typeface="Arial"/>
+                <a:latin typeface="Noto Sans"/>
+                <a:ea typeface="Noto Sans CJK JP"/>
+                <a:cs typeface="Noto Sans"/>
               </a:rPr>
               <a:t>Background &amp; Purpose</a:t>
             </a:r>
@@ -1747,9 +1747,9 @@
               <a:solidFill>
                 <a:schemeClr val="dk1"/>
               </a:solidFill>
-              <a:latin typeface="Arial"/>
-              <a:ea typeface="ＭＳ Ｐゴシック"/>
-              <a:cs typeface="Arial"/>
+              <a:latin typeface="Noto Sans"/>
+              <a:ea typeface="Noto Sans CJK JP"/>
+              <a:cs typeface="Noto Sans"/>
             </a:endParaRPr>
           </a:p>
         </p:txBody>
@@ -1793,13 +1793,13 @@
                 <a:schemeClr val="dk1"/>
               </a:buClr>
               <a:buSzPts val="1018"/>
-              <a:buFont typeface="Arial"/>
+              <a:buFont typeface="Noto Sans CJK JP"/>
               <a:buNone/>
               <a:tabLst/>
               <a:defRPr lang="ja-JP">
-                <a:latin typeface="Arial"/>
-                <a:ea typeface="ＭＳ Ｐゴシック"/>
-                <a:cs typeface="Arial"/>
+                <a:latin typeface="Noto Sans"/>
+                <a:ea typeface="Noto Sans CJK JP"/>
+                <a:cs typeface="Noto Sans"/>
               </a:defRPr>
             </a:pPr>
             <a:r>
@@ -1807,9 +1807,9 @@
                 <a:solidFill>
                   <a:schemeClr val="accent2"/>
                 </a:solidFill>
-                <a:latin typeface="Arial"/>
-                <a:ea typeface="ＭＳ Ｐゴシック"/>
-                <a:cs typeface="Arial"/>
+                <a:latin typeface="Noto Sans"/>
+                <a:ea typeface="Noto Sans CJK JP"/>
+                <a:cs typeface="Noto Sans"/>
               </a:rPr>
               <a:t>2.</a:t>
             </a:r>
@@ -1818,9 +1818,9 @@
                 <a:solidFill>
                   <a:schemeClr val="accent2"/>
                 </a:solidFill>
-                <a:latin typeface="Arial"/>
-                <a:ea typeface="ＭＳ Ｐゴシック"/>
-                <a:cs typeface="Arial"/>
+                <a:latin typeface="Noto Sans"/>
+                <a:ea typeface="Noto Sans CJK JP"/>
+                <a:cs typeface="Noto Sans"/>
               </a:rPr>
               <a:t> </a:t>
             </a:r>
@@ -1829,9 +1829,9 @@
                 <a:solidFill>
                   <a:schemeClr val="dk1"/>
                 </a:solidFill>
-                <a:latin typeface="Arial"/>
-                <a:ea typeface="ＭＳ Ｐゴシック"/>
-                <a:cs typeface="Arial"/>
+                <a:latin typeface="Noto Sans"/>
+                <a:ea typeface="Noto Sans CJK JP"/>
+                <a:cs typeface="Noto Sans"/>
               </a:rPr>
               <a:t>Methodology</a:t>
             </a:r>
@@ -1839,9 +1839,9 @@
               <a:solidFill>
                 <a:schemeClr val="dk1"/>
               </a:solidFill>
-              <a:latin typeface="Arial"/>
-              <a:ea typeface="ＭＳ Ｐゴシック"/>
-              <a:cs typeface="Arial"/>
+              <a:latin typeface="Noto Sans"/>
+              <a:ea typeface="Noto Sans CJK JP"/>
+              <a:cs typeface="Noto Sans"/>
             </a:endParaRPr>
           </a:p>
         </p:txBody>
@@ -1885,13 +1885,13 @@
                 <a:schemeClr val="dk1"/>
               </a:buClr>
               <a:buSzPts val="1018"/>
-              <a:buFont typeface="Arial"/>
+              <a:buFont typeface="Noto Sans CJK JP"/>
               <a:buNone/>
               <a:tabLst/>
               <a:defRPr lang="ja-JP">
-                <a:latin typeface="Arial"/>
-                <a:ea typeface="ＭＳ Ｐゴシック"/>
-                <a:cs typeface="Arial"/>
+                <a:latin typeface="Noto Sans"/>
+                <a:ea typeface="Noto Sans CJK JP"/>
+                <a:cs typeface="Noto Sans"/>
               </a:defRPr>
             </a:pPr>
             <a:r>
@@ -1899,9 +1899,9 @@
                 <a:solidFill>
                   <a:schemeClr val="accent2"/>
                 </a:solidFill>
-                <a:latin typeface="Arial"/>
-                <a:ea typeface="ＭＳ Ｐゴシック"/>
-                <a:cs typeface="Arial"/>
+                <a:latin typeface="Noto Sans"/>
+                <a:ea typeface="Noto Sans CJK JP"/>
+                <a:cs typeface="Noto Sans"/>
               </a:rPr>
               <a:t>3.</a:t>
             </a:r>
@@ -1910,9 +1910,9 @@
                 <a:solidFill>
                   <a:schemeClr val="accent2"/>
                 </a:solidFill>
-                <a:latin typeface="Arial"/>
-                <a:ea typeface="ＭＳ Ｐゴシック"/>
-                <a:cs typeface="Arial"/>
+                <a:latin typeface="Noto Sans"/>
+                <a:ea typeface="Noto Sans CJK JP"/>
+                <a:cs typeface="Noto Sans"/>
               </a:rPr>
               <a:t> </a:t>
             </a:r>
@@ -1921,9 +1921,9 @@
                 <a:solidFill>
                   <a:schemeClr val="dk1"/>
                 </a:solidFill>
-                <a:latin typeface="Arial"/>
-                <a:ea typeface="ＭＳ Ｐゴシック"/>
-                <a:cs typeface="Arial"/>
+                <a:latin typeface="Noto Sans"/>
+                <a:ea typeface="Noto Sans CJK JP"/>
+                <a:cs typeface="Noto Sans"/>
               </a:rPr>
               <a:t>Classification Framework</a:t>
             </a:r>
@@ -1931,9 +1931,9 @@
               <a:solidFill>
                 <a:schemeClr val="dk1"/>
               </a:solidFill>
-              <a:latin typeface="Arial"/>
-              <a:ea typeface="ＭＳ Ｐゴシック"/>
-              <a:cs typeface="Arial"/>
+              <a:latin typeface="Noto Sans"/>
+              <a:ea typeface="Noto Sans CJK JP"/>
+              <a:cs typeface="Noto Sans"/>
             </a:endParaRPr>
           </a:p>
         </p:txBody>
@@ -1977,13 +1977,13 @@
                 <a:schemeClr val="dk1"/>
               </a:buClr>
               <a:buSzPts val="1018"/>
-              <a:buFont typeface="Arial"/>
+              <a:buFont typeface="Noto Sans CJK JP"/>
               <a:buNone/>
               <a:tabLst/>
               <a:defRPr lang="ja-JP">
-                <a:latin typeface="Arial"/>
-                <a:ea typeface="ＭＳ Ｐゴシック"/>
-                <a:cs typeface="Arial"/>
+                <a:latin typeface="Noto Sans"/>
+                <a:ea typeface="Noto Sans CJK JP"/>
+                <a:cs typeface="Noto Sans"/>
               </a:defRPr>
             </a:pPr>
             <a:r>
@@ -1991,9 +1991,9 @@
                 <a:solidFill>
                   <a:schemeClr val="accent2"/>
                 </a:solidFill>
-                <a:latin typeface="Arial"/>
-                <a:ea typeface="ＭＳ Ｐゴシック"/>
-                <a:cs typeface="Arial"/>
+                <a:latin typeface="Noto Sans"/>
+                <a:ea typeface="Noto Sans CJK JP"/>
+                <a:cs typeface="Noto Sans"/>
               </a:rPr>
               <a:t>4.</a:t>
             </a:r>
@@ -2002,9 +2002,9 @@
                 <a:solidFill>
                   <a:schemeClr val="accent2"/>
                 </a:solidFill>
-                <a:latin typeface="Arial"/>
-                <a:ea typeface="ＭＳ Ｐゴシック"/>
-                <a:cs typeface="Arial"/>
+                <a:latin typeface="Noto Sans"/>
+                <a:ea typeface="Noto Sans CJK JP"/>
+                <a:cs typeface="Noto Sans"/>
               </a:rPr>
               <a:t> </a:t>
             </a:r>
@@ -2013,9 +2013,9 @@
                 <a:solidFill>
                   <a:schemeClr val="dk1"/>
                 </a:solidFill>
-                <a:latin typeface="Arial"/>
-                <a:ea typeface="ＭＳ Ｐゴシック"/>
-                <a:cs typeface="Arial"/>
+                <a:latin typeface="Noto Sans"/>
+                <a:ea typeface="Noto Sans CJK JP"/>
+                <a:cs typeface="Noto Sans"/>
               </a:rPr>
               <a:t>Results &amp; Analysis</a:t>
             </a:r>
@@ -2023,9 +2023,9 @@
               <a:solidFill>
                 <a:schemeClr val="dk1"/>
               </a:solidFill>
-              <a:latin typeface="Arial"/>
-              <a:ea typeface="ＭＳ Ｐゴシック"/>
-              <a:cs typeface="Arial"/>
+              <a:latin typeface="Noto Sans"/>
+              <a:ea typeface="Noto Sans CJK JP"/>
+              <a:cs typeface="Noto Sans"/>
             </a:endParaRPr>
           </a:p>
         </p:txBody>
@@ -2068,9 +2068,9 @@
               <a:solidFill>
                 <a:schemeClr val="dk1"/>
               </a:solidFill>
-              <a:latin typeface="Arial"/>
-              <a:ea typeface="ＭＳ Ｐゴシック"/>
-              <a:cs typeface="Arial"/>
+              <a:latin typeface="Noto Sans"/>
+              <a:ea typeface="Noto Sans CJK JP"/>
+              <a:cs typeface="Noto Sans"/>
             </a:endParaRPr>
           </a:p>
         </p:txBody>
@@ -2114,13 +2114,13 @@
                 <a:schemeClr val="dk1"/>
               </a:buClr>
               <a:buSzPts val="1018"/>
-              <a:buFont typeface="Arial"/>
+              <a:buFont typeface="Noto Sans CJK JP"/>
               <a:buNone/>
               <a:tabLst/>
               <a:defRPr lang="ja-JP">
-                <a:latin typeface="Arial"/>
-                <a:ea typeface="ＭＳ Ｐゴシック"/>
-                <a:cs typeface="Arial"/>
+                <a:latin typeface="Noto Sans"/>
+                <a:ea typeface="Noto Sans CJK JP"/>
+                <a:cs typeface="Noto Sans"/>
               </a:defRPr>
             </a:pPr>
             <a:r>
@@ -2128,9 +2128,9 @@
                 <a:solidFill>
                   <a:schemeClr val="accent2"/>
                 </a:solidFill>
-                <a:latin typeface="Arial"/>
-                <a:ea typeface="ＭＳ Ｐゴシック"/>
-                <a:cs typeface="Arial"/>
+                <a:latin typeface="Noto Sans"/>
+                <a:ea typeface="Noto Sans CJK JP"/>
+                <a:cs typeface="Noto Sans"/>
               </a:rPr>
               <a:t>5.</a:t>
             </a:r>
@@ -2139,9 +2139,9 @@
                 <a:solidFill>
                   <a:schemeClr val="accent2"/>
                 </a:solidFill>
-                <a:latin typeface="Arial"/>
-                <a:ea typeface="ＭＳ Ｐゴシック"/>
-                <a:cs typeface="Arial"/>
+                <a:latin typeface="Noto Sans"/>
+                <a:ea typeface="Noto Sans CJK JP"/>
+                <a:cs typeface="Noto Sans"/>
               </a:rPr>
               <a:t> </a:t>
             </a:r>
@@ -2150,9 +2150,9 @@
                 <a:solidFill>
                   <a:schemeClr val="dk1"/>
                 </a:solidFill>
-                <a:latin typeface="Arial"/>
-                <a:ea typeface="ＭＳ Ｐゴシック"/>
-                <a:cs typeface="Arial"/>
+                <a:latin typeface="Noto Sans"/>
+                <a:ea typeface="Noto Sans CJK JP"/>
+                <a:cs typeface="Noto Sans"/>
               </a:rPr>
               <a:t>Conclusions and future work</a:t>
             </a:r>
@@ -2160,9 +2160,9 @@
               <a:solidFill>
                 <a:schemeClr val="dk1"/>
               </a:solidFill>
-              <a:latin typeface="Arial"/>
-              <a:ea typeface="ＭＳ Ｐゴシック"/>
-              <a:cs typeface="Arial"/>
+              <a:latin typeface="Noto Sans"/>
+              <a:ea typeface="Noto Sans CJK JP"/>
+              <a:cs typeface="Noto Sans"/>
             </a:endParaRPr>
           </a:p>
         </p:txBody>
@@ -2196,16 +2196,16 @@
                 <a:solidFill>
                   <a:schemeClr val="lt1"/>
                 </a:solidFill>
-                <a:latin typeface="Arial"/>
-                <a:ea typeface="ＭＳ Ｐゴシック"/>
-                <a:cs typeface="Arial"/>
+                <a:latin typeface="Noto Sans"/>
+                <a:ea typeface="Noto Sans CJK JP"/>
+                <a:cs typeface="Noto Sans"/>
               </a:rPr>
               <a:t>‹#›</a:t>
             </a:fld>
             <a:endParaRPr lang="ja-JP" sz="1800" b="1">
-              <a:latin typeface="Arial"/>
-              <a:ea typeface="ＭＳ Ｐゴシック"/>
-              <a:cs typeface="Arial"/>
+              <a:latin typeface="Noto Sans"/>
+              <a:ea typeface="Noto Sans CJK JP"/>
+              <a:cs typeface="Noto Sans"/>
             </a:endParaRPr>
           </a:p>
         </p:txBody>
@@ -2275,9 +2275,9 @@
               <a:buNone/>
             </a:pPr>
             <a:endParaRPr lang="ja-JP">
-              <a:latin typeface="Arial"/>
-              <a:ea typeface="ＭＳ Ｐゴシック"/>
-              <a:cs typeface="Arial"/>
+              <a:latin typeface="Noto Sans"/>
+              <a:ea typeface="Noto Sans CJK JP"/>
+              <a:cs typeface="Noto Sans"/>
             </a:endParaRPr>
           </a:p>
         </p:txBody>
@@ -2322,9 +2322,9 @@
                 <a:solidFill>
                   <a:schemeClr val="dk1"/>
                 </a:solidFill>
-                <a:latin typeface="Arial"/>
-                <a:ea typeface="ＭＳ Ｐゴシック"/>
-                <a:cs typeface="Arial"/>
+                <a:latin typeface="Noto Sans"/>
+                <a:ea typeface="Noto Sans CJK JP"/>
+                <a:cs typeface="Noto Sans"/>
               </a:defRPr>
             </a:lvl1pPr>
             <a:lvl2pPr lvl="1">
@@ -2337,9 +2337,9 @@
               <a:buSzPts val="2800"/>
               <a:buNone/>
               <a:defRPr lang="ja-JP">
-                <a:latin typeface="Arial"/>
-                <a:ea typeface="ＭＳ Ｐゴシック"/>
-                <a:cs typeface="Arial"/>
+                <a:latin typeface="Noto Sans"/>
+                <a:ea typeface="Noto Sans CJK JP"/>
+                <a:cs typeface="Noto Sans"/>
               </a:defRPr>
             </a:lvl2pPr>
             <a:lvl3pPr lvl="2">
@@ -2352,9 +2352,9 @@
               <a:buSzPts val="2800"/>
               <a:buNone/>
               <a:defRPr lang="ja-JP">
-                <a:latin typeface="Arial"/>
-                <a:ea typeface="ＭＳ Ｐゴシック"/>
-                <a:cs typeface="Arial"/>
+                <a:latin typeface="Noto Sans"/>
+                <a:ea typeface="Noto Sans CJK JP"/>
+                <a:cs typeface="Noto Sans"/>
               </a:defRPr>
             </a:lvl3pPr>
             <a:lvl4pPr lvl="3">
@@ -2367,9 +2367,9 @@
               <a:buSzPts val="2800"/>
               <a:buNone/>
               <a:defRPr lang="ja-JP">
-                <a:latin typeface="Arial"/>
-                <a:ea typeface="ＭＳ Ｐゴシック"/>
-                <a:cs typeface="Arial"/>
+                <a:latin typeface="Noto Sans"/>
+                <a:ea typeface="Noto Sans CJK JP"/>
+                <a:cs typeface="Noto Sans"/>
               </a:defRPr>
             </a:lvl4pPr>
             <a:lvl5pPr lvl="4">
@@ -2382,9 +2382,9 @@
               <a:buSzPts val="2800"/>
               <a:buNone/>
               <a:defRPr lang="ja-JP">
-                <a:latin typeface="Arial"/>
-                <a:ea typeface="ＭＳ Ｐゴシック"/>
-                <a:cs typeface="Arial"/>
+                <a:latin typeface="Noto Sans"/>
+                <a:ea typeface="Noto Sans CJK JP"/>
+                <a:cs typeface="Noto Sans"/>
               </a:defRPr>
             </a:lvl5pPr>
             <a:lvl6pPr lvl="5">
@@ -2397,9 +2397,9 @@
               <a:buSzPts val="2800"/>
               <a:buNone/>
               <a:defRPr lang="ja-JP">
-                <a:latin typeface="Arial"/>
-                <a:ea typeface="ＭＳ Ｐゴシック"/>
-                <a:cs typeface="Arial"/>
+                <a:latin typeface="Noto Sans"/>
+                <a:ea typeface="Noto Sans CJK JP"/>
+                <a:cs typeface="Noto Sans"/>
               </a:defRPr>
             </a:lvl6pPr>
             <a:lvl7pPr lvl="6">
@@ -2412,9 +2412,9 @@
               <a:buSzPts val="2800"/>
               <a:buNone/>
               <a:defRPr lang="ja-JP">
-                <a:latin typeface="Arial"/>
-                <a:ea typeface="ＭＳ Ｐゴシック"/>
-                <a:cs typeface="Arial"/>
+                <a:latin typeface="Noto Sans"/>
+                <a:ea typeface="Noto Sans CJK JP"/>
+                <a:cs typeface="Noto Sans"/>
               </a:defRPr>
             </a:lvl7pPr>
             <a:lvl8pPr lvl="7">
@@ -2427,9 +2427,9 @@
               <a:buSzPts val="2800"/>
               <a:buNone/>
               <a:defRPr lang="ja-JP">
-                <a:latin typeface="Arial"/>
-                <a:ea typeface="ＭＳ Ｐゴシック"/>
-                <a:cs typeface="Arial"/>
+                <a:latin typeface="Noto Sans"/>
+                <a:ea typeface="Noto Sans CJK JP"/>
+                <a:cs typeface="Noto Sans"/>
               </a:defRPr>
             </a:lvl8pPr>
             <a:lvl9pPr lvl="8">
@@ -2442,17 +2442,17 @@
               <a:buSzPts val="2800"/>
               <a:buNone/>
               <a:defRPr lang="ja-JP">
-                <a:latin typeface="Arial"/>
-                <a:ea typeface="ＭＳ Ｐゴシック"/>
-                <a:cs typeface="Arial"/>
+                <a:latin typeface="Noto Sans"/>
+                <a:ea typeface="Noto Sans CJK JP"/>
+                <a:cs typeface="Noto Sans"/>
               </a:defRPr>
             </a:lvl9pPr>
           </a:lstStyle>
           <a:p>
             <a:endParaRPr lang="ja-JP">
-              <a:latin typeface="Arial"/>
-              <a:ea typeface="ＭＳ Ｐゴシック"/>
-              <a:cs typeface="Arial"/>
+              <a:latin typeface="Noto Sans"/>
+              <a:ea typeface="Noto Sans CJK JP"/>
+              <a:cs typeface="Noto Sans"/>
             </a:endParaRPr>
           </a:p>
         </p:txBody>
@@ -2497,9 +2497,9 @@
                 <a:solidFill>
                   <a:srgbClr val="303437"/>
                 </a:solidFill>
-                <a:latin typeface="Arial"/>
-                <a:ea typeface="ＭＳ Ｐゴシック"/>
-                <a:cs typeface="Arial"/>
+                <a:latin typeface="Noto Sans"/>
+                <a:ea typeface="Noto Sans CJK JP"/>
+                <a:cs typeface="Noto Sans"/>
               </a:defRPr>
             </a:lvl1pPr>
             <a:lvl2pPr marL="914400" lvl="1" indent="-355600">
@@ -2518,9 +2518,9 @@
                 <a:solidFill>
                   <a:srgbClr val="303437"/>
                 </a:solidFill>
-                <a:latin typeface="Arial"/>
-                <a:ea typeface="ＭＳ Ｐゴシック"/>
-                <a:cs typeface="Arial"/>
+                <a:latin typeface="Noto Sans"/>
+                <a:ea typeface="Noto Sans CJK JP"/>
+                <a:cs typeface="Noto Sans"/>
               </a:defRPr>
             </a:lvl2pPr>
             <a:lvl3pPr marL="1371600" lvl="2" indent="-355600">
@@ -2539,9 +2539,9 @@
                 <a:solidFill>
                   <a:srgbClr val="303437"/>
                 </a:solidFill>
-                <a:latin typeface="Arial"/>
-                <a:ea typeface="ＭＳ Ｐゴシック"/>
-                <a:cs typeface="Arial"/>
+                <a:latin typeface="Noto Sans"/>
+                <a:ea typeface="Noto Sans CJK JP"/>
+                <a:cs typeface="Noto Sans"/>
               </a:defRPr>
             </a:lvl3pPr>
             <a:lvl4pPr marL="1828800" lvl="3" indent="-368300">
@@ -2560,9 +2560,9 @@
                 <a:solidFill>
                   <a:srgbClr val="303437"/>
                 </a:solidFill>
-                <a:latin typeface="Arial"/>
-                <a:ea typeface="ＭＳ Ｐゴシック"/>
-                <a:cs typeface="Arial"/>
+                <a:latin typeface="Noto Sans"/>
+                <a:ea typeface="Noto Sans CJK JP"/>
+                <a:cs typeface="Noto Sans"/>
               </a:defRPr>
             </a:lvl4pPr>
             <a:lvl5pPr marL="2286000" lvl="4" indent="-355600">
@@ -2581,9 +2581,9 @@
                 <a:solidFill>
                   <a:srgbClr val="303437"/>
                 </a:solidFill>
-                <a:latin typeface="Arial"/>
-                <a:ea typeface="ＭＳ Ｐゴシック"/>
-                <a:cs typeface="Arial"/>
+                <a:latin typeface="Noto Sans"/>
+                <a:ea typeface="Noto Sans CJK JP"/>
+                <a:cs typeface="Noto Sans"/>
               </a:defRPr>
             </a:lvl5pPr>
             <a:lvl6pPr marL="2743200" lvl="5" indent="-355600">
@@ -2602,9 +2602,9 @@
                 <a:solidFill>
                   <a:srgbClr val="303437"/>
                 </a:solidFill>
-                <a:latin typeface="Arial"/>
-                <a:ea typeface="ＭＳ Ｐゴシック"/>
-                <a:cs typeface="Arial"/>
+                <a:latin typeface="Noto Sans"/>
+                <a:ea typeface="Noto Sans CJK JP"/>
+                <a:cs typeface="Noto Sans"/>
               </a:defRPr>
             </a:lvl6pPr>
             <a:lvl7pPr marL="3200400" lvl="6" indent="-355600">
@@ -2623,9 +2623,9 @@
                 <a:solidFill>
                   <a:srgbClr val="303437"/>
                 </a:solidFill>
-                <a:latin typeface="Arial"/>
-                <a:ea typeface="ＭＳ Ｐゴシック"/>
-                <a:cs typeface="Arial"/>
+                <a:latin typeface="Noto Sans"/>
+                <a:ea typeface="Noto Sans CJK JP"/>
+                <a:cs typeface="Noto Sans"/>
               </a:defRPr>
             </a:lvl7pPr>
             <a:lvl8pPr marL="3657600" lvl="7" indent="-355600">
@@ -2644,9 +2644,9 @@
                 <a:solidFill>
                   <a:srgbClr val="303437"/>
                 </a:solidFill>
-                <a:latin typeface="Arial"/>
-                <a:ea typeface="ＭＳ Ｐゴシック"/>
-                <a:cs typeface="Arial"/>
+                <a:latin typeface="Noto Sans"/>
+                <a:ea typeface="Noto Sans CJK JP"/>
+                <a:cs typeface="Noto Sans"/>
               </a:defRPr>
             </a:lvl8pPr>
             <a:lvl9pPr marL="4114800" lvl="8" indent="-355600">
@@ -2665,17 +2665,17 @@
                 <a:solidFill>
                   <a:srgbClr val="303437"/>
                 </a:solidFill>
-                <a:latin typeface="Arial"/>
-                <a:ea typeface="ＭＳ Ｐゴシック"/>
-                <a:cs typeface="Arial"/>
+                <a:latin typeface="Noto Sans"/>
+                <a:ea typeface="Noto Sans CJK JP"/>
+                <a:cs typeface="Noto Sans"/>
               </a:defRPr>
             </a:lvl9pPr>
           </a:lstStyle>
           <a:p>
             <a:endParaRPr lang="ja-JP">
-              <a:latin typeface="Arial"/>
-              <a:ea typeface="ＭＳ Ｐゴシック"/>
-              <a:cs typeface="Arial"/>
+              <a:latin typeface="Noto Sans"/>
+              <a:ea typeface="Noto Sans CJK JP"/>
+              <a:cs typeface="Noto Sans"/>
             </a:endParaRPr>
           </a:p>
         </p:txBody>
@@ -2723,9 +2723,9 @@
                 <a:solidFill>
                   <a:schemeClr val="lt1"/>
                 </a:solidFill>
-                <a:latin typeface="Arial"/>
-                <a:ea typeface="ＭＳ Ｐゴシック"/>
-                <a:cs typeface="Arial"/>
+                <a:latin typeface="Noto Sans"/>
+                <a:ea typeface="Noto Sans CJK JP"/>
+                <a:cs typeface="Noto Sans"/>
               </a:defRPr>
             </a:lvl1pPr>
             <a:lvl2pPr lvl="1">
@@ -2738,9 +2738,9 @@
               <a:buSzPts val="2800"/>
               <a:buNone/>
               <a:defRPr lang="ja-JP">
-                <a:latin typeface="Arial"/>
-                <a:ea typeface="ＭＳ Ｐゴシック"/>
-                <a:cs typeface="Arial"/>
+                <a:latin typeface="Noto Sans"/>
+                <a:ea typeface="Noto Sans CJK JP"/>
+                <a:cs typeface="Noto Sans"/>
               </a:defRPr>
             </a:lvl2pPr>
             <a:lvl3pPr lvl="2">
@@ -2753,9 +2753,9 @@
               <a:buSzPts val="2800"/>
               <a:buNone/>
               <a:defRPr lang="ja-JP">
-                <a:latin typeface="Arial"/>
-                <a:ea typeface="ＭＳ Ｐゴシック"/>
-                <a:cs typeface="Arial"/>
+                <a:latin typeface="Noto Sans"/>
+                <a:ea typeface="Noto Sans CJK JP"/>
+                <a:cs typeface="Noto Sans"/>
               </a:defRPr>
             </a:lvl3pPr>
             <a:lvl4pPr lvl="3">
@@ -2768,9 +2768,9 @@
               <a:buSzPts val="2800"/>
               <a:buNone/>
               <a:defRPr lang="ja-JP">
-                <a:latin typeface="Arial"/>
-                <a:ea typeface="ＭＳ Ｐゴシック"/>
-                <a:cs typeface="Arial"/>
+                <a:latin typeface="Noto Sans"/>
+                <a:ea typeface="Noto Sans CJK JP"/>
+                <a:cs typeface="Noto Sans"/>
               </a:defRPr>
             </a:lvl4pPr>
             <a:lvl5pPr lvl="4">
@@ -2783,9 +2783,9 @@
               <a:buSzPts val="2800"/>
               <a:buNone/>
               <a:defRPr lang="ja-JP">
-                <a:latin typeface="Arial"/>
-                <a:ea typeface="ＭＳ Ｐゴシック"/>
-                <a:cs typeface="Arial"/>
+                <a:latin typeface="Noto Sans"/>
+                <a:ea typeface="Noto Sans CJK JP"/>
+                <a:cs typeface="Noto Sans"/>
               </a:defRPr>
             </a:lvl5pPr>
             <a:lvl6pPr lvl="5">
@@ -2798,9 +2798,9 @@
               <a:buSzPts val="2800"/>
               <a:buNone/>
               <a:defRPr lang="ja-JP">
-                <a:latin typeface="Arial"/>
-                <a:ea typeface="ＭＳ Ｐゴシック"/>
-                <a:cs typeface="Arial"/>
+                <a:latin typeface="Noto Sans"/>
+                <a:ea typeface="Noto Sans CJK JP"/>
+                <a:cs typeface="Noto Sans"/>
               </a:defRPr>
             </a:lvl6pPr>
             <a:lvl7pPr lvl="6">
@@ -2813,9 +2813,9 @@
               <a:buSzPts val="2800"/>
               <a:buNone/>
               <a:defRPr lang="ja-JP">
-                <a:latin typeface="Arial"/>
-                <a:ea typeface="ＭＳ Ｐゴシック"/>
-                <a:cs typeface="Arial"/>
+                <a:latin typeface="Noto Sans"/>
+                <a:ea typeface="Noto Sans CJK JP"/>
+                <a:cs typeface="Noto Sans"/>
               </a:defRPr>
             </a:lvl7pPr>
             <a:lvl8pPr lvl="7">
@@ -2828,9 +2828,9 @@
               <a:buSzPts val="2800"/>
               <a:buNone/>
               <a:defRPr lang="ja-JP">
-                <a:latin typeface="Arial"/>
-                <a:ea typeface="ＭＳ Ｐゴシック"/>
-                <a:cs typeface="Arial"/>
+                <a:latin typeface="Noto Sans"/>
+                <a:ea typeface="Noto Sans CJK JP"/>
+                <a:cs typeface="Noto Sans"/>
               </a:defRPr>
             </a:lvl8pPr>
             <a:lvl9pPr lvl="8">
@@ -2843,9 +2843,9 @@
               <a:buSzPts val="2800"/>
               <a:buNone/>
               <a:defRPr lang="ja-JP">
-                <a:latin typeface="Arial"/>
-                <a:ea typeface="ＭＳ Ｐゴシック"/>
-                <a:cs typeface="Arial"/>
+                <a:latin typeface="Noto Sans"/>
+                <a:ea typeface="Noto Sans CJK JP"/>
+                <a:cs typeface="Noto Sans"/>
               </a:defRPr>
             </a:lvl9pPr>
           </a:lstStyle>
@@ -2862,9 +2862,9 @@
               </a:spcAft>
             </a:pPr>
             <a:endParaRPr lang="ja-JP">
-              <a:latin typeface="Arial"/>
-              <a:ea typeface="ＭＳ Ｐゴシック"/>
-              <a:cs typeface="Arial"/>
+              <a:latin typeface="Noto Sans"/>
+              <a:ea typeface="Noto Sans CJK JP"/>
+              <a:cs typeface="Noto Sans"/>
             </a:endParaRPr>
           </a:p>
         </p:txBody>
@@ -2898,16 +2898,16 @@
                 <a:solidFill>
                   <a:schemeClr val="lt1"/>
                 </a:solidFill>
-                <a:latin typeface="Arial"/>
-                <a:ea typeface="ＭＳ Ｐゴシック"/>
-                <a:cs typeface="Arial"/>
+                <a:latin typeface="Noto Sans"/>
+                <a:ea typeface="Noto Sans CJK JP"/>
+                <a:cs typeface="Noto Sans"/>
               </a:rPr>
               <a:t>‹#›</a:t>
             </a:fld>
             <a:endParaRPr lang="ja-JP" sz="1800" b="1" dirty="0">
-              <a:latin typeface="Arial"/>
-              <a:ea typeface="ＭＳ Ｐゴシック"/>
-              <a:cs typeface="Arial"/>
+              <a:latin typeface="Noto Sans"/>
+              <a:ea typeface="Noto Sans CJK JP"/>
+              <a:cs typeface="Noto Sans"/>
             </a:endParaRPr>
           </a:p>
         </p:txBody>
@@ -2977,9 +2977,9 @@
               <a:buNone/>
             </a:pPr>
             <a:endParaRPr lang="ja-JP">
-              <a:latin typeface="Arial"/>
-              <a:ea typeface="ＭＳ Ｐゴシック"/>
-              <a:cs typeface="Arial"/>
+              <a:latin typeface="Noto Sans"/>
+              <a:ea typeface="Noto Sans CJK JP"/>
+              <a:cs typeface="Noto Sans"/>
             </a:endParaRPr>
           </a:p>
         </p:txBody>
@@ -3024,9 +3024,9 @@
                 <a:solidFill>
                   <a:schemeClr val="dk1"/>
                 </a:solidFill>
-                <a:latin typeface="Arial"/>
-                <a:ea typeface="ＭＳ Ｐゴシック"/>
-                <a:cs typeface="Arial"/>
+                <a:latin typeface="Noto Sans"/>
+                <a:ea typeface="Noto Sans CJK JP"/>
+                <a:cs typeface="Noto Sans"/>
               </a:defRPr>
             </a:lvl1pPr>
             <a:lvl2pPr lvl="1" rtl="0">
@@ -3039,9 +3039,9 @@
               <a:buSzPts val="2800"/>
               <a:buNone/>
               <a:defRPr lang="ja-JP">
-                <a:latin typeface="Arial"/>
-                <a:ea typeface="ＭＳ Ｐゴシック"/>
-                <a:cs typeface="Arial"/>
+                <a:latin typeface="Noto Sans"/>
+                <a:ea typeface="Noto Sans CJK JP"/>
+                <a:cs typeface="Noto Sans"/>
               </a:defRPr>
             </a:lvl2pPr>
             <a:lvl3pPr lvl="2" rtl="0">
@@ -3054,9 +3054,9 @@
               <a:buSzPts val="2800"/>
               <a:buNone/>
               <a:defRPr lang="ja-JP">
-                <a:latin typeface="Arial"/>
-                <a:ea typeface="ＭＳ Ｐゴシック"/>
-                <a:cs typeface="Arial"/>
+                <a:latin typeface="Noto Sans"/>
+                <a:ea typeface="Noto Sans CJK JP"/>
+                <a:cs typeface="Noto Sans"/>
               </a:defRPr>
             </a:lvl3pPr>
             <a:lvl4pPr lvl="3" rtl="0">
@@ -3069,9 +3069,9 @@
               <a:buSzPts val="2800"/>
               <a:buNone/>
               <a:defRPr lang="ja-JP">
-                <a:latin typeface="Arial"/>
-                <a:ea typeface="ＭＳ Ｐゴシック"/>
-                <a:cs typeface="Arial"/>
+                <a:latin typeface="Noto Sans"/>
+                <a:ea typeface="Noto Sans CJK JP"/>
+                <a:cs typeface="Noto Sans"/>
               </a:defRPr>
             </a:lvl4pPr>
             <a:lvl5pPr lvl="4" rtl="0">
@@ -3084,9 +3084,9 @@
               <a:buSzPts val="2800"/>
               <a:buNone/>
               <a:defRPr lang="ja-JP">
-                <a:latin typeface="Arial"/>
-                <a:ea typeface="ＭＳ Ｐゴシック"/>
-                <a:cs typeface="Arial"/>
+                <a:latin typeface="Noto Sans"/>
+                <a:ea typeface="Noto Sans CJK JP"/>
+                <a:cs typeface="Noto Sans"/>
               </a:defRPr>
             </a:lvl5pPr>
             <a:lvl6pPr lvl="5" rtl="0">
@@ -3099,9 +3099,9 @@
               <a:buSzPts val="2800"/>
               <a:buNone/>
               <a:defRPr lang="ja-JP">
-                <a:latin typeface="Arial"/>
-                <a:ea typeface="ＭＳ Ｐゴシック"/>
-                <a:cs typeface="Arial"/>
+                <a:latin typeface="Noto Sans"/>
+                <a:ea typeface="Noto Sans CJK JP"/>
+                <a:cs typeface="Noto Sans"/>
               </a:defRPr>
             </a:lvl6pPr>
             <a:lvl7pPr lvl="6" rtl="0">
@@ -3114,9 +3114,9 @@
               <a:buSzPts val="2800"/>
               <a:buNone/>
               <a:defRPr lang="ja-JP">
-                <a:latin typeface="Arial"/>
-                <a:ea typeface="ＭＳ Ｐゴシック"/>
-                <a:cs typeface="Arial"/>
+                <a:latin typeface="Noto Sans"/>
+                <a:ea typeface="Noto Sans CJK JP"/>
+                <a:cs typeface="Noto Sans"/>
               </a:defRPr>
             </a:lvl7pPr>
             <a:lvl8pPr lvl="7" rtl="0">
@@ -3129,9 +3129,9 @@
               <a:buSzPts val="2800"/>
               <a:buNone/>
               <a:defRPr lang="ja-JP">
-                <a:latin typeface="Arial"/>
-                <a:ea typeface="ＭＳ Ｐゴシック"/>
-                <a:cs typeface="Arial"/>
+                <a:latin typeface="Noto Sans"/>
+                <a:ea typeface="Noto Sans CJK JP"/>
+                <a:cs typeface="Noto Sans"/>
               </a:defRPr>
             </a:lvl8pPr>
             <a:lvl9pPr lvl="8" rtl="0">
@@ -3144,17 +3144,17 @@
               <a:buSzPts val="2800"/>
               <a:buNone/>
               <a:defRPr lang="ja-JP">
-                <a:latin typeface="Arial"/>
-                <a:ea typeface="ＭＳ Ｐゴシック"/>
-                <a:cs typeface="Arial"/>
+                <a:latin typeface="Noto Sans"/>
+                <a:ea typeface="Noto Sans CJK JP"/>
+                <a:cs typeface="Noto Sans"/>
               </a:defRPr>
             </a:lvl9pPr>
           </a:lstStyle>
           <a:p>
             <a:endParaRPr lang="ja-JP">
-              <a:latin typeface="Arial"/>
-              <a:ea typeface="ＭＳ Ｐゴシック"/>
-              <a:cs typeface="Arial"/>
+              <a:latin typeface="Noto Sans"/>
+              <a:ea typeface="Noto Sans CJK JP"/>
+              <a:cs typeface="Noto Sans"/>
             </a:endParaRPr>
           </a:p>
         </p:txBody>
@@ -3202,9 +3202,9 @@
                 <a:solidFill>
                   <a:schemeClr val="lt1"/>
                 </a:solidFill>
-                <a:latin typeface="Arial"/>
-                <a:ea typeface="ＭＳ Ｐゴシック"/>
-                <a:cs typeface="Arial"/>
+                <a:latin typeface="Noto Sans"/>
+                <a:ea typeface="Noto Sans CJK JP"/>
+                <a:cs typeface="Noto Sans"/>
               </a:defRPr>
             </a:lvl1pPr>
             <a:lvl2pPr lvl="1" rtl="0">
@@ -3217,9 +3217,9 @@
               <a:buSzPts val="2800"/>
               <a:buNone/>
               <a:defRPr lang="ja-JP">
-                <a:latin typeface="Arial"/>
-                <a:ea typeface="ＭＳ Ｐゴシック"/>
-                <a:cs typeface="Arial"/>
+                <a:latin typeface="Noto Sans"/>
+                <a:ea typeface="Noto Sans CJK JP"/>
+                <a:cs typeface="Noto Sans"/>
               </a:defRPr>
             </a:lvl2pPr>
             <a:lvl3pPr lvl="2" rtl="0">
@@ -3232,9 +3232,9 @@
               <a:buSzPts val="2800"/>
               <a:buNone/>
               <a:defRPr lang="ja-JP">
-                <a:latin typeface="Arial"/>
-                <a:ea typeface="ＭＳ Ｐゴシック"/>
-                <a:cs typeface="Arial"/>
+                <a:latin typeface="Noto Sans"/>
+                <a:ea typeface="Noto Sans CJK JP"/>
+                <a:cs typeface="Noto Sans"/>
               </a:defRPr>
             </a:lvl3pPr>
             <a:lvl4pPr lvl="3" rtl="0">
@@ -3247,9 +3247,9 @@
               <a:buSzPts val="2800"/>
               <a:buNone/>
               <a:defRPr lang="ja-JP">
-                <a:latin typeface="Arial"/>
-                <a:ea typeface="ＭＳ Ｐゴシック"/>
-                <a:cs typeface="Arial"/>
+                <a:latin typeface="Noto Sans"/>
+                <a:ea typeface="Noto Sans CJK JP"/>
+                <a:cs typeface="Noto Sans"/>
               </a:defRPr>
             </a:lvl4pPr>
             <a:lvl5pPr lvl="4" rtl="0">
@@ -3262,9 +3262,9 @@
               <a:buSzPts val="2800"/>
               <a:buNone/>
               <a:defRPr lang="ja-JP">
-                <a:latin typeface="Arial"/>
-                <a:ea typeface="ＭＳ Ｐゴシック"/>
-                <a:cs typeface="Arial"/>
+                <a:latin typeface="Noto Sans"/>
+                <a:ea typeface="Noto Sans CJK JP"/>
+                <a:cs typeface="Noto Sans"/>
               </a:defRPr>
             </a:lvl5pPr>
             <a:lvl6pPr lvl="5" rtl="0">
@@ -3277,9 +3277,9 @@
               <a:buSzPts val="2800"/>
               <a:buNone/>
               <a:defRPr lang="ja-JP">
-                <a:latin typeface="Arial"/>
-                <a:ea typeface="ＭＳ Ｐゴシック"/>
-                <a:cs typeface="Arial"/>
+                <a:latin typeface="Noto Sans"/>
+                <a:ea typeface="Noto Sans CJK JP"/>
+                <a:cs typeface="Noto Sans"/>
               </a:defRPr>
             </a:lvl6pPr>
             <a:lvl7pPr lvl="6" rtl="0">
@@ -3292,9 +3292,9 @@
               <a:buSzPts val="2800"/>
               <a:buNone/>
               <a:defRPr lang="ja-JP">
-                <a:latin typeface="Arial"/>
-                <a:ea typeface="ＭＳ Ｐゴシック"/>
-                <a:cs typeface="Arial"/>
+                <a:latin typeface="Noto Sans"/>
+                <a:ea typeface="Noto Sans CJK JP"/>
+                <a:cs typeface="Noto Sans"/>
               </a:defRPr>
             </a:lvl7pPr>
             <a:lvl8pPr lvl="7" rtl="0">
@@ -3307,9 +3307,9 @@
               <a:buSzPts val="2800"/>
               <a:buNone/>
               <a:defRPr lang="ja-JP">
-                <a:latin typeface="Arial"/>
-                <a:ea typeface="ＭＳ Ｐゴシック"/>
-                <a:cs typeface="Arial"/>
+                <a:latin typeface="Noto Sans"/>
+                <a:ea typeface="Noto Sans CJK JP"/>
+                <a:cs typeface="Noto Sans"/>
               </a:defRPr>
             </a:lvl8pPr>
             <a:lvl9pPr lvl="8" rtl="0">
@@ -3322,9 +3322,9 @@
               <a:buSzPts val="2800"/>
               <a:buNone/>
               <a:defRPr lang="ja-JP">
-                <a:latin typeface="Arial"/>
-                <a:ea typeface="ＭＳ Ｐゴシック"/>
-                <a:cs typeface="Arial"/>
+                <a:latin typeface="Noto Sans"/>
+                <a:ea typeface="Noto Sans CJK JP"/>
+                <a:cs typeface="Noto Sans"/>
               </a:defRPr>
             </a:lvl9pPr>
           </a:lstStyle>
@@ -3341,9 +3341,9 @@
               </a:spcAft>
             </a:pPr>
             <a:endParaRPr lang="ja-JP">
-              <a:latin typeface="Arial"/>
-              <a:ea typeface="ＭＳ Ｐゴシック"/>
-              <a:cs typeface="Arial"/>
+              <a:latin typeface="Noto Sans"/>
+              <a:ea typeface="Noto Sans CJK JP"/>
+              <a:cs typeface="Noto Sans"/>
             </a:endParaRPr>
           </a:p>
         </p:txBody>
@@ -3377,16 +3377,16 @@
                 <a:solidFill>
                   <a:schemeClr val="lt1"/>
                 </a:solidFill>
-                <a:latin typeface="Arial"/>
-                <a:ea typeface="ＭＳ Ｐゴシック"/>
-                <a:cs typeface="Arial"/>
+                <a:latin typeface="Noto Sans"/>
+                <a:ea typeface="Noto Sans CJK JP"/>
+                <a:cs typeface="Noto Sans"/>
               </a:rPr>
               <a:t>‹#›</a:t>
             </a:fld>
             <a:endParaRPr lang="ja-JP" sz="1800" b="1">
-              <a:latin typeface="Arial"/>
-              <a:ea typeface="ＭＳ Ｐゴシック"/>
-              <a:cs typeface="Arial"/>
+              <a:latin typeface="Noto Sans"/>
+              <a:ea typeface="Noto Sans CJK JP"/>
+              <a:cs typeface="Noto Sans"/>
             </a:endParaRPr>
           </a:p>
         </p:txBody>
@@ -3456,9 +3456,9 @@
               <a:buNone/>
             </a:pPr>
             <a:endParaRPr lang="ja-JP">
-              <a:latin typeface="Arial"/>
-              <a:ea typeface="ＭＳ Ｐゴシック"/>
-              <a:cs typeface="Arial"/>
+              <a:latin typeface="Noto Sans"/>
+              <a:ea typeface="Noto Sans CJK JP"/>
+              <a:cs typeface="Noto Sans"/>
             </a:endParaRPr>
           </a:p>
         </p:txBody>
@@ -3503,9 +3503,9 @@
                 <a:solidFill>
                   <a:schemeClr val="dk1"/>
                 </a:solidFill>
-                <a:latin typeface="Arial"/>
-                <a:ea typeface="ＭＳ Ｐゴシック"/>
-                <a:cs typeface="Arial"/>
+                <a:latin typeface="Noto Sans"/>
+                <a:ea typeface="Noto Sans CJK JP"/>
+                <a:cs typeface="Noto Sans"/>
               </a:defRPr>
             </a:lvl1pPr>
             <a:lvl2pPr lvl="1" rtl="0">
@@ -3518,9 +3518,9 @@
               <a:buSzPts val="2800"/>
               <a:buNone/>
               <a:defRPr lang="ja-JP">
-                <a:latin typeface="Arial"/>
-                <a:ea typeface="ＭＳ Ｐゴシック"/>
-                <a:cs typeface="Arial"/>
+                <a:latin typeface="Noto Sans"/>
+                <a:ea typeface="Noto Sans CJK JP"/>
+                <a:cs typeface="Noto Sans"/>
               </a:defRPr>
             </a:lvl2pPr>
             <a:lvl3pPr lvl="2" rtl="0">
@@ -3533,9 +3533,9 @@
               <a:buSzPts val="2800"/>
               <a:buNone/>
               <a:defRPr lang="ja-JP">
-                <a:latin typeface="Arial"/>
-                <a:ea typeface="ＭＳ Ｐゴシック"/>
-                <a:cs typeface="Arial"/>
+                <a:latin typeface="Noto Sans"/>
+                <a:ea typeface="Noto Sans CJK JP"/>
+                <a:cs typeface="Noto Sans"/>
               </a:defRPr>
             </a:lvl3pPr>
             <a:lvl4pPr lvl="3" rtl="0">
@@ -3548,9 +3548,9 @@
               <a:buSzPts val="2800"/>
               <a:buNone/>
               <a:defRPr lang="ja-JP">
-                <a:latin typeface="Arial"/>
-                <a:ea typeface="ＭＳ Ｐゴシック"/>
-                <a:cs typeface="Arial"/>
+                <a:latin typeface="Noto Sans"/>
+                <a:ea typeface="Noto Sans CJK JP"/>
+                <a:cs typeface="Noto Sans"/>
               </a:defRPr>
             </a:lvl4pPr>
             <a:lvl5pPr lvl="4" rtl="0">
@@ -3563,9 +3563,9 @@
               <a:buSzPts val="2800"/>
               <a:buNone/>
               <a:defRPr lang="ja-JP">
-                <a:latin typeface="Arial"/>
-                <a:ea typeface="ＭＳ Ｐゴシック"/>
-                <a:cs typeface="Arial"/>
+                <a:latin typeface="Noto Sans"/>
+                <a:ea typeface="Noto Sans CJK JP"/>
+                <a:cs typeface="Noto Sans"/>
               </a:defRPr>
             </a:lvl5pPr>
             <a:lvl6pPr lvl="5" rtl="0">
@@ -3578,9 +3578,9 @@
               <a:buSzPts val="2800"/>
               <a:buNone/>
               <a:defRPr lang="ja-JP">
-                <a:latin typeface="Arial"/>
-                <a:ea typeface="ＭＳ Ｐゴシック"/>
-                <a:cs typeface="Arial"/>
+                <a:latin typeface="Noto Sans"/>
+                <a:ea typeface="Noto Sans CJK JP"/>
+                <a:cs typeface="Noto Sans"/>
               </a:defRPr>
             </a:lvl6pPr>
             <a:lvl7pPr lvl="6" rtl="0">
@@ -3593,9 +3593,9 @@
               <a:buSzPts val="2800"/>
               <a:buNone/>
               <a:defRPr lang="ja-JP">
-                <a:latin typeface="Arial"/>
-                <a:ea typeface="ＭＳ Ｐゴシック"/>
-                <a:cs typeface="Arial"/>
+                <a:latin typeface="Noto Sans"/>
+                <a:ea typeface="Noto Sans CJK JP"/>
+                <a:cs typeface="Noto Sans"/>
               </a:defRPr>
             </a:lvl7pPr>
             <a:lvl8pPr lvl="7" rtl="0">
@@ -3608,9 +3608,9 @@
               <a:buSzPts val="2800"/>
               <a:buNone/>
               <a:defRPr lang="ja-JP">
-                <a:latin typeface="Arial"/>
-                <a:ea typeface="ＭＳ Ｐゴシック"/>
-                <a:cs typeface="Arial"/>
+                <a:latin typeface="Noto Sans"/>
+                <a:ea typeface="Noto Sans CJK JP"/>
+                <a:cs typeface="Noto Sans"/>
               </a:defRPr>
             </a:lvl8pPr>
             <a:lvl9pPr lvl="8" rtl="0">
@@ -3623,17 +3623,17 @@
               <a:buSzPts val="2800"/>
               <a:buNone/>
               <a:defRPr lang="ja-JP">
-                <a:latin typeface="Arial"/>
-                <a:ea typeface="ＭＳ Ｐゴシック"/>
-                <a:cs typeface="Arial"/>
+                <a:latin typeface="Noto Sans"/>
+                <a:ea typeface="Noto Sans CJK JP"/>
+                <a:cs typeface="Noto Sans"/>
               </a:defRPr>
             </a:lvl9pPr>
           </a:lstStyle>
           <a:p>
             <a:endParaRPr lang="ja-JP">
-              <a:latin typeface="Arial"/>
-              <a:ea typeface="ＭＳ Ｐゴシック"/>
-              <a:cs typeface="Arial"/>
+              <a:latin typeface="Noto Sans"/>
+              <a:ea typeface="Noto Sans CJK JP"/>
+              <a:cs typeface="Noto Sans"/>
             </a:endParaRPr>
           </a:p>
         </p:txBody>
@@ -3681,9 +3681,9 @@
                 <a:solidFill>
                   <a:schemeClr val="lt1"/>
                 </a:solidFill>
-                <a:latin typeface="Arial"/>
-                <a:ea typeface="ＭＳ Ｐゴシック"/>
-                <a:cs typeface="Arial"/>
+                <a:latin typeface="Noto Sans"/>
+                <a:ea typeface="Noto Sans CJK JP"/>
+                <a:cs typeface="Noto Sans"/>
               </a:defRPr>
             </a:lvl1pPr>
             <a:lvl2pPr lvl="1" rtl="0">
@@ -3696,9 +3696,9 @@
               <a:buSzPts val="2800"/>
               <a:buNone/>
               <a:defRPr lang="ja-JP">
-                <a:latin typeface="Arial"/>
-                <a:ea typeface="ＭＳ Ｐゴシック"/>
-                <a:cs typeface="Arial"/>
+                <a:latin typeface="Noto Sans"/>
+                <a:ea typeface="Noto Sans CJK JP"/>
+                <a:cs typeface="Noto Sans"/>
               </a:defRPr>
             </a:lvl2pPr>
             <a:lvl3pPr lvl="2" rtl="0">
@@ -3711,9 +3711,9 @@
               <a:buSzPts val="2800"/>
               <a:buNone/>
               <a:defRPr lang="ja-JP">
-                <a:latin typeface="Arial"/>
-                <a:ea typeface="ＭＳ Ｐゴシック"/>
-                <a:cs typeface="Arial"/>
+                <a:latin typeface="Noto Sans"/>
+                <a:ea typeface="Noto Sans CJK JP"/>
+                <a:cs typeface="Noto Sans"/>
               </a:defRPr>
             </a:lvl3pPr>
             <a:lvl4pPr lvl="3" rtl="0">
@@ -3726,9 +3726,9 @@
               <a:buSzPts val="2800"/>
               <a:buNone/>
               <a:defRPr lang="ja-JP">
-                <a:latin typeface="Arial"/>
-                <a:ea typeface="ＭＳ Ｐゴシック"/>
-                <a:cs typeface="Arial"/>
+                <a:latin typeface="Noto Sans"/>
+                <a:ea typeface="Noto Sans CJK JP"/>
+                <a:cs typeface="Noto Sans"/>
               </a:defRPr>
             </a:lvl4pPr>
             <a:lvl5pPr lvl="4" rtl="0">
@@ -3741,9 +3741,9 @@
               <a:buSzPts val="2800"/>
               <a:buNone/>
               <a:defRPr lang="ja-JP">
-                <a:latin typeface="Arial"/>
-                <a:ea typeface="ＭＳ Ｐゴシック"/>
-                <a:cs typeface="Arial"/>
+                <a:latin typeface="Noto Sans"/>
+                <a:ea typeface="Noto Sans CJK JP"/>
+                <a:cs typeface="Noto Sans"/>
               </a:defRPr>
             </a:lvl5pPr>
             <a:lvl6pPr lvl="5" rtl="0">
@@ -3756,9 +3756,9 @@
               <a:buSzPts val="2800"/>
               <a:buNone/>
               <a:defRPr lang="ja-JP">
-                <a:latin typeface="Arial"/>
-                <a:ea typeface="ＭＳ Ｐゴシック"/>
-                <a:cs typeface="Arial"/>
+                <a:latin typeface="Noto Sans"/>
+                <a:ea typeface="Noto Sans CJK JP"/>
+                <a:cs typeface="Noto Sans"/>
               </a:defRPr>
             </a:lvl6pPr>
             <a:lvl7pPr lvl="6" rtl="0">
@@ -3771,9 +3771,9 @@
               <a:buSzPts val="2800"/>
               <a:buNone/>
               <a:defRPr lang="ja-JP">
-                <a:latin typeface="Arial"/>
-                <a:ea typeface="ＭＳ Ｐゴシック"/>
-                <a:cs typeface="Arial"/>
+                <a:latin typeface="Noto Sans"/>
+                <a:ea typeface="Noto Sans CJK JP"/>
+                <a:cs typeface="Noto Sans"/>
               </a:defRPr>
             </a:lvl7pPr>
             <a:lvl8pPr lvl="7" rtl="0">
@@ -3786,9 +3786,9 @@
               <a:buSzPts val="2800"/>
               <a:buNone/>
               <a:defRPr lang="ja-JP">
-                <a:latin typeface="Arial"/>
-                <a:ea typeface="ＭＳ Ｐゴシック"/>
-                <a:cs typeface="Arial"/>
+                <a:latin typeface="Noto Sans"/>
+                <a:ea typeface="Noto Sans CJK JP"/>
+                <a:cs typeface="Noto Sans"/>
               </a:defRPr>
             </a:lvl8pPr>
             <a:lvl9pPr lvl="8" rtl="0">
@@ -3801,9 +3801,9 @@
               <a:buSzPts val="2800"/>
               <a:buNone/>
               <a:defRPr lang="ja-JP">
-                <a:latin typeface="Arial"/>
-                <a:ea typeface="ＭＳ Ｐゴシック"/>
-                <a:cs typeface="Arial"/>
+                <a:latin typeface="Noto Sans"/>
+                <a:ea typeface="Noto Sans CJK JP"/>
+                <a:cs typeface="Noto Sans"/>
               </a:defRPr>
             </a:lvl9pPr>
           </a:lstStyle>
@@ -3820,9 +3820,9 @@
               </a:spcAft>
             </a:pPr>
             <a:endParaRPr dirty="0" lang="ja-JP">
-              <a:latin typeface="Arial"/>
-              <a:ea typeface="ＭＳ Ｐゴシック"/>
-              <a:cs typeface="Arial"/>
+              <a:latin typeface="Noto Sans"/>
+              <a:ea typeface="Noto Sans CJK JP"/>
+              <a:cs typeface="Noto Sans"/>
             </a:endParaRPr>
           </a:p>
         </p:txBody>
@@ -3856,16 +3856,16 @@
                 <a:solidFill>
                   <a:schemeClr val="lt1"/>
                 </a:solidFill>
-                <a:latin typeface="Arial"/>
-                <a:ea typeface="ＭＳ Ｐゴシック"/>
-                <a:cs typeface="Arial"/>
+                <a:latin typeface="Noto Sans"/>
+                <a:ea typeface="Noto Sans CJK JP"/>
+                <a:cs typeface="Noto Sans"/>
               </a:rPr>
               <a:t>‹#›</a:t>
             </a:fld>
             <a:endParaRPr lang="ja-JP" sz="1800" b="1">
-              <a:latin typeface="Arial"/>
-              <a:ea typeface="ＭＳ Ｐゴシック"/>
-              <a:cs typeface="Arial"/>
+              <a:latin typeface="Noto Sans"/>
+              <a:ea typeface="Noto Sans CJK JP"/>
+              <a:cs typeface="Noto Sans"/>
             </a:endParaRPr>
           </a:p>
         </p:txBody>
@@ -3935,9 +3935,9 @@
               <a:buNone/>
             </a:pPr>
             <a:endParaRPr lang="ja-JP">
-              <a:latin typeface="Arial"/>
-              <a:ea typeface="ＭＳ Ｐゴシック"/>
-              <a:cs typeface="Arial"/>
+              <a:latin typeface="Noto Sans"/>
+              <a:ea typeface="Noto Sans CJK JP"/>
+              <a:cs typeface="Noto Sans"/>
             </a:endParaRPr>
           </a:p>
         </p:txBody>
@@ -3982,9 +3982,9 @@
                 <a:solidFill>
                   <a:srgbClr val="303437"/>
                 </a:solidFill>
-                <a:latin typeface="Arial"/>
-                <a:ea typeface="ＭＳ Ｐゴシック"/>
-                <a:cs typeface="Arial"/>
+                <a:latin typeface="Noto Sans"/>
+                <a:ea typeface="Noto Sans CJK JP"/>
+                <a:cs typeface="Noto Sans"/>
               </a:defRPr>
             </a:lvl1pPr>
             <a:lvl2pPr marL="914400" lvl="1" indent="-355600">
@@ -4003,9 +4003,9 @@
                 <a:solidFill>
                   <a:srgbClr val="303437"/>
                 </a:solidFill>
-                <a:latin typeface="Arial"/>
-                <a:ea typeface="ＭＳ Ｐゴシック"/>
-                <a:cs typeface="Arial"/>
+                <a:latin typeface="Noto Sans"/>
+                <a:ea typeface="Noto Sans CJK JP"/>
+                <a:cs typeface="Noto Sans"/>
               </a:defRPr>
             </a:lvl2pPr>
             <a:lvl3pPr marL="1371600" lvl="2" indent="-355600">
@@ -4024,9 +4024,9 @@
                 <a:solidFill>
                   <a:srgbClr val="303437"/>
                 </a:solidFill>
-                <a:latin typeface="Arial"/>
-                <a:ea typeface="ＭＳ Ｐゴシック"/>
-                <a:cs typeface="Arial"/>
+                <a:latin typeface="Noto Sans"/>
+                <a:ea typeface="Noto Sans CJK JP"/>
+                <a:cs typeface="Noto Sans"/>
               </a:defRPr>
             </a:lvl3pPr>
             <a:lvl4pPr marL="1828800" lvl="3" indent="-368300">
@@ -4045,9 +4045,9 @@
                 <a:solidFill>
                   <a:srgbClr val="303437"/>
                 </a:solidFill>
-                <a:latin typeface="Arial"/>
-                <a:ea typeface="ＭＳ Ｐゴシック"/>
-                <a:cs typeface="Arial"/>
+                <a:latin typeface="Noto Sans"/>
+                <a:ea typeface="Noto Sans CJK JP"/>
+                <a:cs typeface="Noto Sans"/>
               </a:defRPr>
             </a:lvl4pPr>
             <a:lvl5pPr marL="2286000" lvl="4" indent="-355600">
@@ -4066,9 +4066,9 @@
                 <a:solidFill>
                   <a:srgbClr val="303437"/>
                 </a:solidFill>
-                <a:latin typeface="Arial"/>
-                <a:ea typeface="ＭＳ Ｐゴシック"/>
-                <a:cs typeface="Arial"/>
+                <a:latin typeface="Noto Sans"/>
+                <a:ea typeface="Noto Sans CJK JP"/>
+                <a:cs typeface="Noto Sans"/>
               </a:defRPr>
             </a:lvl5pPr>
             <a:lvl6pPr marL="2743200" lvl="5" indent="-355600">
@@ -4087,9 +4087,9 @@
                 <a:solidFill>
                   <a:srgbClr val="303437"/>
                 </a:solidFill>
-                <a:latin typeface="Arial"/>
-                <a:ea typeface="ＭＳ Ｐゴシック"/>
-                <a:cs typeface="Arial"/>
+                <a:latin typeface="Noto Sans"/>
+                <a:ea typeface="Noto Sans CJK JP"/>
+                <a:cs typeface="Noto Sans"/>
               </a:defRPr>
             </a:lvl6pPr>
             <a:lvl7pPr marL="3200400" lvl="6" indent="-355600">
@@ -4108,9 +4108,9 @@
                 <a:solidFill>
                   <a:srgbClr val="303437"/>
                 </a:solidFill>
-                <a:latin typeface="Arial"/>
-                <a:ea typeface="ＭＳ Ｐゴシック"/>
-                <a:cs typeface="Arial"/>
+                <a:latin typeface="Noto Sans"/>
+                <a:ea typeface="Noto Sans CJK JP"/>
+                <a:cs typeface="Noto Sans"/>
               </a:defRPr>
             </a:lvl7pPr>
             <a:lvl8pPr marL="3657600" lvl="7" indent="-355600">
@@ -4129,9 +4129,9 @@
                 <a:solidFill>
                   <a:srgbClr val="303437"/>
                 </a:solidFill>
-                <a:latin typeface="Arial"/>
-                <a:ea typeface="ＭＳ Ｐゴシック"/>
-                <a:cs typeface="Arial"/>
+                <a:latin typeface="Noto Sans"/>
+                <a:ea typeface="Noto Sans CJK JP"/>
+                <a:cs typeface="Noto Sans"/>
               </a:defRPr>
             </a:lvl8pPr>
             <a:lvl9pPr marL="4114800" lvl="8" indent="-355600">
@@ -4150,17 +4150,17 @@
                 <a:solidFill>
                   <a:srgbClr val="303437"/>
                 </a:solidFill>
-                <a:latin typeface="Arial"/>
-                <a:ea typeface="ＭＳ Ｐゴシック"/>
-                <a:cs typeface="Arial"/>
+                <a:latin typeface="Noto Sans"/>
+                <a:ea typeface="Noto Sans CJK JP"/>
+                <a:cs typeface="Noto Sans"/>
               </a:defRPr>
             </a:lvl9pPr>
           </a:lstStyle>
           <a:p>
             <a:endParaRPr lang="ja-JP">
-              <a:latin typeface="Arial"/>
-              <a:ea typeface="ＭＳ Ｐゴシック"/>
-              <a:cs typeface="Arial"/>
+              <a:latin typeface="Noto Sans"/>
+              <a:ea typeface="Noto Sans CJK JP"/>
+              <a:cs typeface="Noto Sans"/>
             </a:endParaRPr>
           </a:p>
         </p:txBody>
@@ -4208,9 +4208,9 @@
                 <a:solidFill>
                   <a:schemeClr val="lt1"/>
                 </a:solidFill>
-                <a:latin typeface="Arial"/>
-                <a:ea typeface="ＭＳ Ｐゴシック"/>
-                <a:cs typeface="Arial"/>
+                <a:latin typeface="Noto Sans"/>
+                <a:ea typeface="Noto Sans CJK JP"/>
+                <a:cs typeface="Noto Sans"/>
               </a:defRPr>
             </a:lvl1pPr>
             <a:lvl2pPr lvl="1" rtl="0">
@@ -4223,9 +4223,9 @@
               <a:buSzPts val="2800"/>
               <a:buNone/>
               <a:defRPr lang="ja-JP">
-                <a:latin typeface="Arial"/>
-                <a:ea typeface="ＭＳ Ｐゴシック"/>
-                <a:cs typeface="Arial"/>
+                <a:latin typeface="Noto Sans"/>
+                <a:ea typeface="Noto Sans CJK JP"/>
+                <a:cs typeface="Noto Sans"/>
               </a:defRPr>
             </a:lvl2pPr>
             <a:lvl3pPr lvl="2" rtl="0">
@@ -4238,9 +4238,9 @@
               <a:buSzPts val="2800"/>
               <a:buNone/>
               <a:defRPr lang="ja-JP">
-                <a:latin typeface="Arial"/>
-                <a:ea typeface="ＭＳ Ｐゴシック"/>
-                <a:cs typeface="Arial"/>
+                <a:latin typeface="Noto Sans"/>
+                <a:ea typeface="Noto Sans CJK JP"/>
+                <a:cs typeface="Noto Sans"/>
               </a:defRPr>
             </a:lvl3pPr>
             <a:lvl4pPr lvl="3" rtl="0">
@@ -4253,9 +4253,9 @@
               <a:buSzPts val="2800"/>
               <a:buNone/>
               <a:defRPr lang="ja-JP">
-                <a:latin typeface="Arial"/>
-                <a:ea typeface="ＭＳ Ｐゴシック"/>
-                <a:cs typeface="Arial"/>
+                <a:latin typeface="Noto Sans"/>
+                <a:ea typeface="Noto Sans CJK JP"/>
+                <a:cs typeface="Noto Sans"/>
               </a:defRPr>
             </a:lvl4pPr>
             <a:lvl5pPr lvl="4" rtl="0">
@@ -4268,9 +4268,9 @@
               <a:buSzPts val="2800"/>
               <a:buNone/>
               <a:defRPr lang="ja-JP">
-                <a:latin typeface="Arial"/>
-                <a:ea typeface="ＭＳ Ｐゴシック"/>
-                <a:cs typeface="Arial"/>
+                <a:latin typeface="Noto Sans"/>
+                <a:ea typeface="Noto Sans CJK JP"/>
+                <a:cs typeface="Noto Sans"/>
               </a:defRPr>
             </a:lvl5pPr>
             <a:lvl6pPr lvl="5" rtl="0">
@@ -4283,9 +4283,9 @@
               <a:buSzPts val="2800"/>
               <a:buNone/>
               <a:defRPr lang="ja-JP">
-                <a:latin typeface="Arial"/>
-                <a:ea typeface="ＭＳ Ｐゴシック"/>
-                <a:cs typeface="Arial"/>
+                <a:latin typeface="Noto Sans"/>
+                <a:ea typeface="Noto Sans CJK JP"/>
+                <a:cs typeface="Noto Sans"/>
               </a:defRPr>
             </a:lvl6pPr>
             <a:lvl7pPr lvl="6" rtl="0">
@@ -4298,9 +4298,9 @@
               <a:buSzPts val="2800"/>
               <a:buNone/>
               <a:defRPr lang="ja-JP">
-                <a:latin typeface="Arial"/>
-                <a:ea typeface="ＭＳ Ｐゴシック"/>
-                <a:cs typeface="Arial"/>
+                <a:latin typeface="Noto Sans"/>
+                <a:ea typeface="Noto Sans CJK JP"/>
+                <a:cs typeface="Noto Sans"/>
               </a:defRPr>
             </a:lvl7pPr>
             <a:lvl8pPr lvl="7" rtl="0">
@@ -4313,9 +4313,9 @@
               <a:buSzPts val="2800"/>
               <a:buNone/>
               <a:defRPr lang="ja-JP">
-                <a:latin typeface="Arial"/>
-                <a:ea typeface="ＭＳ Ｐゴシック"/>
-                <a:cs typeface="Arial"/>
+                <a:latin typeface="Noto Sans"/>
+                <a:ea typeface="Noto Sans CJK JP"/>
+                <a:cs typeface="Noto Sans"/>
               </a:defRPr>
             </a:lvl8pPr>
             <a:lvl9pPr lvl="8" rtl="0">
@@ -4328,9 +4328,9 @@
               <a:buSzPts val="2800"/>
               <a:buNone/>
               <a:defRPr lang="ja-JP">
-                <a:latin typeface="Arial"/>
-                <a:ea typeface="ＭＳ Ｐゴシック"/>
-                <a:cs typeface="Arial"/>
+                <a:latin typeface="Noto Sans"/>
+                <a:ea typeface="Noto Sans CJK JP"/>
+                <a:cs typeface="Noto Sans"/>
               </a:defRPr>
             </a:lvl9pPr>
           </a:lstStyle>
@@ -4347,9 +4347,9 @@
               </a:spcAft>
             </a:pPr>
             <a:endParaRPr dirty="0" lang="ja-JP">
-              <a:latin typeface="Arial"/>
-              <a:ea typeface="ＭＳ Ｐゴシック"/>
-              <a:cs typeface="Arial"/>
+              <a:latin typeface="Noto Sans"/>
+              <a:ea typeface="Noto Sans CJK JP"/>
+              <a:cs typeface="Noto Sans"/>
             </a:endParaRPr>
           </a:p>
         </p:txBody>
@@ -4383,16 +4383,16 @@
                 <a:solidFill>
                   <a:schemeClr val="lt1"/>
                 </a:solidFill>
-                <a:latin typeface="Arial"/>
-                <a:ea typeface="ＭＳ Ｐゴシック"/>
-                <a:cs typeface="Arial"/>
+                <a:latin typeface="Noto Sans"/>
+                <a:ea typeface="Noto Sans CJK JP"/>
+                <a:cs typeface="Noto Sans"/>
               </a:rPr>
               <a:t>‹#›</a:t>
             </a:fld>
             <a:endParaRPr lang="ja-JP" sz="1800" b="1">
-              <a:latin typeface="Arial"/>
-              <a:ea typeface="ＭＳ Ｐゴシック"/>
-              <a:cs typeface="Arial"/>
+              <a:latin typeface="Noto Sans"/>
+              <a:ea typeface="Noto Sans CJK JP"/>
+              <a:cs typeface="Noto Sans"/>
             </a:endParaRPr>
           </a:p>
         </p:txBody>
@@ -4462,9 +4462,9 @@
               <a:buNone/>
             </a:pPr>
             <a:endParaRPr lang="ja-JP">
-              <a:latin typeface="Arial"/>
-              <a:ea typeface="ＭＳ Ｐゴシック"/>
-              <a:cs typeface="Arial"/>
+              <a:latin typeface="Noto Sans"/>
+              <a:ea typeface="Noto Sans CJK JP"/>
+              <a:cs typeface="Noto Sans"/>
             </a:endParaRPr>
           </a:p>
         </p:txBody>
@@ -4512,9 +4512,9 @@
                 <a:solidFill>
                   <a:schemeClr val="lt1"/>
                 </a:solidFill>
-                <a:latin typeface="Arial"/>
-                <a:ea typeface="ＭＳ Ｐゴシック"/>
-                <a:cs typeface="Arial"/>
+                <a:latin typeface="Noto Sans"/>
+                <a:ea typeface="Noto Sans CJK JP"/>
+                <a:cs typeface="Noto Sans"/>
               </a:defRPr>
             </a:lvl1pPr>
             <a:lvl2pPr lvl="1" rtl="0">
@@ -4527,9 +4527,9 @@
               <a:buSzPts val="2800"/>
               <a:buNone/>
               <a:defRPr lang="ja-JP">
-                <a:latin typeface="Arial"/>
-                <a:ea typeface="ＭＳ Ｐゴシック"/>
-                <a:cs typeface="Arial"/>
+                <a:latin typeface="Noto Sans"/>
+                <a:ea typeface="Noto Sans CJK JP"/>
+                <a:cs typeface="Noto Sans"/>
               </a:defRPr>
             </a:lvl2pPr>
             <a:lvl3pPr lvl="2" rtl="0">
@@ -4542,9 +4542,9 @@
               <a:buSzPts val="2800"/>
               <a:buNone/>
               <a:defRPr lang="ja-JP">
-                <a:latin typeface="Arial"/>
-                <a:ea typeface="ＭＳ Ｐゴシック"/>
-                <a:cs typeface="Arial"/>
+                <a:latin typeface="Noto Sans"/>
+                <a:ea typeface="Noto Sans CJK JP"/>
+                <a:cs typeface="Noto Sans"/>
               </a:defRPr>
             </a:lvl3pPr>
             <a:lvl4pPr lvl="3" rtl="0">
@@ -4557,9 +4557,9 @@
               <a:buSzPts val="2800"/>
               <a:buNone/>
               <a:defRPr lang="ja-JP">
-                <a:latin typeface="Arial"/>
-                <a:ea typeface="ＭＳ Ｐゴシック"/>
-                <a:cs typeface="Arial"/>
+                <a:latin typeface="Noto Sans"/>
+                <a:ea typeface="Noto Sans CJK JP"/>
+                <a:cs typeface="Noto Sans"/>
               </a:defRPr>
             </a:lvl4pPr>
             <a:lvl5pPr lvl="4" rtl="0">
@@ -4572,9 +4572,9 @@
               <a:buSzPts val="2800"/>
               <a:buNone/>
               <a:defRPr lang="ja-JP">
-                <a:latin typeface="Arial"/>
-                <a:ea typeface="ＭＳ Ｐゴシック"/>
-                <a:cs typeface="Arial"/>
+                <a:latin typeface="Noto Sans"/>
+                <a:ea typeface="Noto Sans CJK JP"/>
+                <a:cs typeface="Noto Sans"/>
               </a:defRPr>
             </a:lvl5pPr>
             <a:lvl6pPr lvl="5" rtl="0">
@@ -4587,9 +4587,9 @@
               <a:buSzPts val="2800"/>
               <a:buNone/>
               <a:defRPr lang="ja-JP">
-                <a:latin typeface="Arial"/>
-                <a:ea typeface="ＭＳ Ｐゴシック"/>
-                <a:cs typeface="Arial"/>
+                <a:latin typeface="Noto Sans"/>
+                <a:ea typeface="Noto Sans CJK JP"/>
+                <a:cs typeface="Noto Sans"/>
               </a:defRPr>
             </a:lvl6pPr>
             <a:lvl7pPr lvl="6" rtl="0">
@@ -4602,9 +4602,9 @@
               <a:buSzPts val="2800"/>
               <a:buNone/>
               <a:defRPr lang="ja-JP">
-                <a:latin typeface="Arial"/>
-                <a:ea typeface="ＭＳ Ｐゴシック"/>
-                <a:cs typeface="Arial"/>
+                <a:latin typeface="Noto Sans"/>
+                <a:ea typeface="Noto Sans CJK JP"/>
+                <a:cs typeface="Noto Sans"/>
               </a:defRPr>
             </a:lvl7pPr>
             <a:lvl8pPr lvl="7" rtl="0">
@@ -4617,9 +4617,9 @@
               <a:buSzPts val="2800"/>
               <a:buNone/>
               <a:defRPr lang="ja-JP">
-                <a:latin typeface="Arial"/>
-                <a:ea typeface="ＭＳ Ｐゴシック"/>
-                <a:cs typeface="Arial"/>
+                <a:latin typeface="Noto Sans"/>
+                <a:ea typeface="Noto Sans CJK JP"/>
+                <a:cs typeface="Noto Sans"/>
               </a:defRPr>
             </a:lvl8pPr>
             <a:lvl9pPr lvl="8" rtl="0">
@@ -4632,9 +4632,9 @@
               <a:buSzPts val="2800"/>
               <a:buNone/>
               <a:defRPr lang="ja-JP">
-                <a:latin typeface="Arial"/>
-                <a:ea typeface="ＭＳ Ｐゴシック"/>
-                <a:cs typeface="Arial"/>
+                <a:latin typeface="Noto Sans"/>
+                <a:ea typeface="Noto Sans CJK JP"/>
+                <a:cs typeface="Noto Sans"/>
               </a:defRPr>
             </a:lvl9pPr>
           </a:lstStyle>
@@ -4651,9 +4651,9 @@
               </a:spcAft>
             </a:pPr>
             <a:endParaRPr dirty="0" lang="ja-JP">
-              <a:latin typeface="Arial"/>
-              <a:ea typeface="ＭＳ Ｐゴシック"/>
-              <a:cs typeface="Arial"/>
+              <a:latin typeface="Noto Sans"/>
+              <a:ea typeface="Noto Sans CJK JP"/>
+              <a:cs typeface="Noto Sans"/>
             </a:endParaRPr>
           </a:p>
         </p:txBody>
@@ -4687,16 +4687,16 @@
                 <a:solidFill>
                   <a:schemeClr val="lt1"/>
                 </a:solidFill>
-                <a:latin typeface="Arial"/>
-                <a:ea typeface="ＭＳ Ｐゴシック"/>
-                <a:cs typeface="Arial"/>
+                <a:latin typeface="Noto Sans"/>
+                <a:ea typeface="Noto Sans CJK JP"/>
+                <a:cs typeface="Noto Sans"/>
               </a:rPr>
               <a:t>‹#›</a:t>
             </a:fld>
             <a:endParaRPr lang="ja-JP" sz="1800" b="1">
-              <a:latin typeface="Arial"/>
-              <a:ea typeface="ＭＳ Ｐゴシック"/>
-              <a:cs typeface="Arial"/>
+              <a:latin typeface="Noto Sans"/>
+              <a:ea typeface="Noto Sans CJK JP"/>
+              <a:cs typeface="Noto Sans"/>
             </a:endParaRPr>
           </a:p>
         </p:txBody>
@@ -4763,9 +4763,9 @@
               </a:spcAft>
             </a:pPr>
             <a:endParaRPr lang="ja-JP" dirty="0">
-              <a:latin typeface="Arial"/>
-              <a:ea typeface="ＭＳ Ｐゴシック"/>
-              <a:cs typeface="Arial"/>
+              <a:latin typeface="Noto Sans"/>
+              <a:ea typeface="Noto Sans CJK JP"/>
+              <a:cs typeface="Noto Sans"/>
             </a:endParaRPr>
           </a:p>
         </p:txBody>
@@ -4804,16 +4804,16 @@
                 <a:solidFill>
                   <a:schemeClr val="dk2"/>
                 </a:solidFill>
-                <a:latin typeface="Arial"/>
-                <a:ea typeface="ＭＳ Ｐゴシック"/>
-                <a:cs typeface="Arial"/>
+                <a:latin typeface="Noto Sans"/>
+                <a:ea typeface="Noto Sans CJK JP"/>
+                <a:cs typeface="Noto Sans"/>
               </a:rPr>
               <a:t>Insert chart</a:t>
             </a:r>
             <a:endParaRPr lang="ja-JP">
-              <a:latin typeface="Arial"/>
-              <a:ea typeface="ＭＳ Ｐゴシック"/>
-              <a:cs typeface="Arial"/>
+              <a:latin typeface="Noto Sans"/>
+              <a:ea typeface="Noto Sans CJK JP"/>
+              <a:cs typeface="Noto Sans"/>
             </a:endParaRPr>
           </a:p>
         </p:txBody>
@@ -4860,9 +4860,9 @@
                 <a:solidFill>
                   <a:srgbClr val="303437"/>
                 </a:solidFill>
-                <a:latin typeface="Arial"/>
-                <a:ea typeface="ＭＳ Ｐゴシック"/>
-                <a:cs typeface="Arial"/>
+                <a:latin typeface="Noto Sans"/>
+                <a:ea typeface="Noto Sans CJK JP"/>
+                <a:cs typeface="Noto Sans"/>
               </a:defRPr>
             </a:lvl1pPr>
             <a:lvl2pPr marL="914400" lvl="1" indent="-355600">
@@ -4881,9 +4881,9 @@
                 <a:solidFill>
                   <a:srgbClr val="303437"/>
                 </a:solidFill>
-                <a:latin typeface="Arial"/>
-                <a:ea typeface="ＭＳ Ｐゴシック"/>
-                <a:cs typeface="Arial"/>
+                <a:latin typeface="Noto Sans"/>
+                <a:ea typeface="Noto Sans CJK JP"/>
+                <a:cs typeface="Noto Sans"/>
               </a:defRPr>
             </a:lvl2pPr>
             <a:lvl3pPr marL="1371600" lvl="2" indent="-355600">
@@ -4902,9 +4902,9 @@
                 <a:solidFill>
                   <a:srgbClr val="303437"/>
                 </a:solidFill>
-                <a:latin typeface="Arial"/>
-                <a:ea typeface="ＭＳ Ｐゴシック"/>
-                <a:cs typeface="Arial"/>
+                <a:latin typeface="Noto Sans"/>
+                <a:ea typeface="Noto Sans CJK JP"/>
+                <a:cs typeface="Noto Sans"/>
               </a:defRPr>
             </a:lvl3pPr>
             <a:lvl4pPr marL="1828800" lvl="3" indent="-368300">
@@ -4923,9 +4923,9 @@
                 <a:solidFill>
                   <a:srgbClr val="303437"/>
                 </a:solidFill>
-                <a:latin typeface="Arial"/>
-                <a:ea typeface="ＭＳ Ｐゴシック"/>
-                <a:cs typeface="Arial"/>
+                <a:latin typeface="Noto Sans"/>
+                <a:ea typeface="Noto Sans CJK JP"/>
+                <a:cs typeface="Noto Sans"/>
               </a:defRPr>
             </a:lvl4pPr>
             <a:lvl5pPr marL="2286000" lvl="4" indent="-355600">
@@ -4944,9 +4944,9 @@
                 <a:solidFill>
                   <a:srgbClr val="303437"/>
                 </a:solidFill>
-                <a:latin typeface="Arial"/>
-                <a:ea typeface="ＭＳ Ｐゴシック"/>
-                <a:cs typeface="Arial"/>
+                <a:latin typeface="Noto Sans"/>
+                <a:ea typeface="Noto Sans CJK JP"/>
+                <a:cs typeface="Noto Sans"/>
               </a:defRPr>
             </a:lvl5pPr>
             <a:lvl6pPr marL="2743200" lvl="5" indent="-355600">
@@ -4965,9 +4965,9 @@
                 <a:solidFill>
                   <a:srgbClr val="303437"/>
                 </a:solidFill>
-                <a:latin typeface="Arial"/>
-                <a:ea typeface="ＭＳ Ｐゴシック"/>
-                <a:cs typeface="Arial"/>
+                <a:latin typeface="Noto Sans"/>
+                <a:ea typeface="Noto Sans CJK JP"/>
+                <a:cs typeface="Noto Sans"/>
               </a:defRPr>
             </a:lvl6pPr>
             <a:lvl7pPr marL="3200400" lvl="6" indent="-355600">
@@ -4986,9 +4986,9 @@
                 <a:solidFill>
                   <a:srgbClr val="303437"/>
                 </a:solidFill>
-                <a:latin typeface="Arial"/>
-                <a:ea typeface="ＭＳ Ｐゴシック"/>
-                <a:cs typeface="Arial"/>
+                <a:latin typeface="Noto Sans"/>
+                <a:ea typeface="Noto Sans CJK JP"/>
+                <a:cs typeface="Noto Sans"/>
               </a:defRPr>
             </a:lvl7pPr>
             <a:lvl8pPr marL="3657600" lvl="7" indent="-355600">
@@ -5007,9 +5007,9 @@
                 <a:solidFill>
                   <a:srgbClr val="303437"/>
                 </a:solidFill>
-                <a:latin typeface="Arial"/>
-                <a:ea typeface="ＭＳ Ｐゴシック"/>
-                <a:cs typeface="Arial"/>
+                <a:latin typeface="Noto Sans"/>
+                <a:ea typeface="Noto Sans CJK JP"/>
+                <a:cs typeface="Noto Sans"/>
               </a:defRPr>
             </a:lvl8pPr>
             <a:lvl9pPr marL="4114800" lvl="8" indent="-355600">
@@ -5028,17 +5028,17 @@
                 <a:solidFill>
                   <a:srgbClr val="303437"/>
                 </a:solidFill>
-                <a:latin typeface="Arial"/>
-                <a:ea typeface="ＭＳ Ｐゴシック"/>
-                <a:cs typeface="Arial"/>
+                <a:latin typeface="Noto Sans"/>
+                <a:ea typeface="Noto Sans CJK JP"/>
+                <a:cs typeface="Noto Sans"/>
               </a:defRPr>
             </a:lvl9pPr>
           </a:lstStyle>
           <a:p>
             <a:endParaRPr lang="ja-JP" dirty="0">
-              <a:latin typeface="Arial"/>
-              <a:ea typeface="ＭＳ Ｐゴシック"/>
-              <a:cs typeface="Arial"/>
+              <a:latin typeface="Noto Sans"/>
+              <a:ea typeface="Noto Sans CJK JP"/>
+              <a:cs typeface="Noto Sans"/>
             </a:endParaRPr>
           </a:p>
         </p:txBody>
@@ -5085,9 +5085,9 @@
                 <a:solidFill>
                   <a:srgbClr val="303437"/>
                 </a:solidFill>
-                <a:latin typeface="Arial"/>
-                <a:ea typeface="ＭＳ Ｐゴシック"/>
-                <a:cs typeface="Arial"/>
+                <a:latin typeface="Noto Sans"/>
+                <a:ea typeface="Noto Sans CJK JP"/>
+                <a:cs typeface="Noto Sans"/>
               </a:defRPr>
             </a:lvl1pPr>
             <a:lvl2pPr marL="914400" lvl="1" indent="-355600">
@@ -5106,9 +5106,9 @@
                 <a:solidFill>
                   <a:srgbClr val="303437"/>
                 </a:solidFill>
-                <a:latin typeface="Arial"/>
-                <a:ea typeface="ＭＳ Ｐゴシック"/>
-                <a:cs typeface="Arial"/>
+                <a:latin typeface="Noto Sans"/>
+                <a:ea typeface="Noto Sans CJK JP"/>
+                <a:cs typeface="Noto Sans"/>
               </a:defRPr>
             </a:lvl2pPr>
             <a:lvl3pPr marL="1371600" lvl="2" indent="-355600">
@@ -5127,9 +5127,9 @@
                 <a:solidFill>
                   <a:srgbClr val="303437"/>
                 </a:solidFill>
-                <a:latin typeface="Arial"/>
-                <a:ea typeface="ＭＳ Ｐゴシック"/>
-                <a:cs typeface="Arial"/>
+                <a:latin typeface="Noto Sans"/>
+                <a:ea typeface="Noto Sans CJK JP"/>
+                <a:cs typeface="Noto Sans"/>
               </a:defRPr>
             </a:lvl3pPr>
             <a:lvl4pPr marL="1828800" lvl="3" indent="-368300">
@@ -5148,9 +5148,9 @@
                 <a:solidFill>
                   <a:srgbClr val="303437"/>
                 </a:solidFill>
-                <a:latin typeface="Arial"/>
-                <a:ea typeface="ＭＳ Ｐゴシック"/>
-                <a:cs typeface="Arial"/>
+                <a:latin typeface="Noto Sans"/>
+                <a:ea typeface="Noto Sans CJK JP"/>
+                <a:cs typeface="Noto Sans"/>
               </a:defRPr>
             </a:lvl4pPr>
             <a:lvl5pPr marL="2286000" lvl="4" indent="-355600">
@@ -5169,9 +5169,9 @@
                 <a:solidFill>
                   <a:srgbClr val="303437"/>
                 </a:solidFill>
-                <a:latin typeface="Arial"/>
-                <a:ea typeface="ＭＳ Ｐゴシック"/>
-                <a:cs typeface="Arial"/>
+                <a:latin typeface="Noto Sans"/>
+                <a:ea typeface="Noto Sans CJK JP"/>
+                <a:cs typeface="Noto Sans"/>
               </a:defRPr>
             </a:lvl5pPr>
             <a:lvl6pPr marL="2743200" lvl="5" indent="-355600">
@@ -5190,9 +5190,9 @@
                 <a:solidFill>
                   <a:srgbClr val="303437"/>
                 </a:solidFill>
-                <a:latin typeface="Arial"/>
-                <a:ea typeface="ＭＳ Ｐゴシック"/>
-                <a:cs typeface="Arial"/>
+                <a:latin typeface="Noto Sans"/>
+                <a:ea typeface="Noto Sans CJK JP"/>
+                <a:cs typeface="Noto Sans"/>
               </a:defRPr>
             </a:lvl6pPr>
             <a:lvl7pPr marL="3200400" lvl="6" indent="-355600">
@@ -5211,9 +5211,9 @@
                 <a:solidFill>
                   <a:srgbClr val="303437"/>
                 </a:solidFill>
-                <a:latin typeface="Arial"/>
-                <a:ea typeface="ＭＳ Ｐゴシック"/>
-                <a:cs typeface="Arial"/>
+                <a:latin typeface="Noto Sans"/>
+                <a:ea typeface="Noto Sans CJK JP"/>
+                <a:cs typeface="Noto Sans"/>
               </a:defRPr>
             </a:lvl7pPr>
             <a:lvl8pPr marL="3657600" lvl="7" indent="-355600">
@@ -5232,9 +5232,9 @@
                 <a:solidFill>
                   <a:srgbClr val="303437"/>
                 </a:solidFill>
-                <a:latin typeface="Arial"/>
-                <a:ea typeface="ＭＳ Ｐゴシック"/>
-                <a:cs typeface="Arial"/>
+                <a:latin typeface="Noto Sans"/>
+                <a:ea typeface="Noto Sans CJK JP"/>
+                <a:cs typeface="Noto Sans"/>
               </a:defRPr>
             </a:lvl8pPr>
             <a:lvl9pPr marL="4114800" lvl="8" indent="-355600">
@@ -5253,17 +5253,17 @@
                 <a:solidFill>
                   <a:srgbClr val="303437"/>
                 </a:solidFill>
-                <a:latin typeface="Arial"/>
-                <a:ea typeface="ＭＳ Ｐゴシック"/>
-                <a:cs typeface="Arial"/>
+                <a:latin typeface="Noto Sans"/>
+                <a:ea typeface="Noto Sans CJK JP"/>
+                <a:cs typeface="Noto Sans"/>
               </a:defRPr>
             </a:lvl9pPr>
           </a:lstStyle>
           <a:p>
             <a:endParaRPr lang="ja-JP" dirty="0">
-              <a:latin typeface="Arial"/>
-              <a:ea typeface="ＭＳ Ｐゴシック"/>
-              <a:cs typeface="Arial"/>
+              <a:latin typeface="Noto Sans"/>
+              <a:ea typeface="Noto Sans CJK JP"/>
+              <a:cs typeface="Noto Sans"/>
             </a:endParaRPr>
           </a:p>
         </p:txBody>
@@ -5297,16 +5297,16 @@
                 <a:solidFill>
                   <a:schemeClr val="lt1"/>
                 </a:solidFill>
-                <a:latin typeface="Arial"/>
-                <a:ea typeface="ＭＳ Ｐゴシック"/>
-                <a:cs typeface="Arial"/>
+                <a:latin typeface="Noto Sans"/>
+                <a:ea typeface="Noto Sans CJK JP"/>
+                <a:cs typeface="Noto Sans"/>
               </a:rPr>
               <a:t>‹#›</a:t>
             </a:fld>
             <a:endParaRPr lang="ja-JP" sz="1800" b="1">
-              <a:latin typeface="Arial"/>
-              <a:ea typeface="ＭＳ Ｐゴシック"/>
-              <a:cs typeface="Arial"/>
+              <a:latin typeface="Noto Sans"/>
+              <a:ea typeface="Noto Sans CJK JP"/>
+              <a:cs typeface="Noto Sans"/>
             </a:endParaRPr>
           </a:p>
         </p:txBody>
@@ -5333,9 +5333,9 @@
           <a:lstStyle/>
           <a:p>
             <a:endParaRPr kumimoji="1" lang="ja-JP" altLang="en-US">
-              <a:latin typeface="Arial"/>
-              <a:ea typeface="ＭＳ Ｐゴシック"/>
-              <a:cs typeface="Arial"/>
+              <a:latin typeface="Noto Sans"/>
+              <a:ea typeface="Noto Sans CJK JP"/>
+              <a:cs typeface="Noto Sans"/>
             </a:endParaRPr>
           </a:p>
         </p:txBody>
@@ -5408,9 +5408,9 @@
                 <a:solidFill>
                   <a:schemeClr val="lt1"/>
                 </a:solidFill>
-                <a:latin typeface="Arial"/>
-                <a:ea typeface="ＭＳ Ｐゴシック"/>
-                <a:cs typeface="Arial"/>
+                <a:latin typeface="Noto Sans"/>
+                <a:ea typeface="Noto Sans CJK JP"/>
+                <a:cs typeface="Noto Sans"/>
               </a:defRPr>
             </a:lvl1pPr>
             <a:lvl2pPr lvl="1">
@@ -5429,9 +5429,9 @@
                 <a:solidFill>
                   <a:schemeClr val="lt1"/>
                 </a:solidFill>
-                <a:latin typeface="Arial"/>
-                <a:ea typeface="ＭＳ Ｐゴシック"/>
-                <a:cs typeface="Arial"/>
+                <a:latin typeface="Noto Sans"/>
+                <a:ea typeface="Noto Sans CJK JP"/>
+                <a:cs typeface="Noto Sans"/>
               </a:defRPr>
             </a:lvl2pPr>
             <a:lvl3pPr lvl="2">
@@ -5450,9 +5450,9 @@
                 <a:solidFill>
                   <a:schemeClr val="lt1"/>
                 </a:solidFill>
-                <a:latin typeface="Arial"/>
-                <a:ea typeface="ＭＳ Ｐゴシック"/>
-                <a:cs typeface="Arial"/>
+                <a:latin typeface="Noto Sans"/>
+                <a:ea typeface="Noto Sans CJK JP"/>
+                <a:cs typeface="Noto Sans"/>
               </a:defRPr>
             </a:lvl3pPr>
             <a:lvl4pPr lvl="3">
@@ -5471,9 +5471,9 @@
                 <a:solidFill>
                   <a:schemeClr val="lt1"/>
                 </a:solidFill>
-                <a:latin typeface="Arial"/>
-                <a:ea typeface="ＭＳ Ｐゴシック"/>
-                <a:cs typeface="Arial"/>
+                <a:latin typeface="Noto Sans"/>
+                <a:ea typeface="Noto Sans CJK JP"/>
+                <a:cs typeface="Noto Sans"/>
               </a:defRPr>
             </a:lvl4pPr>
             <a:lvl5pPr lvl="4">
@@ -5492,9 +5492,9 @@
                 <a:solidFill>
                   <a:schemeClr val="lt1"/>
                 </a:solidFill>
-                <a:latin typeface="Arial"/>
-                <a:ea typeface="ＭＳ Ｐゴシック"/>
-                <a:cs typeface="Arial"/>
+                <a:latin typeface="Noto Sans"/>
+                <a:ea typeface="Noto Sans CJK JP"/>
+                <a:cs typeface="Noto Sans"/>
               </a:defRPr>
             </a:lvl5pPr>
             <a:lvl6pPr lvl="5">
@@ -5513,9 +5513,9 @@
                 <a:solidFill>
                   <a:schemeClr val="lt1"/>
                 </a:solidFill>
-                <a:latin typeface="Arial"/>
-                <a:ea typeface="ＭＳ Ｐゴシック"/>
-                <a:cs typeface="Arial"/>
+                <a:latin typeface="Noto Sans"/>
+                <a:ea typeface="Noto Sans CJK JP"/>
+                <a:cs typeface="Noto Sans"/>
               </a:defRPr>
             </a:lvl6pPr>
             <a:lvl7pPr lvl="6">
@@ -5534,9 +5534,9 @@
                 <a:solidFill>
                   <a:schemeClr val="lt1"/>
                 </a:solidFill>
-                <a:latin typeface="Arial"/>
-                <a:ea typeface="ＭＳ Ｐゴシック"/>
-                <a:cs typeface="Arial"/>
+                <a:latin typeface="Noto Sans"/>
+                <a:ea typeface="Noto Sans CJK JP"/>
+                <a:cs typeface="Noto Sans"/>
               </a:defRPr>
             </a:lvl7pPr>
             <a:lvl8pPr lvl="7">
@@ -5555,9 +5555,9 @@
                 <a:solidFill>
                   <a:schemeClr val="lt1"/>
                 </a:solidFill>
-                <a:latin typeface="Arial"/>
-                <a:ea typeface="ＭＳ Ｐゴシック"/>
-                <a:cs typeface="Arial"/>
+                <a:latin typeface="Noto Sans"/>
+                <a:ea typeface="Noto Sans CJK JP"/>
+                <a:cs typeface="Noto Sans"/>
               </a:defRPr>
             </a:lvl8pPr>
             <a:lvl9pPr lvl="8">
@@ -5576,17 +5576,17 @@
                 <a:solidFill>
                   <a:schemeClr val="lt1"/>
                 </a:solidFill>
-                <a:latin typeface="Arial"/>
-                <a:ea typeface="ＭＳ Ｐゴシック"/>
-                <a:cs typeface="Arial"/>
+                <a:latin typeface="Noto Sans"/>
+                <a:ea typeface="Noto Sans CJK JP"/>
+                <a:cs typeface="Noto Sans"/>
               </a:defRPr>
             </a:lvl9pPr>
           </a:lstStyle>
           <a:p>
             <a:endParaRPr dirty="0" lang="ja-JP">
-              <a:latin typeface="Arial"/>
-              <a:ea typeface="ＭＳ Ｐゴシック"/>
-              <a:cs typeface="Arial"/>
+              <a:latin typeface="Noto Sans"/>
+              <a:ea typeface="Noto Sans CJK JP"/>
+              <a:cs typeface="Noto Sans"/>
             </a:endParaRPr>
           </a:p>
         </p:txBody>
@@ -5620,16 +5620,16 @@
                 <a:solidFill>
                   <a:schemeClr val="dk2"/>
                 </a:solidFill>
-                <a:latin typeface="Arial"/>
-                <a:ea typeface="ＭＳ Ｐゴシック"/>
-                <a:cs typeface="Arial"/>
+                <a:latin typeface="Noto Sans"/>
+                <a:ea typeface="Noto Sans CJK JP"/>
+                <a:cs typeface="Noto Sans"/>
               </a:rPr>
               <a:t>‹#›</a:t>
             </a:fld>
             <a:endParaRPr lang="ja-JP" sz="1800" b="1">
-              <a:latin typeface="Arial"/>
-              <a:ea typeface="ＭＳ Ｐゴシック"/>
-              <a:cs typeface="Arial"/>
+              <a:latin typeface="Noto Sans"/>
+              <a:ea typeface="Noto Sans CJK JP"/>
+              <a:cs typeface="Noto Sans"/>
             </a:endParaRPr>
           </a:p>
         </p:txBody>
@@ -5711,9 +5711,9 @@
                 <a:solidFill>
                   <a:schemeClr val="dk1"/>
                 </a:solidFill>
-                <a:latin typeface="Arial"/>
-                <a:ea typeface="ＭＳ Ｐゴシック"/>
-                <a:cs typeface="Arial"/>
+                <a:latin typeface="Noto Sans"/>
+                <a:ea typeface="Noto Sans CJK JP"/>
+                <a:cs typeface="Noto Sans"/>
               </a:defRPr>
             </a:lvl1pPr>
             <a:lvl2pPr lvl="1">
@@ -5732,9 +5732,9 @@
                 <a:solidFill>
                   <a:schemeClr val="dk1"/>
                 </a:solidFill>
-                <a:latin typeface="Arial"/>
-                <a:ea typeface="ＭＳ Ｐゴシック"/>
-                <a:cs typeface="Arial"/>
+                <a:latin typeface="Noto Sans"/>
+                <a:ea typeface="Noto Sans CJK JP"/>
+                <a:cs typeface="Noto Sans"/>
               </a:defRPr>
             </a:lvl2pPr>
             <a:lvl3pPr lvl="2">
@@ -5753,9 +5753,9 @@
                 <a:solidFill>
                   <a:schemeClr val="dk1"/>
                 </a:solidFill>
-                <a:latin typeface="Arial"/>
-                <a:ea typeface="ＭＳ Ｐゴシック"/>
-                <a:cs typeface="Arial"/>
+                <a:latin typeface="Noto Sans"/>
+                <a:ea typeface="Noto Sans CJK JP"/>
+                <a:cs typeface="Noto Sans"/>
               </a:defRPr>
             </a:lvl3pPr>
             <a:lvl4pPr lvl="3">
@@ -5774,9 +5774,9 @@
                 <a:solidFill>
                   <a:schemeClr val="dk1"/>
                 </a:solidFill>
-                <a:latin typeface="Arial"/>
-                <a:ea typeface="ＭＳ Ｐゴシック"/>
-                <a:cs typeface="Arial"/>
+                <a:latin typeface="Noto Sans"/>
+                <a:ea typeface="Noto Sans CJK JP"/>
+                <a:cs typeface="Noto Sans"/>
               </a:defRPr>
             </a:lvl4pPr>
             <a:lvl5pPr lvl="4">
@@ -5795,9 +5795,9 @@
                 <a:solidFill>
                   <a:schemeClr val="dk1"/>
                 </a:solidFill>
-                <a:latin typeface="Arial"/>
-                <a:ea typeface="ＭＳ Ｐゴシック"/>
-                <a:cs typeface="Arial"/>
+                <a:latin typeface="Noto Sans"/>
+                <a:ea typeface="Noto Sans CJK JP"/>
+                <a:cs typeface="Noto Sans"/>
               </a:defRPr>
             </a:lvl5pPr>
             <a:lvl6pPr lvl="5">
@@ -5816,9 +5816,9 @@
                 <a:solidFill>
                   <a:schemeClr val="dk1"/>
                 </a:solidFill>
-                <a:latin typeface="Arial"/>
-                <a:ea typeface="ＭＳ Ｐゴシック"/>
-                <a:cs typeface="Arial"/>
+                <a:latin typeface="Noto Sans"/>
+                <a:ea typeface="Noto Sans CJK JP"/>
+                <a:cs typeface="Noto Sans"/>
               </a:defRPr>
             </a:lvl6pPr>
             <a:lvl7pPr lvl="6">
@@ -5837,9 +5837,9 @@
                 <a:solidFill>
                   <a:schemeClr val="dk1"/>
                 </a:solidFill>
-                <a:latin typeface="Arial"/>
-                <a:ea typeface="ＭＳ Ｐゴシック"/>
-                <a:cs typeface="Arial"/>
+                <a:latin typeface="Noto Sans"/>
+                <a:ea typeface="Noto Sans CJK JP"/>
+                <a:cs typeface="Noto Sans"/>
               </a:defRPr>
             </a:lvl7pPr>
             <a:lvl8pPr lvl="7">
@@ -5858,9 +5858,9 @@
                 <a:solidFill>
                   <a:schemeClr val="dk1"/>
                 </a:solidFill>
-                <a:latin typeface="Arial"/>
-                <a:ea typeface="ＭＳ Ｐゴシック"/>
-                <a:cs typeface="Arial"/>
+                <a:latin typeface="Noto Sans"/>
+                <a:ea typeface="Noto Sans CJK JP"/>
+                <a:cs typeface="Noto Sans"/>
               </a:defRPr>
             </a:lvl8pPr>
             <a:lvl9pPr lvl="8">
@@ -5879,17 +5879,17 @@
                 <a:solidFill>
                   <a:schemeClr val="dk1"/>
                 </a:solidFill>
-                <a:latin typeface="Arial"/>
-                <a:ea typeface="ＭＳ Ｐゴシック"/>
-                <a:cs typeface="Arial"/>
+                <a:latin typeface="Noto Sans"/>
+                <a:ea typeface="Noto Sans CJK JP"/>
+                <a:cs typeface="Noto Sans"/>
               </a:defRPr>
             </a:lvl9pPr>
           </a:lstStyle>
           <a:p>
             <a:endParaRPr lang="ja-JP">
-              <a:latin typeface="Arial"/>
-              <a:ea typeface="ＭＳ Ｐゴシック"/>
-              <a:cs typeface="Arial"/>
+              <a:latin typeface="Noto Sans"/>
+              <a:ea typeface="Noto Sans CJK JP"/>
+              <a:cs typeface="Noto Sans"/>
             </a:endParaRPr>
           </a:p>
         </p:txBody>
@@ -5941,9 +5941,9 @@
                 <a:solidFill>
                   <a:schemeClr val="dk2"/>
                 </a:solidFill>
-                <a:latin typeface="Arial"/>
-                <a:ea typeface="ＭＳ Ｐゴシック"/>
-                <a:cs typeface="Arial"/>
+                <a:latin typeface="Noto Sans"/>
+                <a:ea typeface="Noto Sans CJK JP"/>
+                <a:cs typeface="Noto Sans"/>
               </a:defRPr>
             </a:lvl1pPr>
             <a:lvl2pPr marL="482600" lvl="1" indent="-127000">
@@ -5965,9 +5965,9 @@
                 <a:solidFill>
                   <a:schemeClr val="dk2"/>
                 </a:solidFill>
-                <a:latin typeface="Arial"/>
-                <a:ea typeface="ＭＳ Ｐゴシック"/>
-                <a:cs typeface="Arial"/>
+                <a:latin typeface="Noto Sans"/>
+                <a:ea typeface="Noto Sans CJK JP"/>
+                <a:cs typeface="Noto Sans"/>
               </a:defRPr>
             </a:lvl2pPr>
             <a:lvl3pPr marL="762000" lvl="2" indent="-127000">
@@ -5989,9 +5989,9 @@
                 <a:solidFill>
                   <a:schemeClr val="dk2"/>
                 </a:solidFill>
-                <a:latin typeface="Arial"/>
-                <a:ea typeface="ＭＳ Ｐゴシック"/>
-                <a:cs typeface="Arial"/>
+                <a:latin typeface="Noto Sans"/>
+                <a:ea typeface="Noto Sans CJK JP"/>
+                <a:cs typeface="Noto Sans"/>
               </a:defRPr>
             </a:lvl3pPr>
             <a:lvl4pPr marL="1041400" lvl="3" indent="-127000">
@@ -6013,9 +6013,9 @@
                 <a:solidFill>
                   <a:schemeClr val="dk2"/>
                 </a:solidFill>
-                <a:latin typeface="Arial"/>
-                <a:ea typeface="ＭＳ Ｐゴシック"/>
-                <a:cs typeface="Arial"/>
+                <a:latin typeface="Noto Sans"/>
+                <a:ea typeface="Noto Sans CJK JP"/>
+                <a:cs typeface="Noto Sans"/>
               </a:defRPr>
             </a:lvl4pPr>
             <a:lvl5pPr marL="1320800" lvl="4" indent="-127000">
@@ -6037,9 +6037,9 @@
                 <a:solidFill>
                   <a:schemeClr val="dk2"/>
                 </a:solidFill>
-                <a:latin typeface="Arial"/>
-                <a:ea typeface="ＭＳ Ｐゴシック"/>
-                <a:cs typeface="Arial"/>
+                <a:latin typeface="Noto Sans"/>
+                <a:ea typeface="Noto Sans CJK JP"/>
+                <a:cs typeface="Noto Sans"/>
               </a:defRPr>
             </a:lvl5pPr>
             <a:lvl6pPr marL="1600200" lvl="5" indent="-127000">
@@ -6061,9 +6061,9 @@
                 <a:solidFill>
                   <a:schemeClr val="dk2"/>
                 </a:solidFill>
-                <a:latin typeface="Arial"/>
-                <a:ea typeface="ＭＳ Ｐゴシック"/>
-                <a:cs typeface="Arial"/>
+                <a:latin typeface="Noto Sans"/>
+                <a:ea typeface="Noto Sans CJK JP"/>
+                <a:cs typeface="Noto Sans"/>
               </a:defRPr>
             </a:lvl6pPr>
             <a:lvl7pPr marL="1879600" lvl="6" indent="-127000">
@@ -6085,9 +6085,9 @@
                 <a:solidFill>
                   <a:schemeClr val="dk2"/>
                 </a:solidFill>
-                <a:latin typeface="Arial"/>
-                <a:ea typeface="ＭＳ Ｐゴシック"/>
-                <a:cs typeface="Arial"/>
+                <a:latin typeface="Noto Sans"/>
+                <a:ea typeface="Noto Sans CJK JP"/>
+                <a:cs typeface="Noto Sans"/>
               </a:defRPr>
             </a:lvl7pPr>
             <a:lvl8pPr marL="2159000" lvl="7" indent="-127000">
@@ -6109,9 +6109,9 @@
                 <a:solidFill>
                   <a:schemeClr val="dk2"/>
                 </a:solidFill>
-                <a:latin typeface="Arial"/>
-                <a:ea typeface="ＭＳ Ｐゴシック"/>
-                <a:cs typeface="Arial"/>
+                <a:latin typeface="Noto Sans"/>
+                <a:ea typeface="Noto Sans CJK JP"/>
+                <a:cs typeface="Noto Sans"/>
               </a:defRPr>
             </a:lvl8pPr>
             <a:lvl9pPr marL="2438400" lvl="8" indent="-127000">
@@ -6133,17 +6133,17 @@
                 <a:solidFill>
                   <a:schemeClr val="dk2"/>
                 </a:solidFill>
-                <a:latin typeface="Arial"/>
-                <a:ea typeface="ＭＳ Ｐゴシック"/>
-                <a:cs typeface="Arial"/>
+                <a:latin typeface="Noto Sans"/>
+                <a:ea typeface="Noto Sans CJK JP"/>
+                <a:cs typeface="Noto Sans"/>
               </a:defRPr>
             </a:lvl9pPr>
           </a:lstStyle>
           <a:p>
             <a:endParaRPr lang="ja-JP">
-              <a:latin typeface="Arial"/>
-              <a:ea typeface="ＭＳ Ｐゴシック"/>
-              <a:cs typeface="Arial"/>
+              <a:latin typeface="Noto Sans"/>
+              <a:ea typeface="Noto Sans CJK JP"/>
+              <a:cs typeface="Noto Sans"/>
             </a:endParaRPr>
           </a:p>
         </p:txBody>
@@ -6182,9 +6182,9 @@
                 <a:solidFill>
                   <a:schemeClr val="dk2"/>
                 </a:solidFill>
-                <a:latin typeface="Arial"/>
-                <a:ea typeface="ＭＳ Ｐゴシック"/>
-                <a:cs typeface="Arial"/>
+                <a:latin typeface="Noto Sans"/>
+                <a:ea typeface="Noto Sans CJK JP"/>
+                <a:cs typeface="Noto Sans"/>
               </a:defRPr>
             </a:lvl1pPr>
             <a:lvl2pPr lvl="1" algn="r">
@@ -6193,9 +6193,9 @@
                 <a:solidFill>
                   <a:schemeClr val="dk2"/>
                 </a:solidFill>
-                <a:latin typeface="Arial"/>
-                <a:ea typeface="ＭＳ Ｐゴシック"/>
-                <a:cs typeface="Arial"/>
+                <a:latin typeface="Noto Sans"/>
+                <a:ea typeface="Noto Sans CJK JP"/>
+                <a:cs typeface="Noto Sans"/>
               </a:defRPr>
             </a:lvl2pPr>
             <a:lvl3pPr lvl="2" algn="r">
@@ -6204,9 +6204,9 @@
                 <a:solidFill>
                   <a:schemeClr val="dk2"/>
                 </a:solidFill>
-                <a:latin typeface="Arial"/>
-                <a:ea typeface="ＭＳ Ｐゴシック"/>
-                <a:cs typeface="Arial"/>
+                <a:latin typeface="Noto Sans"/>
+                <a:ea typeface="Noto Sans CJK JP"/>
+                <a:cs typeface="Noto Sans"/>
               </a:defRPr>
             </a:lvl3pPr>
             <a:lvl4pPr lvl="3" algn="r">
@@ -6215,9 +6215,9 @@
                 <a:solidFill>
                   <a:schemeClr val="dk2"/>
                 </a:solidFill>
-                <a:latin typeface="Arial"/>
-                <a:ea typeface="ＭＳ Ｐゴシック"/>
-                <a:cs typeface="Arial"/>
+                <a:latin typeface="Noto Sans"/>
+                <a:ea typeface="Noto Sans CJK JP"/>
+                <a:cs typeface="Noto Sans"/>
               </a:defRPr>
             </a:lvl4pPr>
             <a:lvl5pPr lvl="4" algn="r">
@@ -6226,9 +6226,9 @@
                 <a:solidFill>
                   <a:schemeClr val="dk2"/>
                 </a:solidFill>
-                <a:latin typeface="Arial"/>
-                <a:ea typeface="ＭＳ Ｐゴシック"/>
-                <a:cs typeface="Arial"/>
+                <a:latin typeface="Noto Sans"/>
+                <a:ea typeface="Noto Sans CJK JP"/>
+                <a:cs typeface="Noto Sans"/>
               </a:defRPr>
             </a:lvl5pPr>
             <a:lvl6pPr lvl="5" algn="r">
@@ -6237,9 +6237,9 @@
                 <a:solidFill>
                   <a:schemeClr val="dk2"/>
                 </a:solidFill>
-                <a:latin typeface="Arial"/>
-                <a:ea typeface="ＭＳ Ｐゴシック"/>
-                <a:cs typeface="Arial"/>
+                <a:latin typeface="Noto Sans"/>
+                <a:ea typeface="Noto Sans CJK JP"/>
+                <a:cs typeface="Noto Sans"/>
               </a:defRPr>
             </a:lvl6pPr>
             <a:lvl7pPr lvl="6" algn="r">
@@ -6248,9 +6248,9 @@
                 <a:solidFill>
                   <a:schemeClr val="dk2"/>
                 </a:solidFill>
-                <a:latin typeface="Arial"/>
-                <a:ea typeface="ＭＳ Ｐゴシック"/>
-                <a:cs typeface="Arial"/>
+                <a:latin typeface="Noto Sans"/>
+                <a:ea typeface="Noto Sans CJK JP"/>
+                <a:cs typeface="Noto Sans"/>
               </a:defRPr>
             </a:lvl7pPr>
             <a:lvl8pPr lvl="7" algn="r">
@@ -6259,9 +6259,9 @@
                 <a:solidFill>
                   <a:schemeClr val="dk2"/>
                 </a:solidFill>
-                <a:latin typeface="Arial"/>
-                <a:ea typeface="ＭＳ Ｐゴシック"/>
-                <a:cs typeface="Arial"/>
+                <a:latin typeface="Noto Sans"/>
+                <a:ea typeface="Noto Sans CJK JP"/>
+                <a:cs typeface="Noto Sans"/>
               </a:defRPr>
             </a:lvl8pPr>
             <a:lvl9pPr lvl="8" algn="r">
@@ -6270,9 +6270,9 @@
                 <a:solidFill>
                   <a:schemeClr val="dk2"/>
                 </a:solidFill>
-                <a:latin typeface="Arial"/>
-                <a:ea typeface="ＭＳ Ｐゴシック"/>
-                <a:cs typeface="Arial"/>
+                <a:latin typeface="Noto Sans"/>
+                <a:ea typeface="Noto Sans CJK JP"/>
+                <a:cs typeface="Noto Sans"/>
               </a:defRPr>
             </a:lvl9pPr>
           </a:lstStyle>
@@ -6288,16 +6288,16 @@
             </a:pPr>
             <a:fld id="{00000000-1234-1234-1234-123412341234}" type="slidenum">
               <a:rPr lang="ja-JP">
-                <a:latin typeface="Arial"/>
-                <a:ea typeface="ＭＳ Ｐゴシック"/>
-                <a:cs typeface="Arial"/>
+                <a:latin typeface="Noto Sans"/>
+                <a:ea typeface="Noto Sans CJK JP"/>
+                <a:cs typeface="Noto Sans"/>
               </a:rPr>
               <a:t>‹#›</a:t>
             </a:fld>
             <a:endParaRPr lang="ja-JP">
-              <a:latin typeface="Arial"/>
-              <a:ea typeface="ＭＳ Ｐゴシック"/>
-              <a:cs typeface="Arial"/>
+              <a:latin typeface="Noto Sans"/>
+              <a:ea typeface="Noto Sans CJK JP"/>
+              <a:cs typeface="Noto Sans"/>
             </a:endParaRPr>
           </a:p>
         </p:txBody>
@@ -6343,14 +6343,14 @@
         <a:buClr>
           <a:schemeClr val="dk1"/>
         </a:buClr>
-        <a:buFont typeface="Arial"/>
+        <a:buFont typeface="Noto Sans CJK JP"/>
         <a:defRPr sz="1400" b="0" i="0" u="none" strike="noStrike" cap="none" lang="ja-JP">
           <a:solidFill>
             <a:schemeClr val="dk1"/>
           </a:solidFill>
-          <a:latin typeface="Arial"/>
-          <a:ea typeface="ＭＳ Ｐゴシック"/>
-          <a:cs typeface="Arial"/>
+          <a:latin typeface="Noto Sans"/>
+          <a:ea typeface="Noto Sans CJK JP"/>
+          <a:cs typeface="Noto Sans"/>
           <a:sym typeface="Arial"/>
         </a:defRPr>
       </a:lvl1pPr>
@@ -6367,14 +6367,14 @@
         <a:buClr>
           <a:schemeClr val="dk1"/>
         </a:buClr>
-        <a:buFont typeface="Arial"/>
+        <a:buFont typeface="Noto Sans CJK JP"/>
         <a:defRPr sz="1400" b="0" i="0" u="none" strike="noStrike" cap="none" lang="ja-JP">
           <a:solidFill>
             <a:schemeClr val="dk1"/>
           </a:solidFill>
-          <a:latin typeface="Arial"/>
-          <a:ea typeface="ＭＳ Ｐゴシック"/>
-          <a:cs typeface="Arial"/>
+          <a:latin typeface="Noto Sans"/>
+          <a:ea typeface="Noto Sans CJK JP"/>
+          <a:cs typeface="Noto Sans"/>
           <a:sym typeface="Arial"/>
         </a:defRPr>
       </a:lvl2pPr>
@@ -6391,14 +6391,14 @@
         <a:buClr>
           <a:schemeClr val="dk1"/>
         </a:buClr>
-        <a:buFont typeface="Arial"/>
+        <a:buFont typeface="Noto Sans CJK JP"/>
         <a:defRPr sz="1400" b="0" i="0" u="none" strike="noStrike" cap="none" lang="ja-JP">
           <a:solidFill>
             <a:schemeClr val="dk1"/>
           </a:solidFill>
-          <a:latin typeface="Arial"/>
-          <a:ea typeface="ＭＳ Ｐゴシック"/>
-          <a:cs typeface="Arial"/>
+          <a:latin typeface="Noto Sans"/>
+          <a:ea typeface="Noto Sans CJK JP"/>
+          <a:cs typeface="Noto Sans"/>
           <a:sym typeface="Arial"/>
         </a:defRPr>
       </a:lvl3pPr>
@@ -6415,14 +6415,14 @@
         <a:buClr>
           <a:schemeClr val="dk1"/>
         </a:buClr>
-        <a:buFont typeface="Arial"/>
+        <a:buFont typeface="Noto Sans CJK JP"/>
         <a:defRPr sz="1400" b="0" i="0" u="none" strike="noStrike" cap="none" lang="ja-JP">
           <a:solidFill>
             <a:schemeClr val="dk1"/>
           </a:solidFill>
-          <a:latin typeface="Arial"/>
-          <a:ea typeface="ＭＳ Ｐゴシック"/>
-          <a:cs typeface="Arial"/>
+          <a:latin typeface="Noto Sans"/>
+          <a:ea typeface="Noto Sans CJK JP"/>
+          <a:cs typeface="Noto Sans"/>
           <a:sym typeface="Arial"/>
         </a:defRPr>
       </a:lvl4pPr>
@@ -6439,14 +6439,14 @@
         <a:buClr>
           <a:schemeClr val="dk1"/>
         </a:buClr>
-        <a:buFont typeface="Arial"/>
+        <a:buFont typeface="Noto Sans CJK JP"/>
         <a:defRPr sz="1400" b="0" i="0" u="none" strike="noStrike" cap="none" lang="ja-JP">
           <a:solidFill>
             <a:schemeClr val="dk1"/>
           </a:solidFill>
-          <a:latin typeface="Arial"/>
-          <a:ea typeface="ＭＳ Ｐゴシック"/>
-          <a:cs typeface="Arial"/>
+          <a:latin typeface="Noto Sans"/>
+          <a:ea typeface="Noto Sans CJK JP"/>
+          <a:cs typeface="Noto Sans"/>
           <a:sym typeface="Arial"/>
         </a:defRPr>
       </a:lvl5pPr>
@@ -6463,14 +6463,14 @@
         <a:buClr>
           <a:schemeClr val="dk1"/>
         </a:buClr>
-        <a:buFont typeface="Arial"/>
+        <a:buFont typeface="Noto Sans CJK JP"/>
         <a:defRPr sz="1400" b="0" i="0" u="none" strike="noStrike" cap="none" lang="ja-JP">
           <a:solidFill>
             <a:schemeClr val="dk1"/>
           </a:solidFill>
-          <a:latin typeface="Arial"/>
-          <a:ea typeface="ＭＳ Ｐゴシック"/>
-          <a:cs typeface="Arial"/>
+          <a:latin typeface="Noto Sans"/>
+          <a:ea typeface="Noto Sans CJK JP"/>
+          <a:cs typeface="Noto Sans"/>
           <a:sym typeface="Arial"/>
         </a:defRPr>
       </a:lvl6pPr>
@@ -6487,14 +6487,14 @@
         <a:buClr>
           <a:schemeClr val="dk1"/>
         </a:buClr>
-        <a:buFont typeface="Arial"/>
+        <a:buFont typeface="Noto Sans CJK JP"/>
         <a:defRPr sz="1400" b="0" i="0" u="none" strike="noStrike" cap="none" lang="ja-JP">
           <a:solidFill>
             <a:schemeClr val="dk1"/>
           </a:solidFill>
-          <a:latin typeface="Arial"/>
-          <a:ea typeface="ＭＳ Ｐゴシック"/>
-          <a:cs typeface="Arial"/>
+          <a:latin typeface="Noto Sans"/>
+          <a:ea typeface="Noto Sans CJK JP"/>
+          <a:cs typeface="Noto Sans"/>
           <a:sym typeface="Arial"/>
         </a:defRPr>
       </a:lvl7pPr>
@@ -6511,14 +6511,14 @@
         <a:buClr>
           <a:schemeClr val="dk1"/>
         </a:buClr>
-        <a:buFont typeface="Arial"/>
+        <a:buFont typeface="Noto Sans CJK JP"/>
         <a:defRPr sz="1400" b="0" i="0" u="none" strike="noStrike" cap="none" lang="ja-JP">
           <a:solidFill>
             <a:schemeClr val="dk1"/>
           </a:solidFill>
-          <a:latin typeface="Arial"/>
-          <a:ea typeface="ＭＳ Ｐゴシック"/>
-          <a:cs typeface="Arial"/>
+          <a:latin typeface="Noto Sans"/>
+          <a:ea typeface="Noto Sans CJK JP"/>
+          <a:cs typeface="Noto Sans"/>
           <a:sym typeface="Arial"/>
         </a:defRPr>
       </a:lvl8pPr>
@@ -6535,14 +6535,14 @@
         <a:buClr>
           <a:schemeClr val="dk1"/>
         </a:buClr>
-        <a:buFont typeface="Arial"/>
+        <a:buFont typeface="Noto Sans CJK JP"/>
         <a:defRPr sz="1400" b="0" i="0" u="none" strike="noStrike" cap="none" lang="ja-JP">
           <a:solidFill>
             <a:schemeClr val="dk1"/>
           </a:solidFill>
-          <a:latin typeface="Arial"/>
-          <a:ea typeface="ＭＳ Ｐゴシック"/>
-          <a:cs typeface="Arial"/>
+          <a:latin typeface="Noto Sans"/>
+          <a:ea typeface="Noto Sans CJK JP"/>
+          <a:cs typeface="Noto Sans"/>
           <a:sym typeface="Arial"/>
         </a:defRPr>
       </a:lvl9pPr>
@@ -6564,9 +6564,9 @@
           <a:solidFill>
             <a:srgbClr val="303437"/>
           </a:solidFill>
-          <a:latin typeface="Arial"/>
-          <a:ea typeface="ＭＳ Ｐゴシック"/>
-          <a:cs typeface="Arial"/>
+          <a:latin typeface="Noto Sans"/>
+          <a:ea typeface="Noto Sans CJK JP"/>
+          <a:cs typeface="Noto Sans"/>
         </a:defRPr>
       </a:lvl1pPr>
       <a:lvl2pPr marL="914400" lvl="1" indent="-355600">
@@ -6585,9 +6585,9 @@
           <a:solidFill>
             <a:srgbClr val="303437"/>
           </a:solidFill>
-          <a:latin typeface="Arial"/>
-          <a:ea typeface="ＭＳ Ｐゴシック"/>
-          <a:cs typeface="Arial"/>
+          <a:latin typeface="Noto Sans"/>
+          <a:ea typeface="Noto Sans CJK JP"/>
+          <a:cs typeface="Noto Sans"/>
         </a:defRPr>
       </a:lvl2pPr>
       <a:lvl3pPr marL="1371600" lvl="2" indent="-355600">
@@ -6606,9 +6606,9 @@
           <a:solidFill>
             <a:srgbClr val="303437"/>
           </a:solidFill>
-          <a:latin typeface="Arial"/>
-          <a:ea typeface="ＭＳ Ｐゴシック"/>
-          <a:cs typeface="Arial"/>
+          <a:latin typeface="Noto Sans"/>
+          <a:ea typeface="Noto Sans CJK JP"/>
+          <a:cs typeface="Noto Sans"/>
         </a:defRPr>
       </a:lvl3pPr>
       <a:lvl4pPr marL="1828800" lvl="3" indent="-368300">
@@ -6627,9 +6627,9 @@
           <a:solidFill>
             <a:srgbClr val="303437"/>
           </a:solidFill>
-          <a:latin typeface="Arial"/>
-          <a:ea typeface="ＭＳ Ｐゴシック"/>
-          <a:cs typeface="Arial"/>
+          <a:latin typeface="Noto Sans"/>
+          <a:ea typeface="Noto Sans CJK JP"/>
+          <a:cs typeface="Noto Sans"/>
         </a:defRPr>
       </a:lvl4pPr>
       <a:lvl5pPr marL="2286000" lvl="4" indent="-355600">
@@ -6648,9 +6648,9 @@
           <a:solidFill>
             <a:srgbClr val="303437"/>
           </a:solidFill>
-          <a:latin typeface="Arial"/>
-          <a:ea typeface="ＭＳ Ｐゴシック"/>
-          <a:cs typeface="Arial"/>
+          <a:latin typeface="Noto Sans"/>
+          <a:ea typeface="Noto Sans CJK JP"/>
+          <a:cs typeface="Noto Sans"/>
         </a:defRPr>
       </a:lvl5pPr>
       <a:lvl6pPr marL="2743200" lvl="5" indent="-355600">
@@ -6669,9 +6669,9 @@
           <a:solidFill>
             <a:srgbClr val="303437"/>
           </a:solidFill>
-          <a:latin typeface="Arial"/>
-          <a:ea typeface="ＭＳ Ｐゴシック"/>
-          <a:cs typeface="Arial"/>
+          <a:latin typeface="Noto Sans"/>
+          <a:ea typeface="Noto Sans CJK JP"/>
+          <a:cs typeface="Noto Sans"/>
         </a:defRPr>
       </a:lvl6pPr>
       <a:lvl7pPr marL="3200400" lvl="6" indent="-355600">
@@ -6690,9 +6690,9 @@
           <a:solidFill>
             <a:srgbClr val="303437"/>
           </a:solidFill>
-          <a:latin typeface="Arial"/>
-          <a:ea typeface="ＭＳ Ｐゴシック"/>
-          <a:cs typeface="Arial"/>
+          <a:latin typeface="Noto Sans"/>
+          <a:ea typeface="Noto Sans CJK JP"/>
+          <a:cs typeface="Noto Sans"/>
         </a:defRPr>
       </a:lvl7pPr>
       <a:lvl8pPr marL="3657600" lvl="7" indent="-355600">
@@ -6711,9 +6711,9 @@
           <a:solidFill>
             <a:srgbClr val="303437"/>
           </a:solidFill>
-          <a:latin typeface="Arial"/>
-          <a:ea typeface="ＭＳ Ｐゴシック"/>
-          <a:cs typeface="Arial"/>
+          <a:latin typeface="Noto Sans"/>
+          <a:ea typeface="Noto Sans CJK JP"/>
+          <a:cs typeface="Noto Sans"/>
         </a:defRPr>
       </a:lvl8pPr>
       <a:lvl9pPr marL="4114800" lvl="8" indent="-355600">
@@ -6732,9 +6732,9 @@
           <a:solidFill>
             <a:srgbClr val="303437"/>
           </a:solidFill>
-          <a:latin typeface="Arial"/>
-          <a:ea typeface="ＭＳ Ｐゴシック"/>
-          <a:cs typeface="Arial"/>
+          <a:latin typeface="Noto Sans"/>
+          <a:ea typeface="Noto Sans CJK JP"/>
+          <a:cs typeface="Noto Sans"/>
         </a:defRPr>
       </a:lvl9pPr>
     </p:bodyStyle>
@@ -6763,14 +6763,14 @@
         <a:buClr>
           <a:schemeClr val="dk1"/>
         </a:buClr>
-        <a:buFont typeface="Arial"/>
+        <a:buFont typeface="Noto Sans CJK JP"/>
         <a:defRPr sz="1400" b="0" i="0" u="none" strike="noStrike" cap="none" lang="ja-JP">
           <a:solidFill>
             <a:schemeClr val="dk1"/>
           </a:solidFill>
-          <a:latin typeface="Arial"/>
-          <a:ea typeface="ＭＳ Ｐゴシック"/>
-          <a:cs typeface="Arial"/>
+          <a:latin typeface="Noto Sans"/>
+          <a:ea typeface="Noto Sans CJK JP"/>
+          <a:cs typeface="Noto Sans"/>
           <a:sym typeface="Arial"/>
         </a:defRPr>
       </a:lvl1pPr>
@@ -6787,14 +6787,14 @@
         <a:buClr>
           <a:schemeClr val="dk1"/>
         </a:buClr>
-        <a:buFont typeface="Arial"/>
+        <a:buFont typeface="Noto Sans CJK JP"/>
         <a:defRPr sz="1400" b="0" i="0" u="none" strike="noStrike" cap="none" lang="ja-JP">
           <a:solidFill>
             <a:schemeClr val="dk1"/>
           </a:solidFill>
-          <a:latin typeface="Arial"/>
-          <a:ea typeface="ＭＳ Ｐゴシック"/>
-          <a:cs typeface="Arial"/>
+          <a:latin typeface="Noto Sans"/>
+          <a:ea typeface="Noto Sans CJK JP"/>
+          <a:cs typeface="Noto Sans"/>
           <a:sym typeface="Arial"/>
         </a:defRPr>
       </a:lvl2pPr>
@@ -6811,14 +6811,14 @@
         <a:buClr>
           <a:schemeClr val="dk1"/>
         </a:buClr>
-        <a:buFont typeface="Arial"/>
+        <a:buFont typeface="Noto Sans CJK JP"/>
         <a:defRPr sz="1400" b="0" i="0" u="none" strike="noStrike" cap="none" lang="ja-JP">
           <a:solidFill>
             <a:schemeClr val="dk1"/>
           </a:solidFill>
-          <a:latin typeface="Arial"/>
-          <a:ea typeface="ＭＳ Ｐゴシック"/>
-          <a:cs typeface="Arial"/>
+          <a:latin typeface="Noto Sans"/>
+          <a:ea typeface="Noto Sans CJK JP"/>
+          <a:cs typeface="Noto Sans"/>
           <a:sym typeface="Arial"/>
         </a:defRPr>
       </a:lvl3pPr>
@@ -6835,14 +6835,14 @@
         <a:buClr>
           <a:schemeClr val="dk1"/>
         </a:buClr>
-        <a:buFont typeface="Arial"/>
+        <a:buFont typeface="Noto Sans CJK JP"/>
         <a:defRPr sz="1400" b="0" i="0" u="none" strike="noStrike" cap="none" lang="ja-JP">
           <a:solidFill>
             <a:schemeClr val="dk1"/>
           </a:solidFill>
-          <a:latin typeface="Arial"/>
-          <a:ea typeface="ＭＳ Ｐゴシック"/>
-          <a:cs typeface="Arial"/>
+          <a:latin typeface="Noto Sans"/>
+          <a:ea typeface="Noto Sans CJK JP"/>
+          <a:cs typeface="Noto Sans"/>
           <a:sym typeface="Arial"/>
         </a:defRPr>
       </a:lvl4pPr>
@@ -6859,14 +6859,14 @@
         <a:buClr>
           <a:schemeClr val="dk1"/>
         </a:buClr>
-        <a:buFont typeface="Arial"/>
+        <a:buFont typeface="Noto Sans CJK JP"/>
         <a:defRPr sz="1400" b="0" i="0" u="none" strike="noStrike" cap="none" lang="ja-JP">
           <a:solidFill>
             <a:schemeClr val="dk1"/>
           </a:solidFill>
-          <a:latin typeface="Arial"/>
-          <a:ea typeface="ＭＳ Ｐゴシック"/>
-          <a:cs typeface="Arial"/>
+          <a:latin typeface="Noto Sans"/>
+          <a:ea typeface="Noto Sans CJK JP"/>
+          <a:cs typeface="Noto Sans"/>
           <a:sym typeface="Arial"/>
         </a:defRPr>
       </a:lvl5pPr>
@@ -6883,14 +6883,14 @@
         <a:buClr>
           <a:schemeClr val="dk1"/>
         </a:buClr>
-        <a:buFont typeface="Arial"/>
+        <a:buFont typeface="Noto Sans CJK JP"/>
         <a:defRPr sz="1400" b="0" i="0" u="none" strike="noStrike" cap="none" lang="ja-JP">
           <a:solidFill>
             <a:schemeClr val="dk1"/>
           </a:solidFill>
-          <a:latin typeface="Arial"/>
-          <a:ea typeface="ＭＳ Ｐゴシック"/>
-          <a:cs typeface="Arial"/>
+          <a:latin typeface="Noto Sans"/>
+          <a:ea typeface="Noto Sans CJK JP"/>
+          <a:cs typeface="Noto Sans"/>
           <a:sym typeface="Arial"/>
         </a:defRPr>
       </a:lvl6pPr>
@@ -6907,14 +6907,14 @@
         <a:buClr>
           <a:schemeClr val="dk1"/>
         </a:buClr>
-        <a:buFont typeface="Arial"/>
+        <a:buFont typeface="Noto Sans CJK JP"/>
         <a:defRPr sz="1400" b="0" i="0" u="none" strike="noStrike" cap="none" lang="ja-JP">
           <a:solidFill>
             <a:schemeClr val="dk1"/>
           </a:solidFill>
-          <a:latin typeface="Arial"/>
-          <a:ea typeface="ＭＳ Ｐゴシック"/>
-          <a:cs typeface="Arial"/>
+          <a:latin typeface="Noto Sans"/>
+          <a:ea typeface="Noto Sans CJK JP"/>
+          <a:cs typeface="Noto Sans"/>
           <a:sym typeface="Arial"/>
         </a:defRPr>
       </a:lvl7pPr>
@@ -6931,14 +6931,14 @@
         <a:buClr>
           <a:schemeClr val="dk1"/>
         </a:buClr>
-        <a:buFont typeface="Arial"/>
+        <a:buFont typeface="Noto Sans CJK JP"/>
         <a:defRPr sz="1400" b="0" i="0" u="none" strike="noStrike" cap="none" lang="ja-JP">
           <a:solidFill>
             <a:schemeClr val="dk1"/>
           </a:solidFill>
-          <a:latin typeface="Arial"/>
-          <a:ea typeface="ＭＳ Ｐゴシック"/>
-          <a:cs typeface="Arial"/>
+          <a:latin typeface="Noto Sans"/>
+          <a:ea typeface="Noto Sans CJK JP"/>
+          <a:cs typeface="Noto Sans"/>
           <a:sym typeface="Arial"/>
         </a:defRPr>
       </a:lvl8pPr>
@@ -6955,14 +6955,14 @@
         <a:buClr>
           <a:schemeClr val="dk1"/>
         </a:buClr>
-        <a:buFont typeface="Arial"/>
+        <a:buFont typeface="Noto Sans CJK JP"/>
         <a:defRPr sz="1400" b="0" i="0" u="none" strike="noStrike" cap="none" lang="ja-JP">
           <a:solidFill>
             <a:schemeClr val="dk1"/>
           </a:solidFill>
-          <a:latin typeface="Arial"/>
-          <a:ea typeface="ＭＳ Ｐゴシック"/>
-          <a:cs typeface="Arial"/>
+          <a:latin typeface="Noto Sans"/>
+          <a:ea typeface="Noto Sans CJK JP"/>
+          <a:cs typeface="Noto Sans"/>
           <a:sym typeface="Arial"/>
         </a:defRPr>
       </a:lvl9pPr>
@@ -7007,16 +7007,16 @@
           <a:p>
             <a:pPr>
               <a:defRPr lang="ja-JP">
-                <a:latin typeface="Arial"/>
-                <a:ea typeface="ＭＳ Ｐゴシック"/>
-                <a:cs typeface="Arial"/>
+                <a:latin typeface="Noto Sans"/>
+                <a:ea typeface="Noto Sans CJK JP"/>
+                <a:cs typeface="Noto Sans"/>
               </a:defRPr>
             </a:pPr>
             <a:r>
               <a:rPr lang="ja-JP" dirty="0">
-                <a:latin typeface="Arial"/>
-                <a:ea typeface="ＭＳ Ｐゴシック"/>
-                <a:cs typeface="Arial"/>
+                <a:latin typeface="Noto Sans"/>
+                <a:ea typeface="Noto Sans CJK JP"/>
+                <a:cs typeface="Noto Sans"/>
               </a:rPr>
               <a:t>Developing and Applying a Systematic Classification Framework</a:t>
             </a:r>
@@ -7045,16 +7045,16 @@
           <a:p>
             <a:pPr>
               <a:defRPr lang="ja-JP">
-                <a:latin typeface="Arial"/>
-                <a:ea typeface="ＭＳ Ｐゴシック"/>
-                <a:cs typeface="Arial"/>
+                <a:latin typeface="Noto Sans"/>
+                <a:ea typeface="Noto Sans CJK JP"/>
+                <a:cs typeface="Noto Sans"/>
               </a:defRPr>
             </a:pPr>
             <a:r>
               <a:rPr lang="ja-JP" dirty="0">
-                <a:latin typeface="Arial"/>
-                <a:ea typeface="ＭＳ Ｐゴシック"/>
-                <a:cs typeface="Arial"/>
+                <a:latin typeface="Noto Sans"/>
+                <a:ea typeface="Noto Sans CJK JP"/>
+                <a:cs typeface="Noto Sans"/>
               </a:rPr>
               <a:t>Presenter Name, Co-author Name</a:t>
             </a:r>
@@ -7090,16 +7090,16 @@
                 <a:solidFill>
                   <a:srgbClr val="626669"/>
                 </a:solidFill>
-                <a:latin typeface="Arial"/>
-                <a:ea typeface="ＭＳ Ｐゴシック"/>
-                <a:cs typeface="Arial"/>
+                <a:latin typeface="Noto Sans"/>
+                <a:ea typeface="Noto Sans CJK JP"/>
+                <a:cs typeface="Noto Sans"/>
               </a:defRPr>
             </a:pPr>
             <a:r>
               <a:rPr lang="ja-JP">
-                <a:latin typeface="Arial"/>
-                <a:ea typeface="ＭＳ Ｐゴシック"/>
-                <a:cs typeface="Arial"/>
+                <a:latin typeface="Noto Sans"/>
+                <a:ea typeface="Noto Sans CJK JP"/>
+                <a:cs typeface="Noto Sans"/>
               </a:rPr>
               <a:t>所属　［所属］</a:t>
             </a:r>
@@ -7135,16 +7135,16 @@
                 <a:solidFill>
                   <a:srgbClr val="626669"/>
                 </a:solidFill>
-                <a:latin typeface="Arial"/>
-                <a:ea typeface="ＭＳ Ｐゴシック"/>
-                <a:cs typeface="Arial"/>
+                <a:latin typeface="Noto Sans"/>
+                <a:ea typeface="Noto Sans CJK JP"/>
+                <a:cs typeface="Noto Sans"/>
               </a:defRPr>
             </a:pPr>
             <a:r>
               <a:rPr lang="ja-JP">
-                <a:latin typeface="Arial"/>
-                <a:ea typeface="ＭＳ Ｐゴシック"/>
-                <a:cs typeface="Arial"/>
+                <a:latin typeface="Noto Sans"/>
+                <a:ea typeface="Noto Sans CJK JP"/>
+                <a:cs typeface="Noto Sans"/>
               </a:rPr>
               <a:t>氏名　［氏名］</a:t>
             </a:r>
@@ -7185,16 +7185,16 @@
                 <a:solidFill>
                   <a:srgbClr val="626669"/>
                 </a:solidFill>
-                <a:latin typeface="Arial"/>
-                <a:ea typeface="ＭＳ Ｐゴシック"/>
-                <a:cs typeface="Arial"/>
+                <a:latin typeface="Noto Sans"/>
+                <a:ea typeface="Noto Sans CJK JP"/>
+                <a:cs typeface="Noto Sans"/>
               </a:defRPr>
             </a:pPr>
             <a:r>
               <a:rPr lang="ja-JP">
-                <a:latin typeface="Arial"/>
-                <a:ea typeface="ＭＳ Ｐゴシック"/>
-                <a:cs typeface="Arial"/>
+                <a:latin typeface="Noto Sans"/>
+                <a:ea typeface="Noto Sans CJK JP"/>
+                <a:cs typeface="Noto Sans"/>
               </a:rPr>
               <a:t>作成日　YYYY-MM-DD</a:t>
             </a:r>
@@ -7253,9 +7253,9 @@
           <a:p>
             <a:pPr/>
             <a:endParaRPr lang="ja-JP">
-              <a:latin typeface="Arial"/>
-              <a:ea typeface="ＭＳ Ｐゴシック"/>
-              <a:cs typeface="Arial"/>
+              <a:latin typeface="Noto Sans"/>
+              <a:ea typeface="Noto Sans CJK JP"/>
+              <a:cs typeface="Noto Sans"/>
             </a:endParaRPr>
           </a:p>
         </p:txBody>
@@ -7309,9 +7309,9 @@
                   <a:lumMod val="75000"/>
                 </a:schemeClr>
               </a:solidFill>
-              <a:latin typeface="Arial"/>
-              <a:ea typeface="ＭＳ Ｐゴシック"/>
-              <a:cs typeface="Arial"/>
+              <a:latin typeface="Noto Sans"/>
+              <a:ea typeface="Noto Sans CJK JP"/>
+              <a:cs typeface="Noto Sans"/>
             </a:endParaRPr>
           </a:p>
         </p:txBody>
@@ -7338,9 +7338,9 @@
               <a:solidFill>
                 <a:schemeClr val="bg2"/>
               </a:solidFill>
-              <a:latin typeface="Arial"/>
-              <a:ea typeface="ＭＳ Ｐゴシック"/>
-              <a:cs typeface="Arial"/>
+              <a:latin typeface="Noto Sans"/>
+              <a:ea typeface="Noto Sans CJK JP"/>
+              <a:cs typeface="Noto Sans"/>
             </a:endParaRPr>
           </a:p>
         </p:txBody>
@@ -7377,9 +7377,9 @@
               </a:spcAft>
             </a:pPr>
             <a:endParaRPr lang="ja-JP" dirty="0">
-              <a:latin typeface="Arial"/>
-              <a:ea typeface="ＭＳ Ｐゴシック"/>
-              <a:cs typeface="Arial"/>
+              <a:latin typeface="Noto Sans"/>
+              <a:ea typeface="Noto Sans CJK JP"/>
+              <a:cs typeface="Noto Sans"/>
             </a:endParaRPr>
           </a:p>
         </p:txBody>
@@ -7428,9 +7428,9 @@
           <a:p>
             <a:pPr/>
             <a:endParaRPr lang="ja-JP" dirty="0">
-              <a:latin typeface="Arial"/>
-              <a:ea typeface="ＭＳ Ｐゴシック"/>
-              <a:cs typeface="Arial"/>
+              <a:latin typeface="Noto Sans"/>
+              <a:ea typeface="Noto Sans CJK JP"/>
+              <a:cs typeface="Noto Sans"/>
             </a:endParaRPr>
           </a:p>
         </p:txBody>
@@ -7467,9 +7467,9 @@
               </a:spcAft>
             </a:pPr>
             <a:endParaRPr lang="ja-JP" dirty="0">
-              <a:latin typeface="Arial"/>
-              <a:ea typeface="ＭＳ Ｐゴシック"/>
-              <a:cs typeface="Arial"/>
+              <a:latin typeface="Noto Sans"/>
+              <a:ea typeface="Noto Sans CJK JP"/>
+              <a:cs typeface="Noto Sans"/>
             </a:endParaRPr>
           </a:p>
         </p:txBody>
@@ -7518,9 +7518,9 @@
           <a:p>
             <a:pPr/>
             <a:endParaRPr lang="ja-JP" dirty="0">
-              <a:latin typeface="Arial"/>
-              <a:ea typeface="ＭＳ Ｐゴシック"/>
-              <a:cs typeface="Arial"/>
+              <a:latin typeface="Noto Sans"/>
+              <a:ea typeface="Noto Sans CJK JP"/>
+              <a:cs typeface="Noto Sans"/>
             </a:endParaRPr>
           </a:p>
         </p:txBody>
@@ -7557,9 +7557,9 @@
               </a:spcAft>
             </a:pPr>
             <a:endParaRPr lang="ja-JP" dirty="0">
-              <a:latin typeface="Arial"/>
-              <a:ea typeface="ＭＳ Ｐゴシック"/>
-              <a:cs typeface="Arial"/>
+              <a:latin typeface="Noto Sans"/>
+              <a:ea typeface="Noto Sans CJK JP"/>
+              <a:cs typeface="Noto Sans"/>
             </a:endParaRPr>
           </a:p>
         </p:txBody>
@@ -7606,9 +7606,9 @@
           <a:p>
             <a:pPr/>
             <a:endParaRPr lang="ja-JP" dirty="0">
-              <a:latin typeface="Arial"/>
-              <a:ea typeface="ＭＳ Ｐゴシック"/>
-              <a:cs typeface="Arial"/>
+              <a:latin typeface="Noto Sans"/>
+              <a:ea typeface="Noto Sans CJK JP"/>
+              <a:cs typeface="Noto Sans"/>
             </a:endParaRPr>
           </a:p>
         </p:txBody>
@@ -7645,9 +7645,9 @@
               </a:spcAft>
             </a:pPr>
             <a:endParaRPr lang="ja-JP" dirty="0">
-              <a:latin typeface="Arial"/>
-              <a:ea typeface="ＭＳ Ｐゴシック"/>
-              <a:cs typeface="Arial"/>
+              <a:latin typeface="Noto Sans"/>
+              <a:ea typeface="Noto Sans CJK JP"/>
+              <a:cs typeface="Noto Sans"/>
             </a:endParaRPr>
           </a:p>
         </p:txBody>
@@ -7709,9 +7709,9 @@
               </a:spcAft>
             </a:pPr>
             <a:endParaRPr lang="ja-JP" dirty="0">
-              <a:latin typeface="Arial"/>
-              <a:ea typeface="ＭＳ Ｐゴシック"/>
-              <a:cs typeface="Arial"/>
+              <a:latin typeface="Noto Sans"/>
+              <a:ea typeface="Noto Sans CJK JP"/>
+              <a:cs typeface="Noto Sans"/>
             </a:endParaRPr>
           </a:p>
         </p:txBody>
@@ -7760,16 +7760,16 @@
           <a:p>
             <a:pPr>
               <a:defRPr lang="ja-JP">
-                <a:latin typeface="Arial"/>
-                <a:ea typeface="ＭＳ Ｐゴシック"/>
-                <a:cs typeface="Arial"/>
+                <a:latin typeface="Noto Sans"/>
+                <a:ea typeface="Noto Sans CJK JP"/>
+                <a:cs typeface="Noto Sans"/>
               </a:defRPr>
             </a:pPr>
             <a:r>
               <a:rPr lang="ja-JP">
-                <a:latin typeface="Arial"/>
-                <a:ea typeface="ＭＳ Ｐゴシック"/>
-                <a:cs typeface="Arial"/>
+                <a:latin typeface="Noto Sans"/>
+                <a:ea typeface="Noto Sans CJK JP"/>
+                <a:cs typeface="Noto Sans"/>
               </a:rPr>
               <a:t>Bottom-right caption</a:t>
             </a:r>
@@ -7827,10 +7827,10 @@
     </a:clrScheme>
     <a:fontScheme name="Office">
       <a:majorFont>
-        <a:latin typeface="Arial"/>
-        <a:ea typeface="ＭＳ Ｐゴシック"/>
-        <a:cs typeface="Arial"/>
-        <a:font script="Jpan" typeface="ＭＳ Ｐゴシック"/>
+        <a:latin typeface="Noto Sans"/>
+        <a:ea typeface="Noto Sans CJK JP"/>
+        <a:cs typeface="Noto Sans"/>
+        <a:font script="Jpan" typeface="Noto Sans CJK JP"/>
         <a:font script="Hang" typeface="맑은 고딕"/>
         <a:font script="Hans" typeface="宋体"/>
         <a:font script="Hant" typeface="新細明體"/>
@@ -7862,10 +7862,10 @@
         <a:font script="Geor" typeface="Sylfaen"/>
       </a:majorFont>
       <a:minorFont>
-        <a:latin typeface="Arial"/>
-        <a:ea typeface="ＭＳ Ｐゴシック"/>
-        <a:cs typeface="Arial"/>
-        <a:font script="Jpan" typeface="ＭＳ Ｐゴシック"/>
+        <a:latin typeface="Noto Sans"/>
+        <a:ea typeface="Noto Sans CJK JP"/>
+        <a:cs typeface="Noto Sans"/>
+        <a:font script="Jpan" typeface="Noto Sans CJK JP"/>
         <a:font script="Hang" typeface="맑은 고딕"/>
         <a:font script="Hans" typeface="宋体"/>
         <a:font script="Hant" typeface="新細明體"/>

</xml_diff>

<commit_message>
Refine slide bullets, further reading, and SQuAD layout
</commit_message>
<xml_diff>
--- a/.agents/skills/master-guided-slides/SlideMaster.pptx
+++ b/.agents/skills/master-guided-slides/SlideMaster.pptx
@@ -320,7 +320,6 @@
               <a:buClr>
                 <a:schemeClr val="dk1"/>
               </a:buClr>
-              <a:buSzPts val="5200"/>
               <a:buNone/>
               <a:defRPr sz="5200" b="1" lang="ja-JP">
                 <a:solidFill>
@@ -338,7 +337,6 @@
               <a:spcAft>
                 <a:spcPts val="0"/>
               </a:spcAft>
-              <a:buSzPts val="5200"/>
               <a:buNone/>
               <a:defRPr sz="5200" lang="ja-JP">
                 <a:latin typeface="Noto Sans"/>
@@ -353,7 +351,6 @@
               <a:spcAft>
                 <a:spcPts val="0"/>
               </a:spcAft>
-              <a:buSzPts val="5200"/>
               <a:buNone/>
               <a:defRPr sz="5200" lang="ja-JP">
                 <a:latin typeface="Noto Sans"/>
@@ -368,7 +365,6 @@
               <a:spcAft>
                 <a:spcPts val="0"/>
               </a:spcAft>
-              <a:buSzPts val="5200"/>
               <a:buNone/>
               <a:defRPr sz="5200" lang="ja-JP">
                 <a:latin typeface="Noto Sans"/>
@@ -383,7 +379,6 @@
               <a:spcAft>
                 <a:spcPts val="0"/>
               </a:spcAft>
-              <a:buSzPts val="5200"/>
               <a:buNone/>
               <a:defRPr sz="5200" lang="ja-JP">
                 <a:latin typeface="Noto Sans"/>
@@ -398,7 +393,6 @@
               <a:spcAft>
                 <a:spcPts val="0"/>
               </a:spcAft>
-              <a:buSzPts val="5200"/>
               <a:buNone/>
               <a:defRPr sz="5200" lang="ja-JP">
                 <a:latin typeface="Noto Sans"/>
@@ -413,7 +407,6 @@
               <a:spcAft>
                 <a:spcPts val="0"/>
               </a:spcAft>
-              <a:buSzPts val="5200"/>
               <a:buNone/>
               <a:defRPr sz="5200" lang="ja-JP">
                 <a:latin typeface="Noto Sans"/>
@@ -428,7 +421,6 @@
               <a:spcAft>
                 <a:spcPts val="0"/>
               </a:spcAft>
-              <a:buSzPts val="5200"/>
               <a:buNone/>
               <a:defRPr sz="5200" lang="ja-JP">
                 <a:latin typeface="Noto Sans"/>
@@ -443,7 +435,6 @@
               <a:spcAft>
                 <a:spcPts val="0"/>
               </a:spcAft>
-              <a:buSzPts val="5200"/>
               <a:buNone/>
               <a:defRPr sz="5200" lang="ja-JP">
                 <a:latin typeface="Noto Sans"/>
@@ -498,7 +489,6 @@
               <a:buClr>
                 <a:schemeClr val="dk1"/>
               </a:buClr>
-              <a:buSzPts val="2800"/>
               <a:buNone/>
               <a:defRPr sz="2800" lang="ja-JP">
                 <a:solidFill>
@@ -519,7 +509,6 @@
               <a:spcAft>
                 <a:spcPts val="0"/>
               </a:spcAft>
-              <a:buSzPts val="2800"/>
               <a:buNone/>
               <a:defRPr sz="2800" lang="ja-JP">
                 <a:latin typeface="Noto Sans"/>
@@ -537,7 +526,6 @@
               <a:spcAft>
                 <a:spcPts val="0"/>
               </a:spcAft>
-              <a:buSzPts val="2800"/>
               <a:buNone/>
               <a:defRPr sz="2800" lang="ja-JP">
                 <a:latin typeface="Noto Sans"/>
@@ -555,7 +543,6 @@
               <a:spcAft>
                 <a:spcPts val="0"/>
               </a:spcAft>
-              <a:buSzPts val="2800"/>
               <a:buNone/>
               <a:defRPr sz="2800" lang="ja-JP">
                 <a:latin typeface="Noto Sans"/>
@@ -573,7 +560,6 @@
               <a:spcAft>
                 <a:spcPts val="0"/>
               </a:spcAft>
-              <a:buSzPts val="2800"/>
               <a:buNone/>
               <a:defRPr sz="2800" lang="ja-JP">
                 <a:latin typeface="Noto Sans"/>
@@ -591,7 +577,6 @@
               <a:spcAft>
                 <a:spcPts val="0"/>
               </a:spcAft>
-              <a:buSzPts val="2800"/>
               <a:buNone/>
               <a:defRPr sz="2800" lang="ja-JP">
                 <a:latin typeface="Noto Sans"/>
@@ -609,7 +594,6 @@
               <a:spcAft>
                 <a:spcPts val="0"/>
               </a:spcAft>
-              <a:buSzPts val="2800"/>
               <a:buNone/>
               <a:defRPr sz="2800" lang="ja-JP">
                 <a:latin typeface="Noto Sans"/>
@@ -627,7 +611,6 @@
               <a:spcAft>
                 <a:spcPts val="0"/>
               </a:spcAft>
-              <a:buSzPts val="2800"/>
               <a:buNone/>
               <a:defRPr sz="2800" lang="ja-JP">
                 <a:latin typeface="Noto Sans"/>
@@ -645,7 +628,6 @@
               <a:spcAft>
                 <a:spcPts val="0"/>
               </a:spcAft>
-              <a:buSzPts val="2800"/>
               <a:buNone/>
               <a:defRPr sz="2800" lang="ja-JP">
                 <a:latin typeface="Noto Sans"/>
@@ -804,7 +786,8 @@
               <a:buClr>
                 <a:srgbClr val="303437"/>
               </a:buClr>
-              <a:buSzPts val="2000"/>
+              <a:buSzPct val="66500"/>
+              <a:buFont typeface="Noto Sans CJK JP"/>
               <a:buChar char="●"/>
               <a:defRPr sz="2000" lang="ja-JP">
                 <a:solidFill>
@@ -825,7 +808,8 @@
               <a:buClr>
                 <a:srgbClr val="303437"/>
               </a:buClr>
-              <a:buSzPts val="2000"/>
+              <a:buSzPct val="66500"/>
+              <a:buFont typeface="Noto Sans CJK JP"/>
               <a:buChar char="○"/>
               <a:defRPr sz="2000" lang="ja-JP">
                 <a:solidFill>
@@ -846,8 +830,9 @@
               <a:buClr>
                 <a:srgbClr val="303437"/>
               </a:buClr>
-              <a:buSzPts val="2000"/>
-              <a:buChar char="■"/>
+              <a:buSzPct val="66500"/>
+              <a:buFont typeface="Noto Sans CJK JP"/>
+              <a:buChar char="○"/>
               <a:defRPr sz="2000" lang="ja-JP">
                 <a:solidFill>
                   <a:srgbClr val="303437"/>
@@ -867,7 +852,8 @@
               <a:buClr>
                 <a:srgbClr val="303437"/>
               </a:buClr>
-              <a:buSzPts val="2200"/>
+              <a:buSzPct val="60455"/>
+              <a:buFont typeface="Noto Sans CJK JP"/>
               <a:buChar char="●"/>
               <a:defRPr sz="2200" lang="ja-JP">
                 <a:solidFill>
@@ -888,7 +874,8 @@
               <a:buClr>
                 <a:srgbClr val="303437"/>
               </a:buClr>
-              <a:buSzPts val="2000"/>
+              <a:buSzPct val="66500"/>
+              <a:buFont typeface="Noto Sans CJK JP"/>
               <a:buChar char="○"/>
               <a:defRPr sz="2000" lang="ja-JP">
                 <a:solidFill>
@@ -909,8 +896,9 @@
               <a:buClr>
                 <a:srgbClr val="303437"/>
               </a:buClr>
-              <a:buSzPts val="2000"/>
-              <a:buChar char="■"/>
+              <a:buSzPct val="66500"/>
+              <a:buFont typeface="Noto Sans CJK JP"/>
+              <a:buChar char="○"/>
               <a:defRPr sz="2000" lang="ja-JP">
                 <a:solidFill>
                   <a:srgbClr val="303437"/>
@@ -930,7 +918,8 @@
               <a:buClr>
                 <a:srgbClr val="303437"/>
               </a:buClr>
-              <a:buSzPts val="2000"/>
+              <a:buSzPct val="66500"/>
+              <a:buFont typeface="Noto Sans CJK JP"/>
               <a:buChar char="●"/>
               <a:defRPr sz="2000" lang="ja-JP">
                 <a:solidFill>
@@ -951,7 +940,8 @@
               <a:buClr>
                 <a:srgbClr val="303437"/>
               </a:buClr>
-              <a:buSzPts val="2000"/>
+              <a:buSzPct val="66500"/>
+              <a:buFont typeface="Noto Sans CJK JP"/>
               <a:buChar char="○"/>
               <a:defRPr sz="2000" lang="ja-JP">
                 <a:solidFill>
@@ -972,8 +962,9 @@
               <a:buClr>
                 <a:srgbClr val="303437"/>
               </a:buClr>
-              <a:buSzPts val="2000"/>
-              <a:buChar char="■"/>
+              <a:buSzPct val="66500"/>
+              <a:buFont typeface="Noto Sans CJK JP"/>
+              <a:buChar char="○"/>
               <a:defRPr sz="2000" lang="ja-JP">
                 <a:solidFill>
                   <a:srgbClr val="303437"/>
@@ -1044,7 +1035,8 @@
               <a:buClr>
                 <a:srgbClr val="303437"/>
               </a:buClr>
-              <a:buSzPts val="2000"/>
+              <a:buSzPct val="66500"/>
+              <a:buFont typeface="Noto Sans CJK JP"/>
               <a:buChar char="●"/>
               <a:defRPr sz="2000" lang="ja-JP">
                 <a:solidFill>
@@ -1065,7 +1057,8 @@
               <a:buClr>
                 <a:srgbClr val="303437"/>
               </a:buClr>
-              <a:buSzPts val="2000"/>
+              <a:buSzPct val="66500"/>
+              <a:buFont typeface="Noto Sans CJK JP"/>
               <a:buChar char="○"/>
               <a:defRPr sz="2000" lang="ja-JP">
                 <a:solidFill>
@@ -1086,8 +1079,9 @@
               <a:buClr>
                 <a:srgbClr val="303437"/>
               </a:buClr>
-              <a:buSzPts val="2000"/>
-              <a:buChar char="■"/>
+              <a:buSzPct val="66500"/>
+              <a:buFont typeface="Noto Sans CJK JP"/>
+              <a:buChar char="○"/>
               <a:defRPr sz="2000" lang="ja-JP">
                 <a:solidFill>
                   <a:srgbClr val="303437"/>
@@ -1107,7 +1101,8 @@
               <a:buClr>
                 <a:srgbClr val="303437"/>
               </a:buClr>
-              <a:buSzPts val="2200"/>
+              <a:buSzPct val="60455"/>
+              <a:buFont typeface="Noto Sans CJK JP"/>
               <a:buChar char="●"/>
               <a:defRPr sz="2200" lang="ja-JP">
                 <a:solidFill>
@@ -1128,7 +1123,8 @@
               <a:buClr>
                 <a:srgbClr val="303437"/>
               </a:buClr>
-              <a:buSzPts val="2000"/>
+              <a:buSzPct val="66500"/>
+              <a:buFont typeface="Noto Sans CJK JP"/>
               <a:buChar char="○"/>
               <a:defRPr sz="2000" lang="ja-JP">
                 <a:solidFill>
@@ -1149,8 +1145,9 @@
               <a:buClr>
                 <a:srgbClr val="303437"/>
               </a:buClr>
-              <a:buSzPts val="2000"/>
-              <a:buChar char="■"/>
+              <a:buSzPct val="66500"/>
+              <a:buFont typeface="Noto Sans CJK JP"/>
+              <a:buChar char="○"/>
               <a:defRPr sz="2000" lang="ja-JP">
                 <a:solidFill>
                   <a:srgbClr val="303437"/>
@@ -1170,7 +1167,8 @@
               <a:buClr>
                 <a:srgbClr val="303437"/>
               </a:buClr>
-              <a:buSzPts val="2000"/>
+              <a:buSzPct val="66500"/>
+              <a:buFont typeface="Noto Sans CJK JP"/>
               <a:buChar char="●"/>
               <a:defRPr sz="2000" lang="ja-JP">
                 <a:solidFill>
@@ -1191,7 +1189,8 @@
               <a:buClr>
                 <a:srgbClr val="303437"/>
               </a:buClr>
-              <a:buSzPts val="2000"/>
+              <a:buSzPct val="66500"/>
+              <a:buFont typeface="Noto Sans CJK JP"/>
               <a:buChar char="○"/>
               <a:defRPr sz="2000" lang="ja-JP">
                 <a:solidFill>
@@ -1212,8 +1211,9 @@
               <a:buClr>
                 <a:srgbClr val="303437"/>
               </a:buClr>
-              <a:buSzPts val="2000"/>
-              <a:buChar char="■"/>
+              <a:buSzPct val="66500"/>
+              <a:buFont typeface="Noto Sans CJK JP"/>
+              <a:buChar char="○"/>
               <a:defRPr sz="2000" lang="ja-JP">
                 <a:solidFill>
                   <a:srgbClr val="303437"/>
@@ -1292,7 +1292,8 @@
               <a:buClr>
                 <a:srgbClr val="303437"/>
               </a:buClr>
-              <a:buSzPts val="2000"/>
+              <a:buSzPct val="66500"/>
+              <a:buFont typeface="Noto Sans CJK JP"/>
               <a:buChar char="●"/>
               <a:defRPr sz="2000" lang="ja-JP">
                 <a:solidFill>
@@ -1313,7 +1314,8 @@
               <a:buClr>
                 <a:srgbClr val="303437"/>
               </a:buClr>
-              <a:buSzPts val="2000"/>
+              <a:buSzPct val="66500"/>
+              <a:buFont typeface="Noto Sans CJK JP"/>
               <a:buChar char="○"/>
               <a:defRPr sz="2000" lang="ja-JP">
                 <a:solidFill>
@@ -1334,8 +1336,9 @@
               <a:buClr>
                 <a:srgbClr val="303437"/>
               </a:buClr>
-              <a:buSzPts val="2000"/>
-              <a:buChar char="■"/>
+              <a:buSzPct val="66500"/>
+              <a:buFont typeface="Noto Sans CJK JP"/>
+              <a:buChar char="○"/>
               <a:defRPr sz="2000" lang="ja-JP">
                 <a:solidFill>
                   <a:srgbClr val="303437"/>
@@ -1355,7 +1358,8 @@
               <a:buClr>
                 <a:srgbClr val="303437"/>
               </a:buClr>
-              <a:buSzPts val="2200"/>
+              <a:buSzPct val="60455"/>
+              <a:buFont typeface="Noto Sans CJK JP"/>
               <a:buChar char="●"/>
               <a:defRPr sz="2200" lang="ja-JP">
                 <a:solidFill>
@@ -1376,7 +1380,8 @@
               <a:buClr>
                 <a:srgbClr val="303437"/>
               </a:buClr>
-              <a:buSzPts val="2000"/>
+              <a:buSzPct val="66500"/>
+              <a:buFont typeface="Noto Sans CJK JP"/>
               <a:buChar char="○"/>
               <a:defRPr sz="2000" lang="ja-JP">
                 <a:solidFill>
@@ -1397,8 +1402,9 @@
               <a:buClr>
                 <a:srgbClr val="303437"/>
               </a:buClr>
-              <a:buSzPts val="2000"/>
-              <a:buChar char="■"/>
+              <a:buSzPct val="66500"/>
+              <a:buFont typeface="Noto Sans CJK JP"/>
+              <a:buChar char="○"/>
               <a:defRPr sz="2000" lang="ja-JP">
                 <a:solidFill>
                   <a:srgbClr val="303437"/>
@@ -1418,7 +1424,8 @@
               <a:buClr>
                 <a:srgbClr val="303437"/>
               </a:buClr>
-              <a:buSzPts val="2000"/>
+              <a:buSzPct val="66500"/>
+              <a:buFont typeface="Noto Sans CJK JP"/>
               <a:buChar char="●"/>
               <a:defRPr sz="2000" lang="ja-JP">
                 <a:solidFill>
@@ -1439,7 +1446,8 @@
               <a:buClr>
                 <a:srgbClr val="303437"/>
               </a:buClr>
-              <a:buSzPts val="2000"/>
+              <a:buSzPct val="66500"/>
+              <a:buFont typeface="Noto Sans CJK JP"/>
               <a:buChar char="○"/>
               <a:defRPr sz="2000" lang="ja-JP">
                 <a:solidFill>
@@ -1460,8 +1468,9 @@
               <a:buClr>
                 <a:srgbClr val="303437"/>
               </a:buClr>
-              <a:buSzPts val="2000"/>
-              <a:buChar char="■"/>
+              <a:buSzPct val="66500"/>
+              <a:buFont typeface="Noto Sans CJK JP"/>
+              <a:buChar char="○"/>
               <a:defRPr sz="2000" lang="ja-JP">
                 <a:solidFill>
                   <a:srgbClr val="303437"/>
@@ -1700,7 +1709,6 @@
               <a:buClr>
                 <a:schemeClr val="dk1"/>
               </a:buClr>
-              <a:buSzPts val="1018"/>
               <a:buFont typeface="Noto Sans CJK JP"/>
               <a:buNone/>
               <a:tabLst/>
@@ -1792,7 +1800,6 @@
               <a:buClr>
                 <a:schemeClr val="dk1"/>
               </a:buClr>
-              <a:buSzPts val="1018"/>
               <a:buFont typeface="Noto Sans CJK JP"/>
               <a:buNone/>
               <a:tabLst/>
@@ -1884,7 +1891,6 @@
               <a:buClr>
                 <a:schemeClr val="dk1"/>
               </a:buClr>
-              <a:buSzPts val="1018"/>
               <a:buFont typeface="Noto Sans CJK JP"/>
               <a:buNone/>
               <a:tabLst/>
@@ -1976,7 +1982,6 @@
               <a:buClr>
                 <a:schemeClr val="dk1"/>
               </a:buClr>
-              <a:buSzPts val="1018"/>
               <a:buFont typeface="Noto Sans CJK JP"/>
               <a:buNone/>
               <a:tabLst/>
@@ -2113,7 +2118,6 @@
               <a:buClr>
                 <a:schemeClr val="dk1"/>
               </a:buClr>
-              <a:buSzPts val="1018"/>
               <a:buFont typeface="Noto Sans CJK JP"/>
               <a:buNone/>
               <a:tabLst/>
@@ -2316,7 +2320,6 @@
               <a:buClr>
                 <a:schemeClr val="dk1"/>
               </a:buClr>
-              <a:buSzPts val="3000"/>
               <a:buNone/>
               <a:defRPr sz="3000" b="1" lang="ja-JP">
                 <a:solidFill>
@@ -2334,7 +2337,6 @@
               <a:spcAft>
                 <a:spcPts val="0"/>
               </a:spcAft>
-              <a:buSzPts val="2800"/>
               <a:buNone/>
               <a:defRPr lang="ja-JP">
                 <a:latin typeface="Noto Sans"/>
@@ -2349,7 +2351,6 @@
               <a:spcAft>
                 <a:spcPts val="0"/>
               </a:spcAft>
-              <a:buSzPts val="2800"/>
               <a:buNone/>
               <a:defRPr lang="ja-JP">
                 <a:latin typeface="Noto Sans"/>
@@ -2364,7 +2365,6 @@
               <a:spcAft>
                 <a:spcPts val="0"/>
               </a:spcAft>
-              <a:buSzPts val="2800"/>
               <a:buNone/>
               <a:defRPr lang="ja-JP">
                 <a:latin typeface="Noto Sans"/>
@@ -2379,7 +2379,6 @@
               <a:spcAft>
                 <a:spcPts val="0"/>
               </a:spcAft>
-              <a:buSzPts val="2800"/>
               <a:buNone/>
               <a:defRPr lang="ja-JP">
                 <a:latin typeface="Noto Sans"/>
@@ -2394,7 +2393,6 @@
               <a:spcAft>
                 <a:spcPts val="0"/>
               </a:spcAft>
-              <a:buSzPts val="2800"/>
               <a:buNone/>
               <a:defRPr lang="ja-JP">
                 <a:latin typeface="Noto Sans"/>
@@ -2409,7 +2407,6 @@
               <a:spcAft>
                 <a:spcPts val="0"/>
               </a:spcAft>
-              <a:buSzPts val="2800"/>
               <a:buNone/>
               <a:defRPr lang="ja-JP">
                 <a:latin typeface="Noto Sans"/>
@@ -2424,7 +2421,6 @@
               <a:spcAft>
                 <a:spcPts val="0"/>
               </a:spcAft>
-              <a:buSzPts val="2800"/>
               <a:buNone/>
               <a:defRPr lang="ja-JP">
                 <a:latin typeface="Noto Sans"/>
@@ -2439,7 +2435,6 @@
               <a:spcAft>
                 <a:spcPts val="0"/>
               </a:spcAft>
-              <a:buSzPts val="2800"/>
               <a:buNone/>
               <a:defRPr lang="ja-JP">
                 <a:latin typeface="Noto Sans"/>
@@ -2491,7 +2486,8 @@
               <a:buClr>
                 <a:srgbClr val="303437"/>
               </a:buClr>
-              <a:buSzPts val="2000"/>
+              <a:buSzPct val="66500"/>
+              <a:buFont typeface="Noto Sans CJK JP"/>
               <a:buChar char="●"/>
               <a:defRPr sz="2000" lang="ja-JP">
                 <a:solidFill>
@@ -2512,7 +2508,8 @@
               <a:buClr>
                 <a:srgbClr val="303437"/>
               </a:buClr>
-              <a:buSzPts val="2000"/>
+              <a:buSzPct val="66500"/>
+              <a:buFont typeface="Noto Sans CJK JP"/>
               <a:buChar char="○"/>
               <a:defRPr sz="2000" lang="ja-JP">
                 <a:solidFill>
@@ -2533,8 +2530,9 @@
               <a:buClr>
                 <a:srgbClr val="303437"/>
               </a:buClr>
-              <a:buSzPts val="2000"/>
-              <a:buChar char="■"/>
+              <a:buSzPct val="66500"/>
+              <a:buFont typeface="Noto Sans CJK JP"/>
+              <a:buChar char="○"/>
               <a:defRPr sz="2000" lang="ja-JP">
                 <a:solidFill>
                   <a:srgbClr val="303437"/>
@@ -2554,7 +2552,8 @@
               <a:buClr>
                 <a:srgbClr val="303437"/>
               </a:buClr>
-              <a:buSzPts val="2200"/>
+              <a:buSzPct val="60455"/>
+              <a:buFont typeface="Noto Sans CJK JP"/>
               <a:buChar char="●"/>
               <a:defRPr sz="2200" lang="ja-JP">
                 <a:solidFill>
@@ -2575,7 +2574,8 @@
               <a:buClr>
                 <a:srgbClr val="303437"/>
               </a:buClr>
-              <a:buSzPts val="2000"/>
+              <a:buSzPct val="66500"/>
+              <a:buFont typeface="Noto Sans CJK JP"/>
               <a:buChar char="○"/>
               <a:defRPr sz="2000" lang="ja-JP">
                 <a:solidFill>
@@ -2596,8 +2596,9 @@
               <a:buClr>
                 <a:srgbClr val="303437"/>
               </a:buClr>
-              <a:buSzPts val="2000"/>
-              <a:buChar char="■"/>
+              <a:buSzPct val="66500"/>
+              <a:buFont typeface="Noto Sans CJK JP"/>
+              <a:buChar char="○"/>
               <a:defRPr sz="2000" lang="ja-JP">
                 <a:solidFill>
                   <a:srgbClr val="303437"/>
@@ -2617,7 +2618,8 @@
               <a:buClr>
                 <a:srgbClr val="303437"/>
               </a:buClr>
-              <a:buSzPts val="2000"/>
+              <a:buSzPct val="66500"/>
+              <a:buFont typeface="Noto Sans CJK JP"/>
               <a:buChar char="●"/>
               <a:defRPr sz="2000" lang="ja-JP">
                 <a:solidFill>
@@ -2638,7 +2640,8 @@
               <a:buClr>
                 <a:srgbClr val="303437"/>
               </a:buClr>
-              <a:buSzPts val="2000"/>
+              <a:buSzPct val="66500"/>
+              <a:buFont typeface="Noto Sans CJK JP"/>
               <a:buChar char="○"/>
               <a:defRPr sz="2000" lang="ja-JP">
                 <a:solidFill>
@@ -2659,8 +2662,9 @@
               <a:buClr>
                 <a:srgbClr val="303437"/>
               </a:buClr>
-              <a:buSzPts val="2000"/>
-              <a:buChar char="■"/>
+              <a:buSzPct val="66500"/>
+              <a:buFont typeface="Noto Sans CJK JP"/>
+              <a:buChar char="○"/>
               <a:defRPr sz="2000" lang="ja-JP">
                 <a:solidFill>
                   <a:srgbClr val="303437"/>
@@ -2717,7 +2721,6 @@
               <a:buClr>
                 <a:schemeClr val="lt1"/>
               </a:buClr>
-              <a:buSzPts val="1400"/>
               <a:buNone/>
               <a:defRPr sz="1400" b="1" lang="ja-JP">
                 <a:solidFill>
@@ -2735,7 +2738,6 @@
               <a:spcAft>
                 <a:spcPts val="0"/>
               </a:spcAft>
-              <a:buSzPts val="2800"/>
               <a:buNone/>
               <a:defRPr lang="ja-JP">
                 <a:latin typeface="Noto Sans"/>
@@ -2750,7 +2752,6 @@
               <a:spcAft>
                 <a:spcPts val="0"/>
               </a:spcAft>
-              <a:buSzPts val="2800"/>
               <a:buNone/>
               <a:defRPr lang="ja-JP">
                 <a:latin typeface="Noto Sans"/>
@@ -2765,7 +2766,6 @@
               <a:spcAft>
                 <a:spcPts val="0"/>
               </a:spcAft>
-              <a:buSzPts val="2800"/>
               <a:buNone/>
               <a:defRPr lang="ja-JP">
                 <a:latin typeface="Noto Sans"/>
@@ -2780,7 +2780,6 @@
               <a:spcAft>
                 <a:spcPts val="0"/>
               </a:spcAft>
-              <a:buSzPts val="2800"/>
               <a:buNone/>
               <a:defRPr lang="ja-JP">
                 <a:latin typeface="Noto Sans"/>
@@ -2795,7 +2794,6 @@
               <a:spcAft>
                 <a:spcPts val="0"/>
               </a:spcAft>
-              <a:buSzPts val="2800"/>
               <a:buNone/>
               <a:defRPr lang="ja-JP">
                 <a:latin typeface="Noto Sans"/>
@@ -2810,7 +2808,6 @@
               <a:spcAft>
                 <a:spcPts val="0"/>
               </a:spcAft>
-              <a:buSzPts val="2800"/>
               <a:buNone/>
               <a:defRPr lang="ja-JP">
                 <a:latin typeface="Noto Sans"/>
@@ -2825,7 +2822,6 @@
               <a:spcAft>
                 <a:spcPts val="0"/>
               </a:spcAft>
-              <a:buSzPts val="2800"/>
               <a:buNone/>
               <a:defRPr lang="ja-JP">
                 <a:latin typeface="Noto Sans"/>
@@ -2840,7 +2836,6 @@
               <a:spcAft>
                 <a:spcPts val="0"/>
               </a:spcAft>
-              <a:buSzPts val="2800"/>
               <a:buNone/>
               <a:defRPr lang="ja-JP">
                 <a:latin typeface="Noto Sans"/>
@@ -3018,7 +3013,6 @@
               <a:buClr>
                 <a:schemeClr val="dk1"/>
               </a:buClr>
-              <a:buSzPts val="3000"/>
               <a:buNone/>
               <a:defRPr sz="3000" b="1" lang="ja-JP">
                 <a:solidFill>
@@ -3036,7 +3030,6 @@
               <a:spcAft>
                 <a:spcPts val="0"/>
               </a:spcAft>
-              <a:buSzPts val="2800"/>
               <a:buNone/>
               <a:defRPr lang="ja-JP">
                 <a:latin typeface="Noto Sans"/>
@@ -3051,7 +3044,6 @@
               <a:spcAft>
                 <a:spcPts val="0"/>
               </a:spcAft>
-              <a:buSzPts val="2800"/>
               <a:buNone/>
               <a:defRPr lang="ja-JP">
                 <a:latin typeface="Noto Sans"/>
@@ -3066,7 +3058,6 @@
               <a:spcAft>
                 <a:spcPts val="0"/>
               </a:spcAft>
-              <a:buSzPts val="2800"/>
               <a:buNone/>
               <a:defRPr lang="ja-JP">
                 <a:latin typeface="Noto Sans"/>
@@ -3081,7 +3072,6 @@
               <a:spcAft>
                 <a:spcPts val="0"/>
               </a:spcAft>
-              <a:buSzPts val="2800"/>
               <a:buNone/>
               <a:defRPr lang="ja-JP">
                 <a:latin typeface="Noto Sans"/>
@@ -3096,7 +3086,6 @@
               <a:spcAft>
                 <a:spcPts val="0"/>
               </a:spcAft>
-              <a:buSzPts val="2800"/>
               <a:buNone/>
               <a:defRPr lang="ja-JP">
                 <a:latin typeface="Noto Sans"/>
@@ -3111,7 +3100,6 @@
               <a:spcAft>
                 <a:spcPts val="0"/>
               </a:spcAft>
-              <a:buSzPts val="2800"/>
               <a:buNone/>
               <a:defRPr lang="ja-JP">
                 <a:latin typeface="Noto Sans"/>
@@ -3126,7 +3114,6 @@
               <a:spcAft>
                 <a:spcPts val="0"/>
               </a:spcAft>
-              <a:buSzPts val="2800"/>
               <a:buNone/>
               <a:defRPr lang="ja-JP">
                 <a:latin typeface="Noto Sans"/>
@@ -3141,7 +3128,6 @@
               <a:spcAft>
                 <a:spcPts val="0"/>
               </a:spcAft>
-              <a:buSzPts val="2800"/>
               <a:buNone/>
               <a:defRPr lang="ja-JP">
                 <a:latin typeface="Noto Sans"/>
@@ -3196,7 +3182,6 @@
               <a:buClr>
                 <a:schemeClr val="lt1"/>
               </a:buClr>
-              <a:buSzPts val="1400"/>
               <a:buNone/>
               <a:defRPr sz="1400" b="1" lang="ja-JP">
                 <a:solidFill>
@@ -3214,7 +3199,6 @@
               <a:spcAft>
                 <a:spcPts val="0"/>
               </a:spcAft>
-              <a:buSzPts val="2800"/>
               <a:buNone/>
               <a:defRPr lang="ja-JP">
                 <a:latin typeface="Noto Sans"/>
@@ -3229,7 +3213,6 @@
               <a:spcAft>
                 <a:spcPts val="0"/>
               </a:spcAft>
-              <a:buSzPts val="2800"/>
               <a:buNone/>
               <a:defRPr lang="ja-JP">
                 <a:latin typeface="Noto Sans"/>
@@ -3244,7 +3227,6 @@
               <a:spcAft>
                 <a:spcPts val="0"/>
               </a:spcAft>
-              <a:buSzPts val="2800"/>
               <a:buNone/>
               <a:defRPr lang="ja-JP">
                 <a:latin typeface="Noto Sans"/>
@@ -3259,7 +3241,6 @@
               <a:spcAft>
                 <a:spcPts val="0"/>
               </a:spcAft>
-              <a:buSzPts val="2800"/>
               <a:buNone/>
               <a:defRPr lang="ja-JP">
                 <a:latin typeface="Noto Sans"/>
@@ -3274,7 +3255,6 @@
               <a:spcAft>
                 <a:spcPts val="0"/>
               </a:spcAft>
-              <a:buSzPts val="2800"/>
               <a:buNone/>
               <a:defRPr lang="ja-JP">
                 <a:latin typeface="Noto Sans"/>
@@ -3289,7 +3269,6 @@
               <a:spcAft>
                 <a:spcPts val="0"/>
               </a:spcAft>
-              <a:buSzPts val="2800"/>
               <a:buNone/>
               <a:defRPr lang="ja-JP">
                 <a:latin typeface="Noto Sans"/>
@@ -3304,7 +3283,6 @@
               <a:spcAft>
                 <a:spcPts val="0"/>
               </a:spcAft>
-              <a:buSzPts val="2800"/>
               <a:buNone/>
               <a:defRPr lang="ja-JP">
                 <a:latin typeface="Noto Sans"/>
@@ -3319,7 +3297,6 @@
               <a:spcAft>
                 <a:spcPts val="0"/>
               </a:spcAft>
-              <a:buSzPts val="2800"/>
               <a:buNone/>
               <a:defRPr lang="ja-JP">
                 <a:latin typeface="Noto Sans"/>
@@ -3497,7 +3474,6 @@
               <a:buClr>
                 <a:schemeClr val="dk1"/>
               </a:buClr>
-              <a:buSzPts val="3000"/>
               <a:buNone/>
               <a:defRPr sz="3000" b="1" lang="ja-JP">
                 <a:solidFill>
@@ -3515,7 +3491,6 @@
               <a:spcAft>
                 <a:spcPts val="0"/>
               </a:spcAft>
-              <a:buSzPts val="2800"/>
               <a:buNone/>
               <a:defRPr lang="ja-JP">
                 <a:latin typeface="Noto Sans"/>
@@ -3530,7 +3505,6 @@
               <a:spcAft>
                 <a:spcPts val="0"/>
               </a:spcAft>
-              <a:buSzPts val="2800"/>
               <a:buNone/>
               <a:defRPr lang="ja-JP">
                 <a:latin typeface="Noto Sans"/>
@@ -3545,7 +3519,6 @@
               <a:spcAft>
                 <a:spcPts val="0"/>
               </a:spcAft>
-              <a:buSzPts val="2800"/>
               <a:buNone/>
               <a:defRPr lang="ja-JP">
                 <a:latin typeface="Noto Sans"/>
@@ -3560,7 +3533,6 @@
               <a:spcAft>
                 <a:spcPts val="0"/>
               </a:spcAft>
-              <a:buSzPts val="2800"/>
               <a:buNone/>
               <a:defRPr lang="ja-JP">
                 <a:latin typeface="Noto Sans"/>
@@ -3575,7 +3547,6 @@
               <a:spcAft>
                 <a:spcPts val="0"/>
               </a:spcAft>
-              <a:buSzPts val="2800"/>
               <a:buNone/>
               <a:defRPr lang="ja-JP">
                 <a:latin typeface="Noto Sans"/>
@@ -3590,7 +3561,6 @@
               <a:spcAft>
                 <a:spcPts val="0"/>
               </a:spcAft>
-              <a:buSzPts val="2800"/>
               <a:buNone/>
               <a:defRPr lang="ja-JP">
                 <a:latin typeface="Noto Sans"/>
@@ -3605,7 +3575,6 @@
               <a:spcAft>
                 <a:spcPts val="0"/>
               </a:spcAft>
-              <a:buSzPts val="2800"/>
               <a:buNone/>
               <a:defRPr lang="ja-JP">
                 <a:latin typeface="Noto Sans"/>
@@ -3620,7 +3589,6 @@
               <a:spcAft>
                 <a:spcPts val="0"/>
               </a:spcAft>
-              <a:buSzPts val="2800"/>
               <a:buNone/>
               <a:defRPr lang="ja-JP">
                 <a:latin typeface="Noto Sans"/>
@@ -3675,7 +3643,6 @@
               <a:buClr>
                 <a:schemeClr val="lt1"/>
               </a:buClr>
-              <a:buSzPts val="1400"/>
               <a:buNone/>
               <a:defRPr sz="1400" b="1" lang="ja-JP">
                 <a:solidFill>
@@ -3693,7 +3660,6 @@
               <a:spcAft>
                 <a:spcPts val="0"/>
               </a:spcAft>
-              <a:buSzPts val="2800"/>
               <a:buNone/>
               <a:defRPr lang="ja-JP">
                 <a:latin typeface="Noto Sans"/>
@@ -3708,7 +3674,6 @@
               <a:spcAft>
                 <a:spcPts val="0"/>
               </a:spcAft>
-              <a:buSzPts val="2800"/>
               <a:buNone/>
               <a:defRPr lang="ja-JP">
                 <a:latin typeface="Noto Sans"/>
@@ -3723,7 +3688,6 @@
               <a:spcAft>
                 <a:spcPts val="0"/>
               </a:spcAft>
-              <a:buSzPts val="2800"/>
               <a:buNone/>
               <a:defRPr lang="ja-JP">
                 <a:latin typeface="Noto Sans"/>
@@ -3738,7 +3702,6 @@
               <a:spcAft>
                 <a:spcPts val="0"/>
               </a:spcAft>
-              <a:buSzPts val="2800"/>
               <a:buNone/>
               <a:defRPr lang="ja-JP">
                 <a:latin typeface="Noto Sans"/>
@@ -3753,7 +3716,6 @@
               <a:spcAft>
                 <a:spcPts val="0"/>
               </a:spcAft>
-              <a:buSzPts val="2800"/>
               <a:buNone/>
               <a:defRPr lang="ja-JP">
                 <a:latin typeface="Noto Sans"/>
@@ -3768,7 +3730,6 @@
               <a:spcAft>
                 <a:spcPts val="0"/>
               </a:spcAft>
-              <a:buSzPts val="2800"/>
               <a:buNone/>
               <a:defRPr lang="ja-JP">
                 <a:latin typeface="Noto Sans"/>
@@ -3783,7 +3744,6 @@
               <a:spcAft>
                 <a:spcPts val="0"/>
               </a:spcAft>
-              <a:buSzPts val="2800"/>
               <a:buNone/>
               <a:defRPr lang="ja-JP">
                 <a:latin typeface="Noto Sans"/>
@@ -3798,7 +3758,6 @@
               <a:spcAft>
                 <a:spcPts val="0"/>
               </a:spcAft>
-              <a:buSzPts val="2800"/>
               <a:buNone/>
               <a:defRPr lang="ja-JP">
                 <a:latin typeface="Noto Sans"/>
@@ -3976,7 +3935,8 @@
               <a:buClr>
                 <a:srgbClr val="303437"/>
               </a:buClr>
-              <a:buSzPts val="2000"/>
+              <a:buSzPct val="66500"/>
+              <a:buFont typeface="Noto Sans CJK JP"/>
               <a:buChar char="●"/>
               <a:defRPr sz="2000" lang="ja-JP">
                 <a:solidFill>
@@ -3997,7 +3957,8 @@
               <a:buClr>
                 <a:srgbClr val="303437"/>
               </a:buClr>
-              <a:buSzPts val="2000"/>
+              <a:buSzPct val="66500"/>
+              <a:buFont typeface="Noto Sans CJK JP"/>
               <a:buChar char="○"/>
               <a:defRPr sz="2000" lang="ja-JP">
                 <a:solidFill>
@@ -4018,8 +3979,9 @@
               <a:buClr>
                 <a:srgbClr val="303437"/>
               </a:buClr>
-              <a:buSzPts val="2000"/>
-              <a:buChar char="■"/>
+              <a:buSzPct val="66500"/>
+              <a:buFont typeface="Noto Sans CJK JP"/>
+              <a:buChar char="○"/>
               <a:defRPr sz="2000" lang="ja-JP">
                 <a:solidFill>
                   <a:srgbClr val="303437"/>
@@ -4039,7 +4001,8 @@
               <a:buClr>
                 <a:srgbClr val="303437"/>
               </a:buClr>
-              <a:buSzPts val="2200"/>
+              <a:buSzPct val="60455"/>
+              <a:buFont typeface="Noto Sans CJK JP"/>
               <a:buChar char="●"/>
               <a:defRPr sz="2200" lang="ja-JP">
                 <a:solidFill>
@@ -4060,7 +4023,8 @@
               <a:buClr>
                 <a:srgbClr val="303437"/>
               </a:buClr>
-              <a:buSzPts val="2000"/>
+              <a:buSzPct val="66500"/>
+              <a:buFont typeface="Noto Sans CJK JP"/>
               <a:buChar char="○"/>
               <a:defRPr sz="2000" lang="ja-JP">
                 <a:solidFill>
@@ -4081,8 +4045,9 @@
               <a:buClr>
                 <a:srgbClr val="303437"/>
               </a:buClr>
-              <a:buSzPts val="2000"/>
-              <a:buChar char="■"/>
+              <a:buSzPct val="66500"/>
+              <a:buFont typeface="Noto Sans CJK JP"/>
+              <a:buChar char="○"/>
               <a:defRPr sz="2000" lang="ja-JP">
                 <a:solidFill>
                   <a:srgbClr val="303437"/>
@@ -4102,7 +4067,8 @@
               <a:buClr>
                 <a:srgbClr val="303437"/>
               </a:buClr>
-              <a:buSzPts val="2000"/>
+              <a:buSzPct val="66500"/>
+              <a:buFont typeface="Noto Sans CJK JP"/>
               <a:buChar char="●"/>
               <a:defRPr sz="2000" lang="ja-JP">
                 <a:solidFill>
@@ -4123,7 +4089,8 @@
               <a:buClr>
                 <a:srgbClr val="303437"/>
               </a:buClr>
-              <a:buSzPts val="2000"/>
+              <a:buSzPct val="66500"/>
+              <a:buFont typeface="Noto Sans CJK JP"/>
               <a:buChar char="○"/>
               <a:defRPr sz="2000" lang="ja-JP">
                 <a:solidFill>
@@ -4144,8 +4111,9 @@
               <a:buClr>
                 <a:srgbClr val="303437"/>
               </a:buClr>
-              <a:buSzPts val="2000"/>
-              <a:buChar char="■"/>
+              <a:buSzPct val="66500"/>
+              <a:buFont typeface="Noto Sans CJK JP"/>
+              <a:buChar char="○"/>
               <a:defRPr sz="2000" lang="ja-JP">
                 <a:solidFill>
                   <a:srgbClr val="303437"/>
@@ -4202,7 +4170,6 @@
               <a:buClr>
                 <a:schemeClr val="lt1"/>
               </a:buClr>
-              <a:buSzPts val="1400"/>
               <a:buNone/>
               <a:defRPr sz="1400" b="1" lang="ja-JP">
                 <a:solidFill>
@@ -4220,7 +4187,6 @@
               <a:spcAft>
                 <a:spcPts val="0"/>
               </a:spcAft>
-              <a:buSzPts val="2800"/>
               <a:buNone/>
               <a:defRPr lang="ja-JP">
                 <a:latin typeface="Noto Sans"/>
@@ -4235,7 +4201,6 @@
               <a:spcAft>
                 <a:spcPts val="0"/>
               </a:spcAft>
-              <a:buSzPts val="2800"/>
               <a:buNone/>
               <a:defRPr lang="ja-JP">
                 <a:latin typeface="Noto Sans"/>
@@ -4250,7 +4215,6 @@
               <a:spcAft>
                 <a:spcPts val="0"/>
               </a:spcAft>
-              <a:buSzPts val="2800"/>
               <a:buNone/>
               <a:defRPr lang="ja-JP">
                 <a:latin typeface="Noto Sans"/>
@@ -4265,7 +4229,6 @@
               <a:spcAft>
                 <a:spcPts val="0"/>
               </a:spcAft>
-              <a:buSzPts val="2800"/>
               <a:buNone/>
               <a:defRPr lang="ja-JP">
                 <a:latin typeface="Noto Sans"/>
@@ -4280,7 +4243,6 @@
               <a:spcAft>
                 <a:spcPts val="0"/>
               </a:spcAft>
-              <a:buSzPts val="2800"/>
               <a:buNone/>
               <a:defRPr lang="ja-JP">
                 <a:latin typeface="Noto Sans"/>
@@ -4295,7 +4257,6 @@
               <a:spcAft>
                 <a:spcPts val="0"/>
               </a:spcAft>
-              <a:buSzPts val="2800"/>
               <a:buNone/>
               <a:defRPr lang="ja-JP">
                 <a:latin typeface="Noto Sans"/>
@@ -4310,7 +4271,6 @@
               <a:spcAft>
                 <a:spcPts val="0"/>
               </a:spcAft>
-              <a:buSzPts val="2800"/>
               <a:buNone/>
               <a:defRPr lang="ja-JP">
                 <a:latin typeface="Noto Sans"/>
@@ -4325,7 +4285,6 @@
               <a:spcAft>
                 <a:spcPts val="0"/>
               </a:spcAft>
-              <a:buSzPts val="2800"/>
               <a:buNone/>
               <a:defRPr lang="ja-JP">
                 <a:latin typeface="Noto Sans"/>
@@ -4506,7 +4465,6 @@
               <a:buClr>
                 <a:schemeClr val="lt1"/>
               </a:buClr>
-              <a:buSzPts val="1400"/>
               <a:buNone/>
               <a:defRPr sz="1400" b="1" lang="ja-JP">
                 <a:solidFill>
@@ -4524,7 +4482,6 @@
               <a:spcAft>
                 <a:spcPts val="0"/>
               </a:spcAft>
-              <a:buSzPts val="2800"/>
               <a:buNone/>
               <a:defRPr lang="ja-JP">
                 <a:latin typeface="Noto Sans"/>
@@ -4539,7 +4496,6 @@
               <a:spcAft>
                 <a:spcPts val="0"/>
               </a:spcAft>
-              <a:buSzPts val="2800"/>
               <a:buNone/>
               <a:defRPr lang="ja-JP">
                 <a:latin typeface="Noto Sans"/>
@@ -4554,7 +4510,6 @@
               <a:spcAft>
                 <a:spcPts val="0"/>
               </a:spcAft>
-              <a:buSzPts val="2800"/>
               <a:buNone/>
               <a:defRPr lang="ja-JP">
                 <a:latin typeface="Noto Sans"/>
@@ -4569,7 +4524,6 @@
               <a:spcAft>
                 <a:spcPts val="0"/>
               </a:spcAft>
-              <a:buSzPts val="2800"/>
               <a:buNone/>
               <a:defRPr lang="ja-JP">
                 <a:latin typeface="Noto Sans"/>
@@ -4584,7 +4538,6 @@
               <a:spcAft>
                 <a:spcPts val="0"/>
               </a:spcAft>
-              <a:buSzPts val="2800"/>
               <a:buNone/>
               <a:defRPr lang="ja-JP">
                 <a:latin typeface="Noto Sans"/>
@@ -4599,7 +4552,6 @@
               <a:spcAft>
                 <a:spcPts val="0"/>
               </a:spcAft>
-              <a:buSzPts val="2800"/>
               <a:buNone/>
               <a:defRPr lang="ja-JP">
                 <a:latin typeface="Noto Sans"/>
@@ -4614,7 +4566,6 @@
               <a:spcAft>
                 <a:spcPts val="0"/>
               </a:spcAft>
-              <a:buSzPts val="2800"/>
               <a:buNone/>
               <a:defRPr lang="ja-JP">
                 <a:latin typeface="Noto Sans"/>
@@ -4629,7 +4580,6 @@
               <a:spcAft>
                 <a:spcPts val="0"/>
               </a:spcAft>
-              <a:buSzPts val="2800"/>
               <a:buNone/>
               <a:defRPr lang="ja-JP">
                 <a:latin typeface="Noto Sans"/>
@@ -4854,7 +4804,8 @@
               <a:buClr>
                 <a:srgbClr val="303437"/>
               </a:buClr>
-              <a:buSzPts val="2000"/>
+              <a:buSzPct val="66500"/>
+              <a:buFont typeface="Noto Sans CJK JP"/>
               <a:buChar char="●"/>
               <a:defRPr sz="2000" lang="ja-JP">
                 <a:solidFill>
@@ -4875,7 +4826,8 @@
               <a:buClr>
                 <a:srgbClr val="303437"/>
               </a:buClr>
-              <a:buSzPts val="2000"/>
+              <a:buSzPct val="66500"/>
+              <a:buFont typeface="Noto Sans CJK JP"/>
               <a:buChar char="○"/>
               <a:defRPr sz="2000" lang="ja-JP">
                 <a:solidFill>
@@ -4896,8 +4848,9 @@
               <a:buClr>
                 <a:srgbClr val="303437"/>
               </a:buClr>
-              <a:buSzPts val="2000"/>
-              <a:buChar char="■"/>
+              <a:buSzPct val="66500"/>
+              <a:buFont typeface="Noto Sans CJK JP"/>
+              <a:buChar char="○"/>
               <a:defRPr sz="2000" lang="ja-JP">
                 <a:solidFill>
                   <a:srgbClr val="303437"/>
@@ -4917,7 +4870,8 @@
               <a:buClr>
                 <a:srgbClr val="303437"/>
               </a:buClr>
-              <a:buSzPts val="2200"/>
+              <a:buSzPct val="60455"/>
+              <a:buFont typeface="Noto Sans CJK JP"/>
               <a:buChar char="●"/>
               <a:defRPr sz="2200" lang="ja-JP">
                 <a:solidFill>
@@ -4938,7 +4892,8 @@
               <a:buClr>
                 <a:srgbClr val="303437"/>
               </a:buClr>
-              <a:buSzPts val="2000"/>
+              <a:buSzPct val="66500"/>
+              <a:buFont typeface="Noto Sans CJK JP"/>
               <a:buChar char="○"/>
               <a:defRPr sz="2000" lang="ja-JP">
                 <a:solidFill>
@@ -4959,8 +4914,9 @@
               <a:buClr>
                 <a:srgbClr val="303437"/>
               </a:buClr>
-              <a:buSzPts val="2000"/>
-              <a:buChar char="■"/>
+              <a:buSzPct val="66500"/>
+              <a:buFont typeface="Noto Sans CJK JP"/>
+              <a:buChar char="○"/>
               <a:defRPr sz="2000" lang="ja-JP">
                 <a:solidFill>
                   <a:srgbClr val="303437"/>
@@ -4980,7 +4936,8 @@
               <a:buClr>
                 <a:srgbClr val="303437"/>
               </a:buClr>
-              <a:buSzPts val="2000"/>
+              <a:buSzPct val="66500"/>
+              <a:buFont typeface="Noto Sans CJK JP"/>
               <a:buChar char="●"/>
               <a:defRPr sz="2000" lang="ja-JP">
                 <a:solidFill>
@@ -5001,7 +4958,8 @@
               <a:buClr>
                 <a:srgbClr val="303437"/>
               </a:buClr>
-              <a:buSzPts val="2000"/>
+              <a:buSzPct val="66500"/>
+              <a:buFont typeface="Noto Sans CJK JP"/>
               <a:buChar char="○"/>
               <a:defRPr sz="2000" lang="ja-JP">
                 <a:solidFill>
@@ -5022,8 +4980,9 @@
               <a:buClr>
                 <a:srgbClr val="303437"/>
               </a:buClr>
-              <a:buSzPts val="2000"/>
-              <a:buChar char="■"/>
+              <a:buSzPct val="66500"/>
+              <a:buFont typeface="Noto Sans CJK JP"/>
+              <a:buChar char="○"/>
               <a:defRPr sz="2000" lang="ja-JP">
                 <a:solidFill>
                   <a:srgbClr val="303437"/>
@@ -5079,7 +5038,8 @@
               <a:buClr>
                 <a:srgbClr val="303437"/>
               </a:buClr>
-              <a:buSzPts val="2000"/>
+              <a:buSzPct val="66500"/>
+              <a:buFont typeface="Noto Sans CJK JP"/>
               <a:buChar char="●"/>
               <a:defRPr sz="2000" lang="ja-JP">
                 <a:solidFill>
@@ -5100,7 +5060,8 @@
               <a:buClr>
                 <a:srgbClr val="303437"/>
               </a:buClr>
-              <a:buSzPts val="2000"/>
+              <a:buSzPct val="66500"/>
+              <a:buFont typeface="Noto Sans CJK JP"/>
               <a:buChar char="○"/>
               <a:defRPr sz="2000" lang="ja-JP">
                 <a:solidFill>
@@ -5121,8 +5082,9 @@
               <a:buClr>
                 <a:srgbClr val="303437"/>
               </a:buClr>
-              <a:buSzPts val="2000"/>
-              <a:buChar char="■"/>
+              <a:buSzPct val="66500"/>
+              <a:buFont typeface="Noto Sans CJK JP"/>
+              <a:buChar char="○"/>
               <a:defRPr sz="2000" lang="ja-JP">
                 <a:solidFill>
                   <a:srgbClr val="303437"/>
@@ -5142,7 +5104,8 @@
               <a:buClr>
                 <a:srgbClr val="303437"/>
               </a:buClr>
-              <a:buSzPts val="2200"/>
+              <a:buSzPct val="60455"/>
+              <a:buFont typeface="Noto Sans CJK JP"/>
               <a:buChar char="●"/>
               <a:defRPr sz="2200" lang="ja-JP">
                 <a:solidFill>
@@ -5163,7 +5126,8 @@
               <a:buClr>
                 <a:srgbClr val="303437"/>
               </a:buClr>
-              <a:buSzPts val="2000"/>
+              <a:buSzPct val="66500"/>
+              <a:buFont typeface="Noto Sans CJK JP"/>
               <a:buChar char="○"/>
               <a:defRPr sz="2000" lang="ja-JP">
                 <a:solidFill>
@@ -5184,8 +5148,9 @@
               <a:buClr>
                 <a:srgbClr val="303437"/>
               </a:buClr>
-              <a:buSzPts val="2000"/>
-              <a:buChar char="■"/>
+              <a:buSzPct val="66500"/>
+              <a:buFont typeface="Noto Sans CJK JP"/>
+              <a:buChar char="○"/>
               <a:defRPr sz="2000" lang="ja-JP">
                 <a:solidFill>
                   <a:srgbClr val="303437"/>
@@ -5205,7 +5170,8 @@
               <a:buClr>
                 <a:srgbClr val="303437"/>
               </a:buClr>
-              <a:buSzPts val="2000"/>
+              <a:buSzPct val="66500"/>
+              <a:buFont typeface="Noto Sans CJK JP"/>
               <a:buChar char="●"/>
               <a:defRPr sz="2000" lang="ja-JP">
                 <a:solidFill>
@@ -5226,7 +5192,8 @@
               <a:buClr>
                 <a:srgbClr val="303437"/>
               </a:buClr>
-              <a:buSzPts val="2000"/>
+              <a:buSzPct val="66500"/>
+              <a:buFont typeface="Noto Sans CJK JP"/>
               <a:buChar char="○"/>
               <a:defRPr sz="2000" lang="ja-JP">
                 <a:solidFill>
@@ -5247,8 +5214,9 @@
               <a:buClr>
                 <a:srgbClr val="303437"/>
               </a:buClr>
-              <a:buSzPts val="2000"/>
-              <a:buChar char="■"/>
+              <a:buSzPct val="66500"/>
+              <a:buFont typeface="Noto Sans CJK JP"/>
+              <a:buChar char="○"/>
               <a:defRPr sz="2000" lang="ja-JP">
                 <a:solidFill>
                   <a:srgbClr val="303437"/>
@@ -5402,7 +5370,6 @@
               <a:buClr>
                 <a:schemeClr val="lt1"/>
               </a:buClr>
-              <a:buSzPts val="2800"/>
               <a:buNone/>
               <a:defRPr b="1" lang="ja-JP">
                 <a:solidFill>
@@ -5423,7 +5390,6 @@
               <a:buClr>
                 <a:schemeClr val="lt1"/>
               </a:buClr>
-              <a:buSzPts val="3200"/>
               <a:buNone/>
               <a:defRPr sz="3200" b="1" lang="ja-JP">
                 <a:solidFill>
@@ -5444,7 +5410,6 @@
               <a:buClr>
                 <a:schemeClr val="lt1"/>
               </a:buClr>
-              <a:buSzPts val="3200"/>
               <a:buNone/>
               <a:defRPr sz="3200" b="1" lang="ja-JP">
                 <a:solidFill>
@@ -5465,7 +5430,6 @@
               <a:buClr>
                 <a:schemeClr val="lt1"/>
               </a:buClr>
-              <a:buSzPts val="3200"/>
               <a:buNone/>
               <a:defRPr sz="3200" b="1" lang="ja-JP">
                 <a:solidFill>
@@ -5486,7 +5450,6 @@
               <a:buClr>
                 <a:schemeClr val="lt1"/>
               </a:buClr>
-              <a:buSzPts val="3200"/>
               <a:buNone/>
               <a:defRPr sz="3200" b="1" lang="ja-JP">
                 <a:solidFill>
@@ -5507,7 +5470,6 @@
               <a:buClr>
                 <a:schemeClr val="lt1"/>
               </a:buClr>
-              <a:buSzPts val="3200"/>
               <a:buNone/>
               <a:defRPr sz="3200" b="1" lang="ja-JP">
                 <a:solidFill>
@@ -5528,7 +5490,6 @@
               <a:buClr>
                 <a:schemeClr val="lt1"/>
               </a:buClr>
-              <a:buSzPts val="3200"/>
               <a:buNone/>
               <a:defRPr sz="3200" b="1" lang="ja-JP">
                 <a:solidFill>
@@ -5549,7 +5510,6 @@
               <a:buClr>
                 <a:schemeClr val="lt1"/>
               </a:buClr>
-              <a:buSzPts val="3200"/>
               <a:buNone/>
               <a:defRPr sz="3200" b="1" lang="ja-JP">
                 <a:solidFill>
@@ -5570,7 +5530,6 @@
               <a:buClr>
                 <a:schemeClr val="lt1"/>
               </a:buClr>
-              <a:buSzPts val="3200"/>
               <a:buNone/>
               <a:defRPr sz="3200" b="1" lang="ja-JP">
                 <a:solidFill>
@@ -5705,7 +5664,6 @@
               <a:buClr>
                 <a:schemeClr val="dk1"/>
               </a:buClr>
-              <a:buSzPts val="2800"/>
               <a:buNone/>
               <a:defRPr sz="2800" lang="ja-JP">
                 <a:solidFill>
@@ -5726,7 +5684,6 @@
               <a:buClr>
                 <a:schemeClr val="dk1"/>
               </a:buClr>
-              <a:buSzPts val="2800"/>
               <a:buNone/>
               <a:defRPr sz="2800" lang="ja-JP">
                 <a:solidFill>
@@ -5747,7 +5704,6 @@
               <a:buClr>
                 <a:schemeClr val="dk1"/>
               </a:buClr>
-              <a:buSzPts val="2800"/>
               <a:buNone/>
               <a:defRPr sz="2800" lang="ja-JP">
                 <a:solidFill>
@@ -5768,7 +5724,6 @@
               <a:buClr>
                 <a:schemeClr val="dk1"/>
               </a:buClr>
-              <a:buSzPts val="2800"/>
               <a:buNone/>
               <a:defRPr sz="2800" lang="ja-JP">
                 <a:solidFill>
@@ -5789,7 +5744,6 @@
               <a:buClr>
                 <a:schemeClr val="dk1"/>
               </a:buClr>
-              <a:buSzPts val="2800"/>
               <a:buNone/>
               <a:defRPr sz="2800" lang="ja-JP">
                 <a:solidFill>
@@ -5810,7 +5764,6 @@
               <a:buClr>
                 <a:schemeClr val="dk1"/>
               </a:buClr>
-              <a:buSzPts val="2800"/>
               <a:buNone/>
               <a:defRPr sz="2800" lang="ja-JP">
                 <a:solidFill>
@@ -5831,7 +5784,6 @@
               <a:buClr>
                 <a:schemeClr val="dk1"/>
               </a:buClr>
-              <a:buSzPts val="2800"/>
               <a:buNone/>
               <a:defRPr sz="2800" lang="ja-JP">
                 <a:solidFill>
@@ -5852,7 +5804,6 @@
               <a:buClr>
                 <a:schemeClr val="dk1"/>
               </a:buClr>
-              <a:buSzPts val="2800"/>
               <a:buNone/>
               <a:defRPr sz="2800" lang="ja-JP">
                 <a:solidFill>
@@ -5873,7 +5824,6 @@
               <a:buClr>
                 <a:schemeClr val="dk1"/>
               </a:buClr>
-              <a:buSzPts val="2800"/>
               <a:buNone/>
               <a:defRPr sz="2800" lang="ja-JP">
                 <a:solidFill>
@@ -5935,8 +5885,9 @@
               <a:buClr>
                 <a:schemeClr val="dk2"/>
               </a:buClr>
-              <a:buSzPts val="1800"/>
-              <a:buChar char="•"/>
+              <a:buSzPct val="73889"/>
+              <a:buFont typeface="Noto Sans CJK JP"/>
+              <a:buChar char="●"/>
               <a:defRPr sz="1800" lang="ja-JP">
                 <a:solidFill>
                   <a:schemeClr val="dk2"/>
@@ -5959,7 +5910,8 @@
               <a:buClr>
                 <a:schemeClr val="dk2"/>
               </a:buClr>
-              <a:buSzPts val="1400"/>
+              <a:buSzPct val="66500"/>
+              <a:buFont typeface="Noto Sans CJK JP"/>
               <a:buChar char="○"/>
               <a:defRPr lang="ja-JP">
                 <a:solidFill>
@@ -5983,8 +5935,9 @@
               <a:buClr>
                 <a:schemeClr val="dk2"/>
               </a:buClr>
-              <a:buSzPts val="1400"/>
-              <a:buChar char="■"/>
+              <a:buSzPct val="66500"/>
+              <a:buFont typeface="Noto Sans CJK JP"/>
+              <a:buChar char="○"/>
               <a:defRPr lang="ja-JP">
                 <a:solidFill>
                   <a:schemeClr val="dk2"/>
@@ -6007,8 +5960,9 @@
               <a:buClr>
                 <a:schemeClr val="dk2"/>
               </a:buClr>
-              <a:buSzPts val="1400"/>
-              <a:buChar char="•"/>
+              <a:buSzPct val="66500"/>
+              <a:buFont typeface="Noto Sans CJK JP"/>
+              <a:buChar char="○"/>
               <a:defRPr lang="ja-JP">
                 <a:solidFill>
                   <a:schemeClr val="dk2"/>
@@ -6031,7 +5985,8 @@
               <a:buClr>
                 <a:schemeClr val="dk2"/>
               </a:buClr>
-              <a:buSzPts val="1400"/>
+              <a:buSzPct val="66500"/>
+              <a:buFont typeface="Noto Sans CJK JP"/>
               <a:buChar char="○"/>
               <a:defRPr lang="ja-JP">
                 <a:solidFill>
@@ -6055,8 +6010,9 @@
               <a:buClr>
                 <a:schemeClr val="dk2"/>
               </a:buClr>
-              <a:buSzPts val="1400"/>
-              <a:buChar char="■"/>
+              <a:buSzPct val="66500"/>
+              <a:buFont typeface="Noto Sans CJK JP"/>
+              <a:buChar char="○"/>
               <a:defRPr lang="ja-JP">
                 <a:solidFill>
                   <a:schemeClr val="dk2"/>
@@ -6079,8 +6035,9 @@
               <a:buClr>
                 <a:schemeClr val="dk2"/>
               </a:buClr>
-              <a:buSzPts val="1400"/>
-              <a:buChar char="•"/>
+              <a:buSzPct val="66500"/>
+              <a:buFont typeface="Noto Sans CJK JP"/>
+              <a:buChar char="○"/>
               <a:defRPr lang="ja-JP">
                 <a:solidFill>
                   <a:schemeClr val="dk2"/>
@@ -6103,7 +6060,8 @@
               <a:buClr>
                 <a:schemeClr val="dk2"/>
               </a:buClr>
-              <a:buSzPts val="1400"/>
+              <a:buSzPct val="66500"/>
+              <a:buFont typeface="Noto Sans CJK JP"/>
               <a:buChar char="○"/>
               <a:defRPr lang="ja-JP">
                 <a:solidFill>
@@ -6127,8 +6085,9 @@
               <a:buClr>
                 <a:schemeClr val="dk2"/>
               </a:buClr>
-              <a:buSzPts val="1400"/>
-              <a:buChar char="■"/>
+              <a:buSzPct val="66500"/>
+              <a:buFont typeface="Noto Sans CJK JP"/>
+              <a:buChar char="○"/>
               <a:defRPr lang="ja-JP">
                 <a:solidFill>
                   <a:schemeClr val="dk2"/>
@@ -6558,7 +6517,8 @@
         <a:buClr>
           <a:srgbClr val="303437"/>
         </a:buClr>
-        <a:buSzPts val="2000"/>
+        <a:buSzPct val="66500"/>
+        <a:buFont typeface="Noto Sans CJK JP"/>
         <a:buChar char="●"/>
         <a:defRPr sz="2000" lang="ja-JP">
           <a:solidFill>
@@ -6579,7 +6539,8 @@
         <a:buClr>
           <a:srgbClr val="303437"/>
         </a:buClr>
-        <a:buSzPts val="2000"/>
+        <a:buSzPct val="66500"/>
+        <a:buFont typeface="Noto Sans CJK JP"/>
         <a:buChar char="○"/>
         <a:defRPr sz="2000" lang="ja-JP">
           <a:solidFill>
@@ -6600,8 +6561,9 @@
         <a:buClr>
           <a:srgbClr val="303437"/>
         </a:buClr>
-        <a:buSzPts val="2000"/>
-        <a:buChar char="■"/>
+        <a:buSzPct val="66500"/>
+        <a:buFont typeface="Noto Sans CJK JP"/>
+        <a:buChar char="○"/>
         <a:defRPr sz="2000" lang="ja-JP">
           <a:solidFill>
             <a:srgbClr val="303437"/>
@@ -6621,7 +6583,8 @@
         <a:buClr>
           <a:srgbClr val="303437"/>
         </a:buClr>
-        <a:buSzPts val="2200"/>
+        <a:buSzPct val="60455"/>
+        <a:buFont typeface="Noto Sans CJK JP"/>
         <a:buChar char="●"/>
         <a:defRPr sz="2200" lang="ja-JP">
           <a:solidFill>
@@ -6642,7 +6605,8 @@
         <a:buClr>
           <a:srgbClr val="303437"/>
         </a:buClr>
-        <a:buSzPts val="2000"/>
+        <a:buSzPct val="66500"/>
+        <a:buFont typeface="Noto Sans CJK JP"/>
         <a:buChar char="○"/>
         <a:defRPr sz="2000" lang="ja-JP">
           <a:solidFill>
@@ -6663,8 +6627,9 @@
         <a:buClr>
           <a:srgbClr val="303437"/>
         </a:buClr>
-        <a:buSzPts val="2000"/>
-        <a:buChar char="■"/>
+        <a:buSzPct val="66500"/>
+        <a:buFont typeface="Noto Sans CJK JP"/>
+        <a:buChar char="○"/>
         <a:defRPr sz="2000" lang="ja-JP">
           <a:solidFill>
             <a:srgbClr val="303437"/>
@@ -6684,7 +6649,8 @@
         <a:buClr>
           <a:srgbClr val="303437"/>
         </a:buClr>
-        <a:buSzPts val="2000"/>
+        <a:buSzPct val="66500"/>
+        <a:buFont typeface="Noto Sans CJK JP"/>
         <a:buChar char="●"/>
         <a:defRPr sz="2000" lang="ja-JP">
           <a:solidFill>
@@ -6705,7 +6671,8 @@
         <a:buClr>
           <a:srgbClr val="303437"/>
         </a:buClr>
-        <a:buSzPts val="2000"/>
+        <a:buSzPct val="66500"/>
+        <a:buFont typeface="Noto Sans CJK JP"/>
         <a:buChar char="○"/>
         <a:defRPr sz="2000" lang="ja-JP">
           <a:solidFill>
@@ -6726,8 +6693,9 @@
         <a:buClr>
           <a:srgbClr val="303437"/>
         </a:buClr>
-        <a:buSzPts val="2000"/>
-        <a:buChar char="■"/>
+        <a:buSzPct val="66500"/>
+        <a:buFont typeface="Noto Sans CJK JP"/>
+        <a:buChar char="○"/>
         <a:defRPr sz="2000" lang="ja-JP">
           <a:solidFill>
             <a:srgbClr val="303437"/>

</xml_diff>

<commit_message>
Fix contents spacing, page number alignment, and citation layout
</commit_message>
<xml_diff>
--- a/.agents/skills/master-guided-slides/SlideMaster.pptx
+++ b/.agents/skills/master-guided-slides/SlideMaster.pptx
@@ -716,8 +716,8 @@
         </p:nvSpPr>
         <p:spPr>
           <a:xfrm>
-            <a:off x="8607898" y="-10450"/>
-            <a:ext cx="548701" cy="479700"/>
+            <a:off x="8412480" y="7937"/>
+            <a:ext cx="640080" cy="480059"/>
           </a:xfrm>
           <a:prstGeom prst="rect">
             <a:avLst/>
@@ -728,10 +728,20 @@
           </a:ln>
         </p:spPr>
         <p:txBody>
-          <a:bodyPr anchor="ctr"/>
+          <a:bodyPr anchor="ctr" lIns="0" tIns="0" bIns="0"/>
           <a:lstStyle/>
           <a:p>
-            <a:pPr algn="ctr"/>
+            <a:pPr algn="r">
+              <a:lnSpc>
+                <a:spcPct val="100000"/>
+              </a:lnSpc>
+              <a:spcBef>
+                <a:spcPts val="0"/>
+              </a:spcBef>
+              <a:spcAft>
+                <a:spcPts val="0"/>
+              </a:spcAft>
+            </a:pPr>
             <a:fld id="{00000000-1234-1234-1234-000000000999}" type="slidenum">
               <a:rPr lang="ja-JP" sz="1800" b="1">
                 <a:solidFill>
@@ -2179,8 +2189,8 @@
         </p:nvSpPr>
         <p:spPr>
           <a:xfrm>
-            <a:off x="8501908" y="28683"/>
-            <a:ext cx="548700" cy="393600"/>
+            <a:off x="8412480" y="7937"/>
+            <a:ext cx="640080" cy="480059"/>
           </a:xfrm>
           <a:prstGeom prst="rect">
             <a:avLst/>
@@ -2191,10 +2201,20 @@
           </a:ln>
         </p:spPr>
         <p:txBody>
-          <a:bodyPr anchor="ctr"/>
+          <a:bodyPr anchor="ctr" lIns="0" tIns="0" bIns="0"/>
           <a:lstStyle/>
           <a:p>
-            <a:pPr algn="r"/>
+            <a:pPr algn="r">
+              <a:lnSpc>
+                <a:spcPct val="100000"/>
+              </a:lnSpc>
+              <a:spcBef>
+                <a:spcPts val="0"/>
+              </a:spcBef>
+              <a:spcAft>
+                <a:spcPts val="0"/>
+              </a:spcAft>
+            </a:pPr>
             <a:fld id="{00000000-1234-1234-1234-000000000999}" type="slidenum">
               <a:rPr lang="ja-JP" sz="1800" b="1">
                 <a:solidFill>
@@ -2872,8 +2892,8 @@
         </p:nvSpPr>
         <p:spPr>
           <a:xfrm>
-            <a:off x="8501908" y="28683"/>
-            <a:ext cx="548700" cy="393600"/>
+            <a:off x="8412480" y="7937"/>
+            <a:ext cx="640080" cy="480059"/>
           </a:xfrm>
           <a:prstGeom prst="rect">
             <a:avLst/>
@@ -2884,10 +2904,20 @@
           </a:ln>
         </p:spPr>
         <p:txBody>
-          <a:bodyPr anchor="ctr"/>
+          <a:bodyPr anchor="ctr" lIns="0" tIns="0" bIns="0"/>
           <a:lstStyle/>
           <a:p>
-            <a:pPr algn="r"/>
+            <a:pPr algn="r">
+              <a:lnSpc>
+                <a:spcPct val="100000"/>
+              </a:lnSpc>
+              <a:spcBef>
+                <a:spcPts val="0"/>
+              </a:spcBef>
+              <a:spcAft>
+                <a:spcPts val="0"/>
+              </a:spcAft>
+            </a:pPr>
             <a:fld id="{00000000-1234-1234-1234-000000000999}" type="slidenum">
               <a:rPr lang="ja-JP" sz="1800" b="1">
                 <a:solidFill>
@@ -3333,8 +3363,8 @@
         </p:nvSpPr>
         <p:spPr>
           <a:xfrm>
-            <a:off x="8501908" y="28683"/>
-            <a:ext cx="548700" cy="393600"/>
+            <a:off x="8412480" y="7937"/>
+            <a:ext cx="640080" cy="480059"/>
           </a:xfrm>
           <a:prstGeom prst="rect">
             <a:avLst/>
@@ -3345,10 +3375,20 @@
           </a:ln>
         </p:spPr>
         <p:txBody>
-          <a:bodyPr anchor="ctr"/>
+          <a:bodyPr anchor="ctr" lIns="0" tIns="0" bIns="0"/>
           <a:lstStyle/>
           <a:p>
-            <a:pPr algn="r"/>
+            <a:pPr algn="r">
+              <a:lnSpc>
+                <a:spcPct val="100000"/>
+              </a:lnSpc>
+              <a:spcBef>
+                <a:spcPts val="0"/>
+              </a:spcBef>
+              <a:spcAft>
+                <a:spcPts val="0"/>
+              </a:spcAft>
+            </a:pPr>
             <a:fld id="{00000000-1234-1234-1234-000000000999}" type="slidenum">
               <a:rPr lang="ja-JP" sz="1800" b="1">
                 <a:solidFill>
@@ -3794,8 +3834,8 @@
         </p:nvSpPr>
         <p:spPr>
           <a:xfrm>
-            <a:off x="8501908" y="28683"/>
-            <a:ext cx="548700" cy="393600"/>
+            <a:off x="8412480" y="7937"/>
+            <a:ext cx="640080" cy="480059"/>
           </a:xfrm>
           <a:prstGeom prst="rect">
             <a:avLst/>
@@ -3806,10 +3846,20 @@
           </a:ln>
         </p:spPr>
         <p:txBody>
-          <a:bodyPr anchor="ctr"/>
+          <a:bodyPr anchor="ctr" lIns="0" tIns="0" bIns="0"/>
           <a:lstStyle/>
           <a:p>
-            <a:pPr algn="r"/>
+            <a:pPr algn="r">
+              <a:lnSpc>
+                <a:spcPct val="100000"/>
+              </a:lnSpc>
+              <a:spcBef>
+                <a:spcPts val="0"/>
+              </a:spcBef>
+              <a:spcAft>
+                <a:spcPts val="0"/>
+              </a:spcAft>
+            </a:pPr>
             <a:fld id="{00000000-1234-1234-1234-000000000999}" type="slidenum">
               <a:rPr lang="ja-JP" sz="1800" b="1">
                 <a:solidFill>
@@ -4321,8 +4371,8 @@
         </p:nvSpPr>
         <p:spPr>
           <a:xfrm>
-            <a:off x="8501908" y="28683"/>
-            <a:ext cx="548700" cy="393600"/>
+            <a:off x="8412480" y="7937"/>
+            <a:ext cx="640080" cy="480059"/>
           </a:xfrm>
           <a:prstGeom prst="rect">
             <a:avLst/>
@@ -4333,10 +4383,20 @@
           </a:ln>
         </p:spPr>
         <p:txBody>
-          <a:bodyPr anchor="ctr"/>
+          <a:bodyPr anchor="ctr" lIns="0" tIns="0" bIns="0"/>
           <a:lstStyle/>
           <a:p>
-            <a:pPr algn="r"/>
+            <a:pPr algn="r">
+              <a:lnSpc>
+                <a:spcPct val="100000"/>
+              </a:lnSpc>
+              <a:spcBef>
+                <a:spcPts val="0"/>
+              </a:spcBef>
+              <a:spcAft>
+                <a:spcPts val="0"/>
+              </a:spcAft>
+            </a:pPr>
             <a:fld id="{00000000-1234-1234-1234-000000000999}" type="slidenum">
               <a:rPr lang="ja-JP" sz="1800" b="1">
                 <a:solidFill>
@@ -4616,8 +4676,8 @@
         </p:nvSpPr>
         <p:spPr>
           <a:xfrm>
-            <a:off x="8501908" y="28683"/>
-            <a:ext cx="548700" cy="393600"/>
+            <a:off x="8412480" y="7937"/>
+            <a:ext cx="640080" cy="480059"/>
           </a:xfrm>
           <a:prstGeom prst="rect">
             <a:avLst/>
@@ -4628,10 +4688,20 @@
           </a:ln>
         </p:spPr>
         <p:txBody>
-          <a:bodyPr anchor="ctr"/>
+          <a:bodyPr anchor="ctr" lIns="0" tIns="0" bIns="0"/>
           <a:lstStyle/>
           <a:p>
-            <a:pPr algn="r"/>
+            <a:pPr algn="r">
+              <a:lnSpc>
+                <a:spcPct val="100000"/>
+              </a:lnSpc>
+              <a:spcBef>
+                <a:spcPts val="0"/>
+              </a:spcBef>
+              <a:spcAft>
+                <a:spcPts val="0"/>
+              </a:spcAft>
+            </a:pPr>
             <a:fld id="{00000000-1234-1234-1234-000000000999}" type="slidenum">
               <a:rPr lang="ja-JP" sz="1800" b="1">
                 <a:solidFill>
@@ -5244,8 +5314,8 @@
         </p:nvSpPr>
         <p:spPr>
           <a:xfrm>
-            <a:off x="8501908" y="28683"/>
-            <a:ext cx="548700" cy="393600"/>
+            <a:off x="8412480" y="7937"/>
+            <a:ext cx="640080" cy="480059"/>
           </a:xfrm>
           <a:prstGeom prst="rect">
             <a:avLst/>
@@ -5256,10 +5326,20 @@
           </a:ln>
         </p:spPr>
         <p:txBody>
-          <a:bodyPr anchor="ctr"/>
+          <a:bodyPr anchor="ctr" lIns="0" tIns="0" bIns="0"/>
           <a:lstStyle/>
           <a:p>
-            <a:pPr algn="r"/>
+            <a:pPr algn="r">
+              <a:lnSpc>
+                <a:spcPct val="100000"/>
+              </a:lnSpc>
+              <a:spcBef>
+                <a:spcPts val="0"/>
+              </a:spcBef>
+              <a:spcAft>
+                <a:spcPts val="0"/>
+              </a:spcAft>
+            </a:pPr>
             <a:fld id="{00000000-1234-1234-1234-000000000999}" type="slidenum">
               <a:rPr lang="ja-JP" sz="1800" b="1">
                 <a:solidFill>
@@ -5558,8 +5638,8 @@
         </p:nvSpPr>
         <p:spPr>
           <a:xfrm>
-            <a:off x="8472458" y="28683"/>
-            <a:ext cx="548700" cy="393600"/>
+            <a:off x="8412480" y="7937"/>
+            <a:ext cx="640080" cy="480059"/>
           </a:xfrm>
           <a:prstGeom prst="rect">
             <a:avLst/>
@@ -5570,10 +5650,20 @@
           </a:ln>
         </p:spPr>
         <p:txBody>
-          <a:bodyPr anchor="ctr"/>
+          <a:bodyPr anchor="ctr" lIns="0" tIns="0" bIns="0"/>
           <a:lstStyle/>
           <a:p>
-            <a:pPr algn="r"/>
+            <a:pPr algn="r">
+              <a:lnSpc>
+                <a:spcPct val="100000"/>
+              </a:lnSpc>
+              <a:spcBef>
+                <a:spcPts val="0"/>
+              </a:spcBef>
+              <a:spcAft>
+                <a:spcPts val="0"/>
+              </a:spcAft>
+            </a:pPr>
             <a:fld id="{00000000-1234-1234-1234-000000000999}" type="slidenum">
               <a:rPr lang="ja-JP" sz="1800" b="1">
                 <a:solidFill>
@@ -6119,8 +6209,8 @@
         </p:nvSpPr>
         <p:spPr>
           <a:xfrm>
-            <a:off x="8472458" y="4663217"/>
-            <a:ext cx="548700" cy="393600"/>
+            <a:off x="8412480" y="7937"/>
+            <a:ext cx="640080" cy="480059"/>
           </a:xfrm>
           <a:prstGeom prst="rect">
             <a:avLst/>
@@ -6131,7 +6221,7 @@
           </a:ln>
         </p:spPr>
         <p:txBody>
-          <a:bodyPr spcFirstLastPara="1" wrap="square" lIns="91425" tIns="91425" rIns="91425" bIns="91425" anchor="ctr" anchorCtr="0">
+          <a:bodyPr spcFirstLastPara="1" wrap="square" lIns="0" tIns="0" bIns="0" anchor="ctr" anchorCtr="0">
             <a:normAutofit/>
           </a:bodyPr>
           <a:lstStyle>
@@ -6237,6 +6327,9 @@
           </a:lstStyle>
           <a:p>
             <a:pPr marL="0" lvl="0" indent="0" algn="r" rtl="0">
+              <a:lnSpc>
+                <a:spcPct val="100000"/>
+              </a:lnSpc>
               <a:spcBef>
                 <a:spcPts val="0"/>
               </a:spcBef>

</xml_diff>

<commit_message>
Add dataset slide gallery for GitHub Pages and unify slide styling
</commit_message>
<xml_diff>
--- a/.agents/skills/master-guided-slides/SlideMaster.pptx
+++ b/.agents/skills/master-guided-slides/SlideMaster.pptx
@@ -1625,9 +1625,14 @@
                 <a:spcPts val="0"/>
               </a:spcAft>
               <a:buNone/>
+              <a:defRPr sz="1400" b="1" lang="ja-JP" altLang="en-US">
+                <a:latin typeface="Noto Sans"/>
+                <a:ea typeface="Noto Sans CJK JP"/>
+                <a:cs typeface="Noto Sans"/>
+              </a:defRPr>
             </a:pPr>
             <a:r>
-              <a:rPr lang="ja-JP" altLang="ja" b="1" dirty="0">
+              <a:rPr lang="ja-JP" altLang="en-US" b="1" dirty="0" sz="1400">
                 <a:solidFill>
                   <a:schemeClr val="lt1"/>
                 </a:solidFill>
@@ -1638,7 +1643,7 @@
               <a:t>T</a:t>
             </a:r>
             <a:r>
-              <a:rPr lang="ja-JP" b="1" dirty="0">
+              <a:rPr lang="ja-JP" b="1" dirty="0" sz="1400" altLang="en-US">
                 <a:solidFill>
                   <a:schemeClr val="lt1"/>
                 </a:solidFill>
@@ -1649,7 +1654,7 @@
               <a:t>able of </a:t>
             </a:r>
             <a:r>
-              <a:rPr lang="ja-JP" altLang="ja" b="1" dirty="0">
+              <a:rPr lang="ja-JP" altLang="en-US" b="1" dirty="0" sz="1400">
                 <a:solidFill>
                   <a:schemeClr val="lt1"/>
                 </a:solidFill>
@@ -1660,7 +1665,7 @@
               <a:t>C</a:t>
             </a:r>
             <a:r>
-              <a:rPr lang="ja-JP" b="1" dirty="0">
+              <a:rPr lang="ja-JP" b="1" dirty="0" sz="1400" altLang="en-US">
                 <a:solidFill>
                   <a:schemeClr val="lt1"/>
                 </a:solidFill>
@@ -1670,7 +1675,7 @@
               </a:rPr>
               <a:t>ontents</a:t>
             </a:r>
-            <a:endParaRPr b="1" dirty="0" lang="ja-JP">
+            <a:endParaRPr b="1" dirty="0" lang="ja-JP" sz="1400" altLang="en-US">
               <a:solidFill>
                 <a:schemeClr val="lt1"/>
               </a:solidFill>
@@ -2742,7 +2747,7 @@
                 <a:schemeClr val="lt1"/>
               </a:buClr>
               <a:buNone/>
-              <a:defRPr sz="1400" b="1" lang="ja-JP">
+              <a:defRPr sz="1400" b="1" lang="ja-JP" altLang="en-US">
                 <a:solidFill>
                   <a:schemeClr val="lt1"/>
                 </a:solidFill>
@@ -2759,7 +2764,7 @@
                 <a:spcPts val="0"/>
               </a:spcAft>
               <a:buNone/>
-              <a:defRPr lang="ja-JP">
+              <a:defRPr lang="ja-JP" sz="1400" b="1" altLang="en-US">
                 <a:latin typeface="Noto Sans"/>
                 <a:ea typeface="Noto Sans CJK JP"/>
                 <a:cs typeface="Noto Sans"/>
@@ -2773,7 +2778,7 @@
                 <a:spcPts val="0"/>
               </a:spcAft>
               <a:buNone/>
-              <a:defRPr lang="ja-JP">
+              <a:defRPr lang="ja-JP" sz="1400" b="1" altLang="en-US">
                 <a:latin typeface="Noto Sans"/>
                 <a:ea typeface="Noto Sans CJK JP"/>
                 <a:cs typeface="Noto Sans"/>
@@ -2787,7 +2792,7 @@
                 <a:spcPts val="0"/>
               </a:spcAft>
               <a:buNone/>
-              <a:defRPr lang="ja-JP">
+              <a:defRPr lang="ja-JP" sz="1400" b="1" altLang="en-US">
                 <a:latin typeface="Noto Sans"/>
                 <a:ea typeface="Noto Sans CJK JP"/>
                 <a:cs typeface="Noto Sans"/>
@@ -2801,7 +2806,7 @@
                 <a:spcPts val="0"/>
               </a:spcAft>
               <a:buNone/>
-              <a:defRPr lang="ja-JP">
+              <a:defRPr lang="ja-JP" sz="1400" b="1" altLang="en-US">
                 <a:latin typeface="Noto Sans"/>
                 <a:ea typeface="Noto Sans CJK JP"/>
                 <a:cs typeface="Noto Sans"/>
@@ -2815,7 +2820,7 @@
                 <a:spcPts val="0"/>
               </a:spcAft>
               <a:buNone/>
-              <a:defRPr lang="ja-JP">
+              <a:defRPr lang="ja-JP" sz="1400" b="1" altLang="en-US">
                 <a:latin typeface="Noto Sans"/>
                 <a:ea typeface="Noto Sans CJK JP"/>
                 <a:cs typeface="Noto Sans"/>
@@ -2829,7 +2834,7 @@
                 <a:spcPts val="0"/>
               </a:spcAft>
               <a:buNone/>
-              <a:defRPr lang="ja-JP">
+              <a:defRPr lang="ja-JP" sz="1400" b="1" altLang="en-US">
                 <a:latin typeface="Noto Sans"/>
                 <a:ea typeface="Noto Sans CJK JP"/>
                 <a:cs typeface="Noto Sans"/>
@@ -2843,7 +2848,7 @@
                 <a:spcPts val="0"/>
               </a:spcAft>
               <a:buNone/>
-              <a:defRPr lang="ja-JP">
+              <a:defRPr lang="ja-JP" sz="1400" b="1" altLang="en-US">
                 <a:latin typeface="Noto Sans"/>
                 <a:ea typeface="Noto Sans CJK JP"/>
                 <a:cs typeface="Noto Sans"/>
@@ -2857,7 +2862,7 @@
                 <a:spcPts val="0"/>
               </a:spcAft>
               <a:buNone/>
-              <a:defRPr lang="ja-JP">
+              <a:defRPr lang="ja-JP" sz="1400" b="1" altLang="en-US">
                 <a:latin typeface="Noto Sans"/>
                 <a:ea typeface="Noto Sans CJK JP"/>
                 <a:cs typeface="Noto Sans"/>
@@ -2875,8 +2880,13 @@
               <a:spcAft>
                 <a:spcPts val="0"/>
               </a:spcAft>
+              <a:defRPr sz="1400" b="1" lang="ja-JP" altLang="en-US">
+                <a:latin typeface="Noto Sans"/>
+                <a:ea typeface="Noto Sans CJK JP"/>
+                <a:cs typeface="Noto Sans"/>
+              </a:defRPr>
             </a:pPr>
-            <a:endParaRPr lang="ja-JP">
+            <a:endParaRPr lang="ja-JP" sz="1400" b="1" altLang="en-US">
               <a:latin typeface="Noto Sans"/>
               <a:ea typeface="Noto Sans CJK JP"/>
               <a:cs typeface="Noto Sans"/>
@@ -3213,7 +3223,7 @@
                 <a:schemeClr val="lt1"/>
               </a:buClr>
               <a:buNone/>
-              <a:defRPr sz="1400" b="1" lang="ja-JP">
+              <a:defRPr sz="1400" b="1" lang="ja-JP" altLang="en-US">
                 <a:solidFill>
                   <a:schemeClr val="lt1"/>
                 </a:solidFill>
@@ -3230,7 +3240,7 @@
                 <a:spcPts val="0"/>
               </a:spcAft>
               <a:buNone/>
-              <a:defRPr lang="ja-JP">
+              <a:defRPr lang="ja-JP" sz="1400" b="1" altLang="en-US">
                 <a:latin typeface="Noto Sans"/>
                 <a:ea typeface="Noto Sans CJK JP"/>
                 <a:cs typeface="Noto Sans"/>
@@ -3244,7 +3254,7 @@
                 <a:spcPts val="0"/>
               </a:spcAft>
               <a:buNone/>
-              <a:defRPr lang="ja-JP">
+              <a:defRPr lang="ja-JP" sz="1400" b="1" altLang="en-US">
                 <a:latin typeface="Noto Sans"/>
                 <a:ea typeface="Noto Sans CJK JP"/>
                 <a:cs typeface="Noto Sans"/>
@@ -3258,7 +3268,7 @@
                 <a:spcPts val="0"/>
               </a:spcAft>
               <a:buNone/>
-              <a:defRPr lang="ja-JP">
+              <a:defRPr lang="ja-JP" sz="1400" b="1" altLang="en-US">
                 <a:latin typeface="Noto Sans"/>
                 <a:ea typeface="Noto Sans CJK JP"/>
                 <a:cs typeface="Noto Sans"/>
@@ -3272,7 +3282,7 @@
                 <a:spcPts val="0"/>
               </a:spcAft>
               <a:buNone/>
-              <a:defRPr lang="ja-JP">
+              <a:defRPr lang="ja-JP" sz="1400" b="1" altLang="en-US">
                 <a:latin typeface="Noto Sans"/>
                 <a:ea typeface="Noto Sans CJK JP"/>
                 <a:cs typeface="Noto Sans"/>
@@ -3286,7 +3296,7 @@
                 <a:spcPts val="0"/>
               </a:spcAft>
               <a:buNone/>
-              <a:defRPr lang="ja-JP">
+              <a:defRPr lang="ja-JP" sz="1400" b="1" altLang="en-US">
                 <a:latin typeface="Noto Sans"/>
                 <a:ea typeface="Noto Sans CJK JP"/>
                 <a:cs typeface="Noto Sans"/>
@@ -3300,7 +3310,7 @@
                 <a:spcPts val="0"/>
               </a:spcAft>
               <a:buNone/>
-              <a:defRPr lang="ja-JP">
+              <a:defRPr lang="ja-JP" sz="1400" b="1" altLang="en-US">
                 <a:latin typeface="Noto Sans"/>
                 <a:ea typeface="Noto Sans CJK JP"/>
                 <a:cs typeface="Noto Sans"/>
@@ -3314,7 +3324,7 @@
                 <a:spcPts val="0"/>
               </a:spcAft>
               <a:buNone/>
-              <a:defRPr lang="ja-JP">
+              <a:defRPr lang="ja-JP" sz="1400" b="1" altLang="en-US">
                 <a:latin typeface="Noto Sans"/>
                 <a:ea typeface="Noto Sans CJK JP"/>
                 <a:cs typeface="Noto Sans"/>
@@ -3328,7 +3338,7 @@
                 <a:spcPts val="0"/>
               </a:spcAft>
               <a:buNone/>
-              <a:defRPr lang="ja-JP">
+              <a:defRPr lang="ja-JP" sz="1400" b="1" altLang="en-US">
                 <a:latin typeface="Noto Sans"/>
                 <a:ea typeface="Noto Sans CJK JP"/>
                 <a:cs typeface="Noto Sans"/>
@@ -3346,8 +3356,13 @@
               <a:spcAft>
                 <a:spcPts val="0"/>
               </a:spcAft>
+              <a:defRPr sz="1400" b="1" lang="ja-JP" altLang="en-US">
+                <a:latin typeface="Noto Sans"/>
+                <a:ea typeface="Noto Sans CJK JP"/>
+                <a:cs typeface="Noto Sans"/>
+              </a:defRPr>
             </a:pPr>
-            <a:endParaRPr lang="ja-JP">
+            <a:endParaRPr lang="ja-JP" sz="1400" b="1" altLang="en-US">
               <a:latin typeface="Noto Sans"/>
               <a:ea typeface="Noto Sans CJK JP"/>
               <a:cs typeface="Noto Sans"/>
@@ -3417,7 +3432,7 @@
 </file>
 
 <file path=ppt/slideLayouts/slideLayout5.xml><?xml version="1.0" encoding="utf-8"?>
-<p:sldLayout xmlns:a="http://schemas.openxmlformats.org/drawingml/2006/main" xmlns:r="http://schemas.openxmlformats.org/officeDocument/2006/relationships" xmlns:p="http://schemas.openxmlformats.org/presentationml/2006/main" matchingName="transition">
+<p:sldLayout xmlns:a="http://schemas.openxmlformats.org/drawingml/2006/main" xmlns:r="http://schemas.openxmlformats.org/officeDocument/2006/relationships" xmlns:p="http://schemas.openxmlformats.org/presentationml/2006/main" matchingName="transition" type="secHead">
   <p:cSld name="ONE_COLUMN_TEXT_1_4_1">
     <p:spTree>
       <p:nvGrpSpPr>
@@ -3492,19 +3507,19 @@
         </p:nvSpPr>
         <p:spPr>
           <a:xfrm>
-            <a:off x="468600" y="2263650"/>
-            <a:ext cx="8206800" cy="616200"/>
+            <a:off x="548640" y="2414016"/>
+            <a:ext cx="8046720" cy="822960"/>
           </a:xfrm>
           <a:prstGeom prst="rect">
             <a:avLst/>
           </a:prstGeom>
         </p:spPr>
         <p:txBody>
-          <a:bodyPr spcFirstLastPara="1" wrap="none" lIns="91425" tIns="91425" rIns="91425" bIns="91425" anchor="t" anchorCtr="0">
+          <a:bodyPr spcFirstLastPara="1" wrap="none" lIns="0" tIns="0" rIns="0" bIns="0" anchor="ctr" anchorCtr="0">
             <a:normAutofit/>
           </a:bodyPr>
           <a:lstStyle>
-            <a:lvl1pPr lvl="0" rtl="0">
+            <a:lvl1pPr lvl="0" rtl="0" algn="ctr">
               <a:spcBef>
                 <a:spcPts val="0"/>
               </a:spcBef>
@@ -3515,7 +3530,7 @@
                 <a:schemeClr val="dk1"/>
               </a:buClr>
               <a:buNone/>
-              <a:defRPr sz="3000" b="1" lang="ja-JP">
+              <a:defRPr sz="3600" b="1" lang="ja-JP" altLang="en-US">
                 <a:solidFill>
                   <a:schemeClr val="dk1"/>
                 </a:solidFill>
@@ -3524,113 +3539,113 @@
                 <a:cs typeface="Noto Sans"/>
               </a:defRPr>
             </a:lvl1pPr>
-            <a:lvl2pPr lvl="1" rtl="0">
-              <a:spcBef>
-                <a:spcPts val="0"/>
-              </a:spcBef>
-              <a:spcAft>
-                <a:spcPts val="0"/>
-              </a:spcAft>
-              <a:buNone/>
-              <a:defRPr lang="ja-JP">
+            <a:lvl2pPr lvl="1" rtl="0" algn="ctr">
+              <a:spcBef>
+                <a:spcPts val="0"/>
+              </a:spcBef>
+              <a:spcAft>
+                <a:spcPts val="0"/>
+              </a:spcAft>
+              <a:buNone/>
+              <a:defRPr lang="ja-JP" sz="3600" b="1" altLang="en-US">
                 <a:latin typeface="Noto Sans"/>
                 <a:ea typeface="Noto Sans CJK JP"/>
                 <a:cs typeface="Noto Sans"/>
               </a:defRPr>
             </a:lvl2pPr>
-            <a:lvl3pPr lvl="2" rtl="0">
-              <a:spcBef>
-                <a:spcPts val="0"/>
-              </a:spcBef>
-              <a:spcAft>
-                <a:spcPts val="0"/>
-              </a:spcAft>
-              <a:buNone/>
-              <a:defRPr lang="ja-JP">
+            <a:lvl3pPr lvl="2" rtl="0" algn="ctr">
+              <a:spcBef>
+                <a:spcPts val="0"/>
+              </a:spcBef>
+              <a:spcAft>
+                <a:spcPts val="0"/>
+              </a:spcAft>
+              <a:buNone/>
+              <a:defRPr lang="ja-JP" sz="3600" b="1" altLang="en-US">
                 <a:latin typeface="Noto Sans"/>
                 <a:ea typeface="Noto Sans CJK JP"/>
                 <a:cs typeface="Noto Sans"/>
               </a:defRPr>
             </a:lvl3pPr>
-            <a:lvl4pPr lvl="3" rtl="0">
-              <a:spcBef>
-                <a:spcPts val="0"/>
-              </a:spcBef>
-              <a:spcAft>
-                <a:spcPts val="0"/>
-              </a:spcAft>
-              <a:buNone/>
-              <a:defRPr lang="ja-JP">
+            <a:lvl4pPr lvl="3" rtl="0" algn="ctr">
+              <a:spcBef>
+                <a:spcPts val="0"/>
+              </a:spcBef>
+              <a:spcAft>
+                <a:spcPts val="0"/>
+              </a:spcAft>
+              <a:buNone/>
+              <a:defRPr lang="ja-JP" sz="3600" b="1" altLang="en-US">
                 <a:latin typeface="Noto Sans"/>
                 <a:ea typeface="Noto Sans CJK JP"/>
                 <a:cs typeface="Noto Sans"/>
               </a:defRPr>
             </a:lvl4pPr>
-            <a:lvl5pPr lvl="4" rtl="0">
-              <a:spcBef>
-                <a:spcPts val="0"/>
-              </a:spcBef>
-              <a:spcAft>
-                <a:spcPts val="0"/>
-              </a:spcAft>
-              <a:buNone/>
-              <a:defRPr lang="ja-JP">
+            <a:lvl5pPr lvl="4" rtl="0" algn="ctr">
+              <a:spcBef>
+                <a:spcPts val="0"/>
+              </a:spcBef>
+              <a:spcAft>
+                <a:spcPts val="0"/>
+              </a:spcAft>
+              <a:buNone/>
+              <a:defRPr lang="ja-JP" sz="3600" b="1" altLang="en-US">
                 <a:latin typeface="Noto Sans"/>
                 <a:ea typeface="Noto Sans CJK JP"/>
                 <a:cs typeface="Noto Sans"/>
               </a:defRPr>
             </a:lvl5pPr>
-            <a:lvl6pPr lvl="5" rtl="0">
-              <a:spcBef>
-                <a:spcPts val="0"/>
-              </a:spcBef>
-              <a:spcAft>
-                <a:spcPts val="0"/>
-              </a:spcAft>
-              <a:buNone/>
-              <a:defRPr lang="ja-JP">
+            <a:lvl6pPr lvl="5" rtl="0" algn="ctr">
+              <a:spcBef>
+                <a:spcPts val="0"/>
+              </a:spcBef>
+              <a:spcAft>
+                <a:spcPts val="0"/>
+              </a:spcAft>
+              <a:buNone/>
+              <a:defRPr lang="ja-JP" sz="3600" b="1" altLang="en-US">
                 <a:latin typeface="Noto Sans"/>
                 <a:ea typeface="Noto Sans CJK JP"/>
                 <a:cs typeface="Noto Sans"/>
               </a:defRPr>
             </a:lvl6pPr>
-            <a:lvl7pPr lvl="6" rtl="0">
-              <a:spcBef>
-                <a:spcPts val="0"/>
-              </a:spcBef>
-              <a:spcAft>
-                <a:spcPts val="0"/>
-              </a:spcAft>
-              <a:buNone/>
-              <a:defRPr lang="ja-JP">
+            <a:lvl7pPr lvl="6" rtl="0" algn="ctr">
+              <a:spcBef>
+                <a:spcPts val="0"/>
+              </a:spcBef>
+              <a:spcAft>
+                <a:spcPts val="0"/>
+              </a:spcAft>
+              <a:buNone/>
+              <a:defRPr lang="ja-JP" sz="3600" b="1" altLang="en-US">
                 <a:latin typeface="Noto Sans"/>
                 <a:ea typeface="Noto Sans CJK JP"/>
                 <a:cs typeface="Noto Sans"/>
               </a:defRPr>
             </a:lvl7pPr>
-            <a:lvl8pPr lvl="7" rtl="0">
-              <a:spcBef>
-                <a:spcPts val="0"/>
-              </a:spcBef>
-              <a:spcAft>
-                <a:spcPts val="0"/>
-              </a:spcAft>
-              <a:buNone/>
-              <a:defRPr lang="ja-JP">
+            <a:lvl8pPr lvl="7" rtl="0" algn="ctr">
+              <a:spcBef>
+                <a:spcPts val="0"/>
+              </a:spcBef>
+              <a:spcAft>
+                <a:spcPts val="0"/>
+              </a:spcAft>
+              <a:buNone/>
+              <a:defRPr lang="ja-JP" sz="3600" b="1" altLang="en-US">
                 <a:latin typeface="Noto Sans"/>
                 <a:ea typeface="Noto Sans CJK JP"/>
                 <a:cs typeface="Noto Sans"/>
               </a:defRPr>
             </a:lvl8pPr>
-            <a:lvl9pPr lvl="8" rtl="0">
-              <a:spcBef>
-                <a:spcPts val="0"/>
-              </a:spcBef>
-              <a:spcAft>
-                <a:spcPts val="0"/>
-              </a:spcAft>
-              <a:buNone/>
-              <a:defRPr lang="ja-JP">
+            <a:lvl9pPr lvl="8" rtl="0" algn="ctr">
+              <a:spcBef>
+                <a:spcPts val="0"/>
+              </a:spcBef>
+              <a:spcAft>
+                <a:spcPts val="0"/>
+              </a:spcAft>
+              <a:buNone/>
+              <a:defRPr lang="ja-JP" sz="3600" b="1" altLang="en-US">
                 <a:latin typeface="Noto Sans"/>
                 <a:ea typeface="Noto Sans CJK JP"/>
                 <a:cs typeface="Noto Sans"/>
@@ -3638,7 +3653,17 @@
             </a:lvl9pPr>
           </a:lstStyle>
           <a:p>
-            <a:endParaRPr lang="ja-JP">
+            <a:pPr algn="ctr">
+              <a:lnSpc>
+                <a:spcPct val="110000"/>
+              </a:lnSpc>
+              <a:defRPr sz="3600" b="1" lang="ja-JP" altLang="en-US">
+                <a:latin typeface="Noto Sans"/>
+                <a:ea typeface="Noto Sans CJK JP"/>
+                <a:cs typeface="Noto Sans"/>
+              </a:defRPr>
+            </a:pPr>
+            <a:endParaRPr lang="ja-JP" sz="3600" b="1" altLang="en-US">
               <a:latin typeface="Noto Sans"/>
               <a:ea typeface="Noto Sans CJK JP"/>
               <a:cs typeface="Noto Sans"/>
@@ -3684,7 +3709,7 @@
                 <a:schemeClr val="lt1"/>
               </a:buClr>
               <a:buNone/>
-              <a:defRPr sz="1400" b="1" lang="ja-JP">
+              <a:defRPr sz="1400" b="1" lang="ja-JP" altLang="en-US">
                 <a:solidFill>
                   <a:schemeClr val="lt1"/>
                 </a:solidFill>
@@ -3701,7 +3726,7 @@
                 <a:spcPts val="0"/>
               </a:spcAft>
               <a:buNone/>
-              <a:defRPr lang="ja-JP">
+              <a:defRPr lang="ja-JP" sz="1400" b="1" altLang="en-US">
                 <a:latin typeface="Noto Sans"/>
                 <a:ea typeface="Noto Sans CJK JP"/>
                 <a:cs typeface="Noto Sans"/>
@@ -3715,7 +3740,7 @@
                 <a:spcPts val="0"/>
               </a:spcAft>
               <a:buNone/>
-              <a:defRPr lang="ja-JP">
+              <a:defRPr lang="ja-JP" sz="1400" b="1" altLang="en-US">
                 <a:latin typeface="Noto Sans"/>
                 <a:ea typeface="Noto Sans CJK JP"/>
                 <a:cs typeface="Noto Sans"/>
@@ -3729,7 +3754,7 @@
                 <a:spcPts val="0"/>
               </a:spcAft>
               <a:buNone/>
-              <a:defRPr lang="ja-JP">
+              <a:defRPr lang="ja-JP" sz="1400" b="1" altLang="en-US">
                 <a:latin typeface="Noto Sans"/>
                 <a:ea typeface="Noto Sans CJK JP"/>
                 <a:cs typeface="Noto Sans"/>
@@ -3743,7 +3768,7 @@
                 <a:spcPts val="0"/>
               </a:spcAft>
               <a:buNone/>
-              <a:defRPr lang="ja-JP">
+              <a:defRPr lang="ja-JP" sz="1400" b="1" altLang="en-US">
                 <a:latin typeface="Noto Sans"/>
                 <a:ea typeface="Noto Sans CJK JP"/>
                 <a:cs typeface="Noto Sans"/>
@@ -3757,7 +3782,7 @@
                 <a:spcPts val="0"/>
               </a:spcAft>
               <a:buNone/>
-              <a:defRPr lang="ja-JP">
+              <a:defRPr lang="ja-JP" sz="1400" b="1" altLang="en-US">
                 <a:latin typeface="Noto Sans"/>
                 <a:ea typeface="Noto Sans CJK JP"/>
                 <a:cs typeface="Noto Sans"/>
@@ -3771,7 +3796,7 @@
                 <a:spcPts val="0"/>
               </a:spcAft>
               <a:buNone/>
-              <a:defRPr lang="ja-JP">
+              <a:defRPr lang="ja-JP" sz="1400" b="1" altLang="en-US">
                 <a:latin typeface="Noto Sans"/>
                 <a:ea typeface="Noto Sans CJK JP"/>
                 <a:cs typeface="Noto Sans"/>
@@ -3785,7 +3810,7 @@
                 <a:spcPts val="0"/>
               </a:spcAft>
               <a:buNone/>
-              <a:defRPr lang="ja-JP">
+              <a:defRPr lang="ja-JP" sz="1400" b="1" altLang="en-US">
                 <a:latin typeface="Noto Sans"/>
                 <a:ea typeface="Noto Sans CJK JP"/>
                 <a:cs typeface="Noto Sans"/>
@@ -3799,7 +3824,7 @@
                 <a:spcPts val="0"/>
               </a:spcAft>
               <a:buNone/>
-              <a:defRPr lang="ja-JP">
+              <a:defRPr lang="ja-JP" sz="1400" b="1" altLang="en-US">
                 <a:latin typeface="Noto Sans"/>
                 <a:ea typeface="Noto Sans CJK JP"/>
                 <a:cs typeface="Noto Sans"/>
@@ -3817,8 +3842,13 @@
               <a:spcAft>
                 <a:spcPts val="0"/>
               </a:spcAft>
+              <a:defRPr sz="1400" b="1" lang="ja-JP" altLang="en-US">
+                <a:latin typeface="Noto Sans"/>
+                <a:ea typeface="Noto Sans CJK JP"/>
+                <a:cs typeface="Noto Sans"/>
+              </a:defRPr>
             </a:pPr>
-            <a:endParaRPr dirty="0" lang="ja-JP">
+            <a:endParaRPr dirty="0" lang="ja-JP" sz="1400" b="1" altLang="en-US">
               <a:latin typeface="Noto Sans"/>
               <a:ea typeface="Noto Sans CJK JP"/>
               <a:cs typeface="Noto Sans"/>
@@ -4221,7 +4251,7 @@
                 <a:schemeClr val="lt1"/>
               </a:buClr>
               <a:buNone/>
-              <a:defRPr sz="1400" b="1" lang="ja-JP">
+              <a:defRPr sz="1400" b="1" lang="ja-JP" altLang="en-US">
                 <a:solidFill>
                   <a:schemeClr val="lt1"/>
                 </a:solidFill>
@@ -4238,7 +4268,7 @@
                 <a:spcPts val="0"/>
               </a:spcAft>
               <a:buNone/>
-              <a:defRPr lang="ja-JP">
+              <a:defRPr lang="ja-JP" sz="1400" b="1" altLang="en-US">
                 <a:latin typeface="Noto Sans"/>
                 <a:ea typeface="Noto Sans CJK JP"/>
                 <a:cs typeface="Noto Sans"/>
@@ -4252,7 +4282,7 @@
                 <a:spcPts val="0"/>
               </a:spcAft>
               <a:buNone/>
-              <a:defRPr lang="ja-JP">
+              <a:defRPr lang="ja-JP" sz="1400" b="1" altLang="en-US">
                 <a:latin typeface="Noto Sans"/>
                 <a:ea typeface="Noto Sans CJK JP"/>
                 <a:cs typeface="Noto Sans"/>
@@ -4266,7 +4296,7 @@
                 <a:spcPts val="0"/>
               </a:spcAft>
               <a:buNone/>
-              <a:defRPr lang="ja-JP">
+              <a:defRPr lang="ja-JP" sz="1400" b="1" altLang="en-US">
                 <a:latin typeface="Noto Sans"/>
                 <a:ea typeface="Noto Sans CJK JP"/>
                 <a:cs typeface="Noto Sans"/>
@@ -4280,7 +4310,7 @@
                 <a:spcPts val="0"/>
               </a:spcAft>
               <a:buNone/>
-              <a:defRPr lang="ja-JP">
+              <a:defRPr lang="ja-JP" sz="1400" b="1" altLang="en-US">
                 <a:latin typeface="Noto Sans"/>
                 <a:ea typeface="Noto Sans CJK JP"/>
                 <a:cs typeface="Noto Sans"/>
@@ -4294,7 +4324,7 @@
                 <a:spcPts val="0"/>
               </a:spcAft>
               <a:buNone/>
-              <a:defRPr lang="ja-JP">
+              <a:defRPr lang="ja-JP" sz="1400" b="1" altLang="en-US">
                 <a:latin typeface="Noto Sans"/>
                 <a:ea typeface="Noto Sans CJK JP"/>
                 <a:cs typeface="Noto Sans"/>
@@ -4308,7 +4338,7 @@
                 <a:spcPts val="0"/>
               </a:spcAft>
               <a:buNone/>
-              <a:defRPr lang="ja-JP">
+              <a:defRPr lang="ja-JP" sz="1400" b="1" altLang="en-US">
                 <a:latin typeface="Noto Sans"/>
                 <a:ea typeface="Noto Sans CJK JP"/>
                 <a:cs typeface="Noto Sans"/>
@@ -4322,7 +4352,7 @@
                 <a:spcPts val="0"/>
               </a:spcAft>
               <a:buNone/>
-              <a:defRPr lang="ja-JP">
+              <a:defRPr lang="ja-JP" sz="1400" b="1" altLang="en-US">
                 <a:latin typeface="Noto Sans"/>
                 <a:ea typeface="Noto Sans CJK JP"/>
                 <a:cs typeface="Noto Sans"/>
@@ -4336,7 +4366,7 @@
                 <a:spcPts val="0"/>
               </a:spcAft>
               <a:buNone/>
-              <a:defRPr lang="ja-JP">
+              <a:defRPr lang="ja-JP" sz="1400" b="1" altLang="en-US">
                 <a:latin typeface="Noto Sans"/>
                 <a:ea typeface="Noto Sans CJK JP"/>
                 <a:cs typeface="Noto Sans"/>
@@ -4354,8 +4384,13 @@
               <a:spcAft>
                 <a:spcPts val="0"/>
               </a:spcAft>
+              <a:defRPr sz="1400" b="1" lang="ja-JP" altLang="en-US">
+                <a:latin typeface="Noto Sans"/>
+                <a:ea typeface="Noto Sans CJK JP"/>
+                <a:cs typeface="Noto Sans"/>
+              </a:defRPr>
             </a:pPr>
-            <a:endParaRPr dirty="0" lang="ja-JP">
+            <a:endParaRPr dirty="0" lang="ja-JP" sz="1400" b="1" altLang="en-US">
               <a:latin typeface="Noto Sans"/>
               <a:ea typeface="Noto Sans CJK JP"/>
               <a:cs typeface="Noto Sans"/>
@@ -4526,7 +4561,7 @@
                 <a:schemeClr val="lt1"/>
               </a:buClr>
               <a:buNone/>
-              <a:defRPr sz="1400" b="1" lang="ja-JP">
+              <a:defRPr sz="1400" b="1" lang="ja-JP" altLang="en-US">
                 <a:solidFill>
                   <a:schemeClr val="lt1"/>
                 </a:solidFill>
@@ -4543,7 +4578,7 @@
                 <a:spcPts val="0"/>
               </a:spcAft>
               <a:buNone/>
-              <a:defRPr lang="ja-JP">
+              <a:defRPr lang="ja-JP" sz="1400" b="1" altLang="en-US">
                 <a:latin typeface="Noto Sans"/>
                 <a:ea typeface="Noto Sans CJK JP"/>
                 <a:cs typeface="Noto Sans"/>
@@ -4557,7 +4592,7 @@
                 <a:spcPts val="0"/>
               </a:spcAft>
               <a:buNone/>
-              <a:defRPr lang="ja-JP">
+              <a:defRPr lang="ja-JP" sz="1400" b="1" altLang="en-US">
                 <a:latin typeface="Noto Sans"/>
                 <a:ea typeface="Noto Sans CJK JP"/>
                 <a:cs typeface="Noto Sans"/>
@@ -4571,7 +4606,7 @@
                 <a:spcPts val="0"/>
               </a:spcAft>
               <a:buNone/>
-              <a:defRPr lang="ja-JP">
+              <a:defRPr lang="ja-JP" sz="1400" b="1" altLang="en-US">
                 <a:latin typeface="Noto Sans"/>
                 <a:ea typeface="Noto Sans CJK JP"/>
                 <a:cs typeface="Noto Sans"/>
@@ -4585,7 +4620,7 @@
                 <a:spcPts val="0"/>
               </a:spcAft>
               <a:buNone/>
-              <a:defRPr lang="ja-JP">
+              <a:defRPr lang="ja-JP" sz="1400" b="1" altLang="en-US">
                 <a:latin typeface="Noto Sans"/>
                 <a:ea typeface="Noto Sans CJK JP"/>
                 <a:cs typeface="Noto Sans"/>
@@ -4599,7 +4634,7 @@
                 <a:spcPts val="0"/>
               </a:spcAft>
               <a:buNone/>
-              <a:defRPr lang="ja-JP">
+              <a:defRPr lang="ja-JP" sz="1400" b="1" altLang="en-US">
                 <a:latin typeface="Noto Sans"/>
                 <a:ea typeface="Noto Sans CJK JP"/>
                 <a:cs typeface="Noto Sans"/>
@@ -4613,7 +4648,7 @@
                 <a:spcPts val="0"/>
               </a:spcAft>
               <a:buNone/>
-              <a:defRPr lang="ja-JP">
+              <a:defRPr lang="ja-JP" sz="1400" b="1" altLang="en-US">
                 <a:latin typeface="Noto Sans"/>
                 <a:ea typeface="Noto Sans CJK JP"/>
                 <a:cs typeface="Noto Sans"/>
@@ -4627,7 +4662,7 @@
                 <a:spcPts val="0"/>
               </a:spcAft>
               <a:buNone/>
-              <a:defRPr lang="ja-JP">
+              <a:defRPr lang="ja-JP" sz="1400" b="1" altLang="en-US">
                 <a:latin typeface="Noto Sans"/>
                 <a:ea typeface="Noto Sans CJK JP"/>
                 <a:cs typeface="Noto Sans"/>
@@ -4641,7 +4676,7 @@
                 <a:spcPts val="0"/>
               </a:spcAft>
               <a:buNone/>
-              <a:defRPr lang="ja-JP">
+              <a:defRPr lang="ja-JP" sz="1400" b="1" altLang="en-US">
                 <a:latin typeface="Noto Sans"/>
                 <a:ea typeface="Noto Sans CJK JP"/>
                 <a:cs typeface="Noto Sans"/>
@@ -4659,8 +4694,13 @@
               <a:spcAft>
                 <a:spcPts val="0"/>
               </a:spcAft>
+              <a:defRPr sz="1400" b="1" lang="ja-JP" altLang="en-US">
+                <a:latin typeface="Noto Sans"/>
+                <a:ea typeface="Noto Sans CJK JP"/>
+                <a:cs typeface="Noto Sans"/>
+              </a:defRPr>
             </a:pPr>
-            <a:endParaRPr dirty="0" lang="ja-JP">
+            <a:endParaRPr dirty="0" lang="ja-JP" sz="1400" b="1" altLang="en-US">
               <a:latin typeface="Noto Sans"/>
               <a:ea typeface="Noto Sans CJK JP"/>
               <a:cs typeface="Noto Sans"/>
@@ -7436,8 +7476,13 @@
               <a:spcAft>
                 <a:spcPts val="0"/>
               </a:spcAft>
+              <a:defRPr sz="1400" b="1" lang="ja-JP" altLang="en-US">
+                <a:latin typeface="Noto Sans"/>
+                <a:ea typeface="Noto Sans CJK JP"/>
+                <a:cs typeface="Noto Sans"/>
+              </a:defRPr>
             </a:pPr>
-            <a:endParaRPr lang="ja-JP" dirty="0">
+            <a:endParaRPr lang="ja-JP" dirty="0" sz="1400" b="1" altLang="en-US">
               <a:latin typeface="Noto Sans"/>
               <a:ea typeface="Noto Sans CJK JP"/>
               <a:cs typeface="Noto Sans"/>
@@ -7526,8 +7571,13 @@
               <a:spcAft>
                 <a:spcPts val="0"/>
               </a:spcAft>
+              <a:defRPr sz="1400" b="1" lang="ja-JP" altLang="en-US">
+                <a:latin typeface="Noto Sans"/>
+                <a:ea typeface="Noto Sans CJK JP"/>
+                <a:cs typeface="Noto Sans"/>
+              </a:defRPr>
             </a:pPr>
-            <a:endParaRPr lang="ja-JP" dirty="0">
+            <a:endParaRPr lang="ja-JP" dirty="0" sz="1400" b="1" altLang="en-US">
               <a:latin typeface="Noto Sans"/>
               <a:ea typeface="Noto Sans CJK JP"/>
               <a:cs typeface="Noto Sans"/>
@@ -7577,8 +7627,14 @@
           </a:bodyPr>
           <a:lstStyle/>
           <a:p>
-            <a:pPr/>
-            <a:endParaRPr lang="ja-JP" dirty="0">
+            <a:pPr>
+              <a:defRPr sz="3600" b="1" lang="ja-JP" altLang="en-US">
+                <a:latin typeface="Noto Sans"/>
+                <a:ea typeface="Noto Sans CJK JP"/>
+                <a:cs typeface="Noto Sans"/>
+              </a:defRPr>
+            </a:pPr>
+            <a:endParaRPr lang="ja-JP" dirty="0" sz="3600" b="1" altLang="en-US">
               <a:latin typeface="Noto Sans"/>
               <a:ea typeface="Noto Sans CJK JP"/>
               <a:cs typeface="Noto Sans"/>
@@ -7616,8 +7672,13 @@
               <a:spcAft>
                 <a:spcPts val="0"/>
               </a:spcAft>
+              <a:defRPr sz="1400" b="1" lang="ja-JP" altLang="en-US">
+                <a:latin typeface="Noto Sans"/>
+                <a:ea typeface="Noto Sans CJK JP"/>
+                <a:cs typeface="Noto Sans"/>
+              </a:defRPr>
             </a:pPr>
-            <a:endParaRPr lang="ja-JP" dirty="0">
+            <a:endParaRPr lang="ja-JP" dirty="0" sz="1400" b="1" altLang="en-US">
               <a:latin typeface="Noto Sans"/>
               <a:ea typeface="Noto Sans CJK JP"/>
               <a:cs typeface="Noto Sans"/>
@@ -7704,8 +7765,13 @@
               <a:spcAft>
                 <a:spcPts val="0"/>
               </a:spcAft>
+              <a:defRPr sz="1400" b="1" lang="ja-JP" altLang="en-US">
+                <a:latin typeface="Noto Sans"/>
+                <a:ea typeface="Noto Sans CJK JP"/>
+                <a:cs typeface="Noto Sans"/>
+              </a:defRPr>
             </a:pPr>
-            <a:endParaRPr lang="ja-JP" dirty="0">
+            <a:endParaRPr lang="ja-JP" dirty="0" sz="1400" b="1" altLang="en-US">
               <a:latin typeface="Noto Sans"/>
               <a:ea typeface="Noto Sans CJK JP"/>
               <a:cs typeface="Noto Sans"/>
@@ -7768,8 +7834,13 @@
               <a:spcAft>
                 <a:spcPts val="0"/>
               </a:spcAft>
+              <a:defRPr sz="1400" b="1" lang="ja-JP" altLang="en-US">
+                <a:latin typeface="Noto Sans"/>
+                <a:ea typeface="Noto Sans CJK JP"/>
+                <a:cs typeface="Noto Sans"/>
+              </a:defRPr>
             </a:pPr>
-            <a:endParaRPr lang="ja-JP" dirty="0">
+            <a:endParaRPr lang="ja-JP" dirty="0" sz="1400" b="1" altLang="en-US">
               <a:latin typeface="Noto Sans"/>
               <a:ea typeface="Noto Sans CJK JP"/>
               <a:cs typeface="Noto Sans"/>

</xml_diff>